<commit_message>
收工：quantimmu pTuneos 进 5 工具 benchmark（Pre&RecNeo 子模型跑 ELISpot，r=1.0 复刻官方）
- 重判完成度：pTuneos 用真实 Pre&RecNeo 识别模型(model_pro)跑 ELISpot 32178 肽对，进 5 工具 benchmark
- AUC max/>0：pTuneos 0.7525(第一) > PredIG 0.6611 > NeoTImmuML 0.6551 > IMPROVE 0.6207 > DeepImmuno 0.4813；4 工具数字不变
- wrapper 批 netMHCpan/blastp + 并行 calculate_R，截断 immuno_effect 只取 model_pro；修 netMHCpan 列位[2]/blastp gap KeyError/per-row try
- merged_5tools.xlsx + 3 版 R 图(加 pTuneos) + Word 报告 + PPT 12 页(新增 benchmark 深入页 + 官方/改动透明声明 + slide3 部分完成说明)
- 文档：pTuneos.md/DEPLOY_TRACKER/04_LOG Entry 20。诚实标：pTuneos 本地 docker(HPC sif 受限)、9-11mer 覆盖、DS2 阴性仅 11

Co-Authored-By: Claude Opus 4.8 <noreply@anthropic.com>
</commit_message>
<xml_diff>
--- a/project/meeting/QuantImmuBench/QuantImmuBench_部署测试报告.pptx
+++ b/project/meeting/QuantImmuBench/QuantImmuBench_部署测试报告.pptx
@@ -4,6 +4,9 @@
   <p:sldMasterIdLst>
     <p:sldMasterId id="2147483648" r:id="rId1"/>
   </p:sldMasterIdLst>
+  <p:notesMasterIdLst>
+    <p:notesMasterId r:id="rId14"/>
+  </p:notesMasterIdLst>
   <p:sldIdLst>
     <p:sldId id="256" r:id="rId2"/>
     <p:sldId id="257" r:id="rId3"/>
@@ -16,10 +19,8 @@
     <p:sldId id="264" r:id="rId10"/>
     <p:sldId id="265" r:id="rId11"/>
     <p:sldId id="266" r:id="rId12"/>
+    <p:sldId id="267" r:id="rId13"/>
   </p:sldIdLst>
-  <p:notesMasterIdLst>
-    <p:notesMasterId r:id="rId13"/>
-  </p:notesMasterIdLst>
   <p:sldSz cx="12192000" cy="6858000"/>
   <p:notesSz cx="6858000" cy="12192000"/>
   <p:defaultTextStyle>
@@ -114,6 +115,11 @@
       </a:defRPr>
     </a:lvl9pPr>
   </p:defaultTextStyle>
+  <p:extLst>
+    <p:ext uri="{EFAFB233-063F-42B5-8137-9DF3F51BA10A}">
+      <p15:sldGuideLst xmlns:p15="http://schemas.microsoft.com/office/powerpoint/2012/main"/>
+    </p:ext>
+  </p:extLst>
 </p:presentation>
 </file>
 
@@ -139,234 +145,10 @@
           <a:chExt cx="0" cy="0"/>
         </a:xfrm>
       </p:grpSpPr>
-      <p:sp>
-        <p:nvSpPr>
-          <p:cNvPr id="2" name="Header Placeholder 1"/>
-          <p:cNvSpPr>
-            <a:spLocks noGrp="1"/>
-          </p:cNvSpPr>
-          <p:nvPr>
-            <p:ph type="hdr" sz="quarter"/>
-          </p:nvPr>
-        </p:nvSpPr>
-        <p:spPr>
-          <a:xfrm>
-            <a:off x="0" y="0"/>
-            <a:ext cx="2971800" cy="458788"/>
-          </a:xfrm>
-          <a:prstGeom prst="rect">
-            <a:avLst/>
-          </a:prstGeom>
-        </p:spPr>
-        <p:txBody>
-          <a:bodyPr vert="horz" lIns="91440" tIns="45720" rIns="91440" bIns="45720" rtlCol="0"/>
-          <a:lstStyle>
-            <a:lvl1pPr algn="l">
-              <a:defRPr sz="1200"/>
-            </a:lvl1pPr>
-          </a:lstStyle>
-          <a:p>
-            <a:endParaRPr lang="en-US"/>
-          </a:p>
-        </p:txBody>
-      </p:sp>
-      <p:sp>
-        <p:nvSpPr>
-          <p:cNvPr id="3" name="Date Placeholder 2"/>
-          <p:cNvSpPr>
-            <a:spLocks noGrp="1"/>
-          </p:cNvSpPr>
-          <p:nvPr>
-            <p:ph type="dt" idx="1"/>
-          </p:nvPr>
-        </p:nvSpPr>
-        <p:spPr>
-          <a:xfrm>
-            <a:off x="3884613" y="0"/>
-            <a:ext cx="2971800" cy="458788"/>
-          </a:xfrm>
-          <a:prstGeom prst="rect">
-            <a:avLst/>
-          </a:prstGeom>
-        </p:spPr>
-        <p:txBody>
-          <a:bodyPr vert="horz" lIns="91440" tIns="45720" rIns="91440" bIns="45720" rtlCol="0"/>
-          <a:lstStyle>
-            <a:lvl1pPr algn="r">
-              <a:defRPr sz="1200"/>
-            </a:lvl1pPr>
-          </a:lstStyle>
-          <a:p>
-            <a:fld id="{5282F153-3F37-0F45-9E97-73ACFA13230C}" type="datetimeFigureOut">
-              <a:rPr lang="en-US"/>
-              <a:t>7/23/19</a:t>
-            </a:fld>
-            <a:endParaRPr lang="en-US"/>
-          </a:p>
-        </p:txBody>
-      </p:sp>
-      <p:sp>
-        <p:nvSpPr>
-          <p:cNvPr id="4" name="Slide Image Placeholder 3"/>
-          <p:cNvSpPr>
-            <a:spLocks noGrp="1" noRot="1" noChangeAspect="1"/>
-          </p:cNvSpPr>
-          <p:nvPr>
-            <p:ph type="sldImg" idx="2"/>
-          </p:nvPr>
-        </p:nvSpPr>
-        <p:spPr>
-          <a:xfrm>
-            <a:off x="685800" y="1143000"/>
-            <a:ext cx="5486400" cy="3086100"/>
-          </a:xfrm>
-          <a:prstGeom prst="rect">
-            <a:avLst/>
-          </a:prstGeom>
-          <a:noFill/>
-          <a:ln w="12700">
-            <a:solidFill>
-              <a:prstClr val="black"/>
-            </a:solidFill>
-          </a:ln>
-        </p:spPr>
-        <p:txBody>
-          <a:bodyPr vert="horz" lIns="91440" tIns="45720" rIns="91440" bIns="45720" rtlCol="0" anchor="ctr"/>
-          <a:lstStyle/>
-          <a:p>
-            <a:endParaRPr lang="en-US"/>
-          </a:p>
-        </p:txBody>
-      </p:sp>
-      <p:sp>
-        <p:nvSpPr>
-          <p:cNvPr id="5" name="Notes Placeholder 4"/>
-          <p:cNvSpPr>
-            <a:spLocks noGrp="1"/>
-          </p:cNvSpPr>
-          <p:nvPr>
-            <p:ph type="body" sz="quarter" idx="3"/>
-          </p:nvPr>
-        </p:nvSpPr>
-        <p:spPr>
-          <a:xfrm>
-            <a:off x="685800" y="4400550"/>
-            <a:ext cx="5486400" cy="3600450"/>
-          </a:xfrm>
-          <a:prstGeom prst="rect">
-            <a:avLst/>
-          </a:prstGeom>
-        </p:spPr>
-        <p:txBody>
-          <a:bodyPr vert="horz" lIns="91440" tIns="45720" rIns="91440" bIns="45720" rtlCol="0"/>
-          <a:lstStyle/>
-          <a:p>
-            <a:pPr lvl="0"/>
-            <a:r>
-              <a:rPr lang="en-US"/>
-              <a:t>Click to edit Master text styles</a:t>
-            </a:r>
-          </a:p>
-          <a:p>
-            <a:pPr lvl="1"/>
-            <a:r>
-              <a:rPr lang="en-US"/>
-              <a:t>Second level</a:t>
-            </a:r>
-          </a:p>
-          <a:p>
-            <a:pPr lvl="2"/>
-            <a:r>
-              <a:rPr lang="en-US"/>
-              <a:t>Third level</a:t>
-            </a:r>
-          </a:p>
-          <a:p>
-            <a:pPr lvl="3"/>
-            <a:r>
-              <a:rPr lang="en-US"/>
-              <a:t>Fourth level</a:t>
-            </a:r>
-          </a:p>
-          <a:p>
-            <a:pPr lvl="4"/>
-            <a:r>
-              <a:rPr lang="en-US"/>
-              <a:t>Fifth level</a:t>
-            </a:r>
-          </a:p>
-        </p:txBody>
-      </p:sp>
-      <p:sp>
-        <p:nvSpPr>
-          <p:cNvPr id="6" name="Footer Placeholder 5"/>
-          <p:cNvSpPr>
-            <a:spLocks noGrp="1"/>
-          </p:cNvSpPr>
-          <p:nvPr>
-            <p:ph type="ftr" sz="quarter" idx="4"/>
-          </p:nvPr>
-        </p:nvSpPr>
-        <p:spPr>
-          <a:xfrm>
-            <a:off x="0" y="8685213"/>
-            <a:ext cx="2971800" cy="458787"/>
-          </a:xfrm>
-          <a:prstGeom prst="rect">
-            <a:avLst/>
-          </a:prstGeom>
-        </p:spPr>
-        <p:txBody>
-          <a:bodyPr vert="horz" lIns="91440" tIns="45720" rIns="91440" bIns="45720" rtlCol="0" anchor="b"/>
-          <a:lstStyle>
-            <a:lvl1pPr algn="l">
-              <a:defRPr sz="1200"/>
-            </a:lvl1pPr>
-          </a:lstStyle>
-          <a:p>
-            <a:endParaRPr lang="en-US"/>
-          </a:p>
-        </p:txBody>
-      </p:sp>
-      <p:sp>
-        <p:nvSpPr>
-          <p:cNvPr id="7" name="Slide Number Placeholder 6"/>
-          <p:cNvSpPr>
-            <a:spLocks noGrp="1"/>
-          </p:cNvSpPr>
-          <p:nvPr>
-            <p:ph type="sldNum" sz="quarter" idx="5"/>
-          </p:nvPr>
-        </p:nvSpPr>
-        <p:spPr>
-          <a:xfrm>
-            <a:off x="3884613" y="8685213"/>
-            <a:ext cx="2971800" cy="458787"/>
-          </a:xfrm>
-          <a:prstGeom prst="rect">
-            <a:avLst/>
-          </a:prstGeom>
-        </p:spPr>
-        <p:txBody>
-          <a:bodyPr vert="horz" lIns="91440" tIns="45720" rIns="91440" bIns="45720" rtlCol="0" anchor="b"/>
-          <a:lstStyle>
-            <a:lvl1pPr algn="r">
-              <a:defRPr sz="1200"/>
-            </a:lvl1pPr>
-          </a:lstStyle>
-          <a:p>
-            <a:fld id="{CE5E9CC1-C706-0F49-92D6-E571CC5EEA8F}" type="slidenum">
-              <a:rPr lang="en-US"/>
-              <a:t>‹#›</a:t>
-            </a:fld>
-            <a:endParaRPr lang="en-US"/>
-          </a:p>
-        </p:txBody>
-      </p:sp>
     </p:spTree>
     <p:extLst>
       <p:ext uri="{BB962C8B-B14F-4D97-AF65-F5344CB8AC3E}">
-        <p14:creationId xmlns:p14="http://schemas.microsoft.com/office/powerpoint/2010/main" val="1024086991"/>
+        <p14:creationId xmlns:p14="http://schemas.microsoft.com/office/powerpoint/2010/main" val="2768288389"/>
       </p:ext>
     </p:extLst>
   </p:cSld>
@@ -510,10 +292,6 @@
           <a:bodyPr/>
           <a:lstStyle/>
           <a:p>
-            <a:r>
-              <a:rPr lang="en-US" dirty="0"/>
-              <a:t/>
-            </a:r>
             <a:endParaRPr lang="en-US" dirty="0"/>
           </a:p>
         </p:txBody>
@@ -598,10 +376,6 @@
           <a:bodyPr/>
           <a:lstStyle/>
           <a:p>
-            <a:r>
-              <a:rPr lang="en-US" dirty="0"/>
-              <a:t/>
-            </a:r>
             <a:endParaRPr lang="en-US" dirty="0"/>
           </a:p>
         </p:txBody>
@@ -686,10 +460,6 @@
           <a:bodyPr/>
           <a:lstStyle/>
           <a:p>
-            <a:r>
-              <a:rPr lang="en-US" dirty="0"/>
-              <a:t/>
-            </a:r>
             <a:endParaRPr lang="en-US" dirty="0"/>
           </a:p>
         </p:txBody>
@@ -712,6 +482,90 @@
             <a:fld id="{F7021451-1387-4CA6-816F-3879F97B5CBC}" type="slidenum">
               <a:rPr lang="en-US"/>
               <a:t>11</a:t>
+            </a:fld>
+            <a:endParaRPr lang="en-US"/>
+          </a:p>
+        </p:txBody>
+      </p:sp>
+    </p:spTree>
+    <p:extLst>
+      <p:ext uri="{BB962C8B-B14F-4D97-AF65-F5344CB8AC3E}">
+        <p14:creationId xmlns:p14="http://schemas.microsoft.com/office/powerpoint/2010/main" val="1024086991"/>
+      </p:ext>
+    </p:extLst>
+  </p:cSld>
+  <p:clrMapOvr>
+    <a:masterClrMapping/>
+  </p:clrMapOvr>
+</p:notes>
+</file>
+
+<file path=ppt/notesSlides/notesSlide12.xml><?xml version="1.0" encoding="utf-8"?>
+<p:notes xmlns:a="http://schemas.openxmlformats.org/drawingml/2006/main" xmlns:r="http://schemas.openxmlformats.org/officeDocument/2006/relationships" xmlns:p="http://schemas.openxmlformats.org/presentationml/2006/main">
+  <p:cSld>
+    <p:spTree>
+      <p:nvGrpSpPr>
+        <p:cNvPr id="1" name=""/>
+        <p:cNvGrpSpPr/>
+        <p:nvPr/>
+      </p:nvGrpSpPr>
+      <p:grpSpPr>
+        <a:xfrm>
+          <a:off x="0" y="0"/>
+          <a:ext cx="0" cy="0"/>
+          <a:chOff x="0" y="0"/>
+          <a:chExt cx="0" cy="0"/>
+        </a:xfrm>
+      </p:grpSpPr>
+      <p:sp>
+        <p:nvSpPr>
+          <p:cNvPr id="2" name="Slide Image Placeholder 1"/>
+          <p:cNvSpPr>
+            <a:spLocks noGrp="1" noRot="1" noChangeAspect="1"/>
+          </p:cNvSpPr>
+          <p:nvPr>
+            <p:ph type="sldImg"/>
+          </p:nvPr>
+        </p:nvSpPr>
+        <p:spPr/>
+      </p:sp>
+      <p:sp>
+        <p:nvSpPr>
+          <p:cNvPr id="3" name="Notes Placeholder 2"/>
+          <p:cNvSpPr>
+            <a:spLocks noGrp="1"/>
+          </p:cNvSpPr>
+          <p:nvPr>
+            <p:ph type="body" idx="1"/>
+          </p:nvPr>
+        </p:nvSpPr>
+        <p:spPr/>
+        <p:txBody>
+          <a:bodyPr/>
+          <a:lstStyle/>
+          <a:p>
+            <a:endParaRPr lang="en-US" dirty="0"/>
+          </a:p>
+        </p:txBody>
+      </p:sp>
+      <p:sp>
+        <p:nvSpPr>
+          <p:cNvPr id="4" name="Slide Number Placeholder 3"/>
+          <p:cNvSpPr>
+            <a:spLocks noGrp="1"/>
+          </p:cNvSpPr>
+          <p:nvPr>
+            <p:ph type="sldNum" sz="quarter" idx="10"/>
+          </p:nvPr>
+        </p:nvSpPr>
+        <p:spPr/>
+        <p:txBody>
+          <a:bodyPr/>
+          <a:lstStyle/>
+          <a:p>
+            <a:fld id="{F7021451-1387-4CA6-816F-3879F97B5CBC}" type="slidenum">
+              <a:rPr lang="en-US"/>
+              <a:t>12</a:t>
             </a:fld>
             <a:endParaRPr lang="en-US"/>
           </a:p>
@@ -774,10 +628,6 @@
           <a:bodyPr/>
           <a:lstStyle/>
           <a:p>
-            <a:r>
-              <a:rPr lang="en-US" dirty="0"/>
-              <a:t/>
-            </a:r>
             <a:endParaRPr lang="en-US" dirty="0"/>
           </a:p>
         </p:txBody>
@@ -862,10 +712,6 @@
           <a:bodyPr/>
           <a:lstStyle/>
           <a:p>
-            <a:r>
-              <a:rPr lang="en-US" dirty="0"/>
-              <a:t/>
-            </a:r>
             <a:endParaRPr lang="en-US" dirty="0"/>
           </a:p>
         </p:txBody>
@@ -950,10 +796,6 @@
           <a:bodyPr/>
           <a:lstStyle/>
           <a:p>
-            <a:r>
-              <a:rPr lang="en-US" dirty="0"/>
-              <a:t/>
-            </a:r>
             <a:endParaRPr lang="en-US" dirty="0"/>
           </a:p>
         </p:txBody>
@@ -1038,10 +880,6 @@
           <a:bodyPr/>
           <a:lstStyle/>
           <a:p>
-            <a:r>
-              <a:rPr lang="en-US" dirty="0"/>
-              <a:t/>
-            </a:r>
             <a:endParaRPr lang="en-US" dirty="0"/>
           </a:p>
         </p:txBody>
@@ -1126,10 +964,6 @@
           <a:bodyPr/>
           <a:lstStyle/>
           <a:p>
-            <a:r>
-              <a:rPr lang="en-US" dirty="0"/>
-              <a:t/>
-            </a:r>
             <a:endParaRPr lang="en-US" dirty="0"/>
           </a:p>
         </p:txBody>
@@ -1214,10 +1048,6 @@
           <a:bodyPr/>
           <a:lstStyle/>
           <a:p>
-            <a:r>
-              <a:rPr lang="en-US" dirty="0"/>
-              <a:t/>
-            </a:r>
             <a:endParaRPr lang="en-US" dirty="0"/>
           </a:p>
         </p:txBody>
@@ -1302,10 +1132,6 @@
           <a:bodyPr/>
           <a:lstStyle/>
           <a:p>
-            <a:r>
-              <a:rPr lang="en-US" dirty="0"/>
-              <a:t/>
-            </a:r>
             <a:endParaRPr lang="en-US" dirty="0"/>
           </a:p>
         </p:txBody>
@@ -1390,10 +1216,6 @@
           <a:bodyPr/>
           <a:lstStyle/>
           <a:p>
-            <a:r>
-              <a:rPr lang="en-US" dirty="0"/>
-              <a:t/>
-            </a:r>
             <a:endParaRPr lang="en-US" dirty="0"/>
           </a:p>
         </p:txBody>
@@ -1467,6 +1289,11 @@
 <file path=ppt/slideMasters/slideMaster1.xml><?xml version="1.0" encoding="utf-8"?>
 <p:sldMaster xmlns:a="http://schemas.openxmlformats.org/drawingml/2006/main" xmlns:r="http://schemas.openxmlformats.org/officeDocument/2006/relationships" xmlns:p="http://schemas.openxmlformats.org/presentationml/2006/main">
   <p:cSld>
+    <p:bg>
+      <p:bgRef idx="1001">
+        <a:schemeClr val="bg1"/>
+      </p:bgRef>
+    </p:bg>
     <p:spTree>
       <p:nvGrpSpPr>
         <p:cNvPr id="1" name=""/>
@@ -1749,6 +1576,7 @@
         <a:solidFill>
           <a:srgbClr val="0B3C49"/>
         </a:solidFill>
+        <a:effectLst/>
       </p:bgPr>
     </p:bg>
     <p:spTree>
@@ -1850,11 +1678,11 @@
           <a:bodyPr wrap="square" lIns="0" tIns="0" rIns="0" bIns="0" rtlCol="0" anchor="ctr"/>
           <a:lstStyle/>
           <a:p>
-            <a:pPr indent="0" marL="0">
+            <a:pPr marL="0" indent="0">
               <a:buNone/>
             </a:pPr>
             <a:r>
-              <a:rPr lang="en-US" sz="1500" b="1" spc="200" kern="0" dirty="0">
+              <a:rPr lang="en-US" sz="1500" b="1" kern="0" spc="200" dirty="0">
                 <a:solidFill>
                   <a:srgbClr val="02C39A"/>
                 </a:solidFill>
@@ -1889,7 +1717,7 @@
           <a:bodyPr wrap="square" lIns="0" tIns="0" rIns="0" bIns="0" rtlCol="0" anchor="ctr"/>
           <a:lstStyle/>
           <a:p>
-            <a:pPr indent="0" marL="0">
+            <a:pPr marL="0" indent="0">
               <a:lnSpc>
                 <a:spcPct val="105000"/>
               </a:lnSpc>
@@ -1909,7 +1737,7 @@
             <a:endParaRPr lang="en-US" sz="4600" dirty="0"/>
           </a:p>
           <a:p>
-            <a:pPr indent="0" marL="0">
+            <a:pPr marL="0" indent="0">
               <a:lnSpc>
                 <a:spcPct val="105000"/>
               </a:lnSpc>
@@ -1951,7 +1779,7 @@
           <a:bodyPr wrap="square" lIns="0" tIns="0" rIns="0" bIns="0" rtlCol="0" anchor="ctr"/>
           <a:lstStyle/>
           <a:p>
-            <a:pPr indent="0" marL="0">
+            <a:pPr marL="0" indent="0">
               <a:buNone/>
             </a:pPr>
             <a:r>
@@ -2013,7 +1841,7 @@
           <a:bodyPr wrap="square" lIns="0" tIns="0" rIns="0" bIns="0" rtlCol="0" anchor="t"/>
           <a:lstStyle/>
           <a:p>
-            <a:pPr indent="0" marL="0">
+            <a:pPr marL="0" indent="0">
               <a:buNone/>
             </a:pPr>
             <a:r>
@@ -2027,11 +1855,47 @@
               </a:rPr>
               <a:t>汇报人  </a:t>
             </a:r>
-            <a:pPr indent="0" marL="0">
+            <a:r>
+              <a:rPr lang="en-US" sz="1300" b="1" dirty="0">
+                <a:solidFill>
+                  <a:srgbClr val="FFFFFF"/>
+                </a:solidFill>
+                <a:latin typeface="Microsoft YaHei" pitchFamily="34" charset="0"/>
+                <a:ea typeface="Microsoft YaHei" pitchFamily="34" charset="-122"/>
+                <a:cs typeface="Microsoft YaHei" pitchFamily="34" charset="-120"/>
+              </a:rPr>
+              <a:t>余嘉 (legacccy)</a:t>
+            </a:r>
+            <a:endParaRPr lang="en-US" sz="1300" dirty="0"/>
+          </a:p>
+          <a:p>
+            <a:pPr marL="0" indent="0">
               <a:buNone/>
             </a:pPr>
             <a:r>
-              <a:rPr lang="en-US" sz="1300" b="1" dirty="0">
+              <a:rPr lang="en-US" sz="1300" dirty="0" err="1">
+                <a:solidFill>
+                  <a:srgbClr val="8FB7BD"/>
+                </a:solidFill>
+                <a:latin typeface="Microsoft YaHei" pitchFamily="34" charset="0"/>
+                <a:ea typeface="Microsoft YaHei" pitchFamily="34" charset="-122"/>
+                <a:cs typeface="Microsoft YaHei" pitchFamily="34" charset="-120"/>
+              </a:rPr>
+              <a:t>协作项目</a:t>
+            </a:r>
+            <a:r>
+              <a:rPr lang="en-US" sz="1300" dirty="0">
+                <a:solidFill>
+                  <a:srgbClr val="8FB7BD"/>
+                </a:solidFill>
+                <a:latin typeface="Microsoft YaHei" pitchFamily="34" charset="0"/>
+                <a:ea typeface="Microsoft YaHei" pitchFamily="34" charset="-122"/>
+                <a:cs typeface="Microsoft YaHei" pitchFamily="34" charset="-120"/>
+              </a:rPr>
+              <a:t>  </a:t>
+            </a:r>
+            <a:r>
+              <a:rPr lang="en-US" sz="1300" dirty="0" err="1">
                 <a:solidFill>
                   <a:srgbClr val="FFFFFF"/>
                 </a:solidFill>
@@ -2039,38 +1903,18 @@
                 <a:ea typeface="Microsoft YaHei" pitchFamily="34" charset="-122"/>
                 <a:cs typeface="Microsoft YaHei" pitchFamily="34" charset="-120"/>
               </a:rPr>
-              <a:t>余嘉 (legacccy)</a:t>
-            </a:r>
-            <a:endParaRPr lang="en-US" sz="1300" dirty="0"/>
-          </a:p>
-          <a:p>
-            <a:pPr indent="0" marL="0">
-              <a:buNone/>
-            </a:pPr>
+              <a:t>课题组</a:t>
+            </a:r>
             <a:r>
               <a:rPr lang="en-US" sz="1300" dirty="0">
                 <a:solidFill>
-                  <a:srgbClr val="8FB7BD"/>
-                </a:solidFill>
-                <a:latin typeface="Microsoft YaHei" pitchFamily="34" charset="0"/>
-                <a:ea typeface="Microsoft YaHei" pitchFamily="34" charset="-122"/>
-                <a:cs typeface="Microsoft YaHei" pitchFamily="34" charset="-120"/>
-              </a:rPr>
-              <a:t>协作项目  </a:t>
-            </a:r>
-            <a:pPr indent="0" marL="0">
-              <a:buNone/>
-            </a:pPr>
-            <a:r>
-              <a:rPr lang="en-US" sz="1300" dirty="0">
-                <a:solidFill>
                   <a:srgbClr val="FFFFFF"/>
                 </a:solidFill>
                 <a:latin typeface="Microsoft YaHei" pitchFamily="34" charset="0"/>
                 <a:ea typeface="Microsoft YaHei" pitchFamily="34" charset="-122"/>
                 <a:cs typeface="Microsoft YaHei" pitchFamily="34" charset="-120"/>
               </a:rPr>
-              <a:t>袁老师课题组 · 西交利物浦大学</a:t>
+              <a:t> · 西交利物浦大学</a:t>
             </a:r>
             <a:endParaRPr lang="en-US" sz="1300" dirty="0"/>
           </a:p>
@@ -2097,7 +1941,7 @@
           <a:bodyPr wrap="square" lIns="0" tIns="0" rIns="0" bIns="0" rtlCol="0" anchor="ctr"/>
           <a:lstStyle/>
           <a:p>
-            <a:pPr algn="r" indent="0" marL="0">
+            <a:pPr marL="0" indent="0" algn="r">
               <a:buNone/>
             </a:pPr>
             <a:r>
@@ -2131,6 +1975,7 @@
         <a:solidFill>
           <a:srgbClr val="F2F7F7"/>
         </a:solidFill>
+        <a:effectLst/>
       </p:bgPr>
     </p:bg>
     <p:spTree>
@@ -2188,11 +2033,11 @@
           <a:bodyPr wrap="square" lIns="0" tIns="0" rIns="0" bIns="0" rtlCol="0" anchor="ctr"/>
           <a:lstStyle/>
           <a:p>
-            <a:pPr indent="0" marL="0">
+            <a:pPr marL="0" indent="0">
               <a:buNone/>
             </a:pPr>
             <a:r>
-              <a:rPr lang="en-US" sz="1200" b="1" spc="300" kern="0" dirty="0">
+              <a:rPr lang="en-US" sz="1200" b="1" kern="0" spc="300" dirty="0">
                 <a:solidFill>
                   <a:srgbClr val="028090"/>
                 </a:solidFill>
@@ -2227,7 +2072,7 @@
           <a:bodyPr wrap="square" lIns="0" tIns="0" rIns="0" bIns="0" rtlCol="0" anchor="ctr"/>
           <a:lstStyle/>
           <a:p>
-            <a:pPr indent="0" marL="0">
+            <a:pPr marL="0" indent="0">
               <a:buNone/>
             </a:pPr>
             <a:r>
@@ -2239,7 +2084,7 @@
                 <a:ea typeface="Microsoft YaHei" pitchFamily="34" charset="-122"/>
                 <a:cs typeface="Microsoft YaHei" pitchFamily="34" charset="-120"/>
               </a:rPr>
-              <a:t>用袁老师 ELISpot 真实数据跑通</a:t>
+              <a:t>ELISpot 真实数据跑通</a:t>
             </a:r>
             <a:endParaRPr lang="en-US" sz="3000" dirty="0"/>
           </a:p>
@@ -2266,7 +2111,7 @@
           <a:bodyPr wrap="square" lIns="0" tIns="0" rIns="0" bIns="0" rtlCol="0" anchor="t"/>
           <a:lstStyle/>
           <a:p>
-            <a:pPr indent="0" marL="0">
+            <a:pPr marL="0" indent="0">
               <a:lnSpc>
                 <a:spcPct val="110000"/>
               </a:lnSpc>
@@ -2287,7 +2132,7 @@
             <a:endParaRPr lang="en-US" sz="1400" dirty="0"/>
           </a:p>
           <a:p>
-            <a:pPr indent="0" marL="0">
+            <a:pPr marL="0" indent="0">
               <a:lnSpc>
                 <a:spcPct val="110000"/>
               </a:lnSpc>
@@ -2316,8 +2161,8 @@
         </p:nvSpPr>
         <p:spPr>
           <a:xfrm>
-            <a:off x="640080" y="3063240"/>
-            <a:ext cx="4937760" cy="603504"/>
+            <a:off x="640080" y="2907792"/>
+            <a:ext cx="4937760" cy="512064"/>
           </a:xfrm>
           <a:prstGeom prst="rect">
             <a:avLst/>
@@ -2341,8 +2186,8 @@
         </p:nvSpPr>
         <p:spPr>
           <a:xfrm>
-            <a:off x="640080" y="3063240"/>
-            <a:ext cx="73152" cy="603504"/>
+            <a:off x="640080" y="2907792"/>
+            <a:ext cx="73152" cy="512064"/>
           </a:xfrm>
           <a:prstGeom prst="rect">
             <a:avLst/>
@@ -2361,8 +2206,8 @@
         </p:nvSpPr>
         <p:spPr>
           <a:xfrm>
-            <a:off x="914400" y="3063240"/>
-            <a:ext cx="2743200" cy="603504"/>
+            <a:off x="914400" y="2907792"/>
+            <a:ext cx="2743200" cy="512064"/>
           </a:xfrm>
           <a:prstGeom prst="rect">
             <a:avLst/>
@@ -2374,11 +2219,11 @@
           <a:bodyPr wrap="square" lIns="0" tIns="0" rIns="0" bIns="0" rtlCol="0" anchor="ctr"/>
           <a:lstStyle/>
           <a:p>
-            <a:pPr indent="0" marL="0">
+            <a:pPr marL="0" indent="0">
               <a:buNone/>
             </a:pPr>
             <a:r>
-              <a:rPr lang="en-US" sz="1300" b="1" dirty="0">
+              <a:rPr lang="en-US" sz="1250" b="1" dirty="0">
                 <a:solidFill>
                   <a:srgbClr val="16323A"/>
                 </a:solidFill>
@@ -2388,7 +2233,7 @@
               </a:rPr>
               <a:t>DeepImmuno</a:t>
             </a:r>
-            <a:endParaRPr lang="en-US" sz="1300" dirty="0"/>
+            <a:endParaRPr lang="en-US" sz="1250" dirty="0"/>
           </a:p>
         </p:txBody>
       </p:sp>
@@ -2400,8 +2245,8 @@
         </p:nvSpPr>
         <p:spPr>
           <a:xfrm>
-            <a:off x="3383280" y="3063240"/>
-            <a:ext cx="2011680" cy="603504"/>
+            <a:off x="3383280" y="2907792"/>
+            <a:ext cx="2011680" cy="512064"/>
           </a:xfrm>
           <a:prstGeom prst="rect">
             <a:avLst/>
@@ -2413,11 +2258,11 @@
           <a:bodyPr wrap="square" lIns="0" tIns="0" rIns="0" bIns="0" rtlCol="0" anchor="ctr"/>
           <a:lstStyle/>
           <a:p>
-            <a:pPr algn="r" indent="0" marL="0">
+            <a:pPr marL="0" indent="0" algn="r">
               <a:buNone/>
             </a:pPr>
             <a:r>
-              <a:rPr lang="en-US" sz="1300" b="1" dirty="0">
+              <a:rPr lang="en-US" sz="1250" b="1" dirty="0">
                 <a:solidFill>
                   <a:srgbClr val="028090"/>
                 </a:solidFill>
@@ -2427,7 +2272,7 @@
               </a:rPr>
               <a:t>17,103  行</a:t>
             </a:r>
-            <a:endParaRPr lang="en-US" sz="1300" dirty="0"/>
+            <a:endParaRPr lang="en-US" sz="1250" dirty="0"/>
           </a:p>
         </p:txBody>
       </p:sp>
@@ -2439,8 +2284,8 @@
         </p:nvSpPr>
         <p:spPr>
           <a:xfrm>
-            <a:off x="640080" y="3758184"/>
-            <a:ext cx="4937760" cy="603504"/>
+            <a:off x="640080" y="3511296"/>
+            <a:ext cx="4937760" cy="512064"/>
           </a:xfrm>
           <a:prstGeom prst="rect">
             <a:avLst/>
@@ -2464,8 +2309,8 @@
         </p:nvSpPr>
         <p:spPr>
           <a:xfrm>
-            <a:off x="640080" y="3758184"/>
-            <a:ext cx="73152" cy="603504"/>
+            <a:off x="640080" y="3511296"/>
+            <a:ext cx="73152" cy="512064"/>
           </a:xfrm>
           <a:prstGeom prst="rect">
             <a:avLst/>
@@ -2484,8 +2329,8 @@
         </p:nvSpPr>
         <p:spPr>
           <a:xfrm>
-            <a:off x="914400" y="3758184"/>
-            <a:ext cx="2743200" cy="603504"/>
+            <a:off x="914400" y="3511296"/>
+            <a:ext cx="2743200" cy="512064"/>
           </a:xfrm>
           <a:prstGeom prst="rect">
             <a:avLst/>
@@ -2497,11 +2342,11 @@
           <a:bodyPr wrap="square" lIns="0" tIns="0" rIns="0" bIns="0" rtlCol="0" anchor="ctr"/>
           <a:lstStyle/>
           <a:p>
-            <a:pPr indent="0" marL="0">
+            <a:pPr marL="0" indent="0">
               <a:buNone/>
             </a:pPr>
             <a:r>
-              <a:rPr lang="en-US" sz="1300" b="1" dirty="0">
+              <a:rPr lang="en-US" sz="1250" b="1" dirty="0">
                 <a:solidFill>
                   <a:srgbClr val="16323A"/>
                 </a:solidFill>
@@ -2511,7 +2356,7 @@
               </a:rPr>
               <a:t>PredIG</a:t>
             </a:r>
-            <a:endParaRPr lang="en-US" sz="1300" dirty="0"/>
+            <a:endParaRPr lang="en-US" sz="1250" dirty="0"/>
           </a:p>
         </p:txBody>
       </p:sp>
@@ -2523,8 +2368,8 @@
         </p:nvSpPr>
         <p:spPr>
           <a:xfrm>
-            <a:off x="3383280" y="3758184"/>
-            <a:ext cx="2011680" cy="603504"/>
+            <a:off x="3383280" y="3511296"/>
+            <a:ext cx="2011680" cy="512064"/>
           </a:xfrm>
           <a:prstGeom prst="rect">
             <a:avLst/>
@@ -2536,11 +2381,11 @@
           <a:bodyPr wrap="square" lIns="0" tIns="0" rIns="0" bIns="0" rtlCol="0" anchor="ctr"/>
           <a:lstStyle/>
           <a:p>
-            <a:pPr algn="r" indent="0" marL="0">
+            <a:pPr marL="0" indent="0" algn="r">
               <a:buNone/>
             </a:pPr>
             <a:r>
-              <a:rPr lang="en-US" sz="1300" b="1" dirty="0">
+              <a:rPr lang="en-US" sz="1250" b="1" dirty="0">
                 <a:solidFill>
                   <a:srgbClr val="028090"/>
                 </a:solidFill>
@@ -2550,7 +2395,7 @@
               </a:rPr>
               <a:t>68,494  行</a:t>
             </a:r>
-            <a:endParaRPr lang="en-US" sz="1300" dirty="0"/>
+            <a:endParaRPr lang="en-US" sz="1250" dirty="0"/>
           </a:p>
         </p:txBody>
       </p:sp>
@@ -2562,8 +2407,8 @@
         </p:nvSpPr>
         <p:spPr>
           <a:xfrm>
-            <a:off x="640080" y="4453128"/>
-            <a:ext cx="4937760" cy="603504"/>
+            <a:off x="640080" y="4114800"/>
+            <a:ext cx="4937760" cy="512064"/>
           </a:xfrm>
           <a:prstGeom prst="rect">
             <a:avLst/>
@@ -2587,8 +2432,8 @@
         </p:nvSpPr>
         <p:spPr>
           <a:xfrm>
-            <a:off x="640080" y="4453128"/>
-            <a:ext cx="73152" cy="603504"/>
+            <a:off x="640080" y="4114800"/>
+            <a:ext cx="73152" cy="512064"/>
           </a:xfrm>
           <a:prstGeom prst="rect">
             <a:avLst/>
@@ -2607,8 +2452,8 @@
         </p:nvSpPr>
         <p:spPr>
           <a:xfrm>
-            <a:off x="914400" y="4453128"/>
-            <a:ext cx="2743200" cy="603504"/>
+            <a:off x="914400" y="4114800"/>
+            <a:ext cx="2743200" cy="512064"/>
           </a:xfrm>
           <a:prstGeom prst="rect">
             <a:avLst/>
@@ -2620,11 +2465,11 @@
           <a:bodyPr wrap="square" lIns="0" tIns="0" rIns="0" bIns="0" rtlCol="0" anchor="ctr"/>
           <a:lstStyle/>
           <a:p>
-            <a:pPr indent="0" marL="0">
+            <a:pPr marL="0" indent="0">
               <a:buNone/>
             </a:pPr>
             <a:r>
-              <a:rPr lang="en-US" sz="1300" b="1" dirty="0">
+              <a:rPr lang="en-US" sz="1250" b="1" dirty="0">
                 <a:solidFill>
                   <a:srgbClr val="16323A"/>
                 </a:solidFill>
@@ -2634,7 +2479,7 @@
               </a:rPr>
               <a:t>IMPROVE</a:t>
             </a:r>
-            <a:endParaRPr lang="en-US" sz="1300" dirty="0"/>
+            <a:endParaRPr lang="en-US" sz="1250" dirty="0"/>
           </a:p>
         </p:txBody>
       </p:sp>
@@ -2646,8 +2491,8 @@
         </p:nvSpPr>
         <p:spPr>
           <a:xfrm>
-            <a:off x="3383280" y="4453128"/>
-            <a:ext cx="2011680" cy="603504"/>
+            <a:off x="3383280" y="4114800"/>
+            <a:ext cx="2011680" cy="512064"/>
           </a:xfrm>
           <a:prstGeom prst="rect">
             <a:avLst/>
@@ -2659,11 +2504,11 @@
           <a:bodyPr wrap="square" lIns="0" tIns="0" rIns="0" bIns="0" rtlCol="0" anchor="ctr"/>
           <a:lstStyle/>
           <a:p>
-            <a:pPr algn="r" indent="0" marL="0">
+            <a:pPr marL="0" indent="0" algn="r">
               <a:buNone/>
             </a:pPr>
             <a:r>
-              <a:rPr lang="en-US" sz="1300" b="1" dirty="0">
+              <a:rPr lang="en-US" sz="1250" b="1" dirty="0">
                 <a:solidFill>
                   <a:srgbClr val="028090"/>
                 </a:solidFill>
@@ -2673,7 +2518,7 @@
               </a:rPr>
               <a:t>26,790  行</a:t>
             </a:r>
-            <a:endParaRPr lang="en-US" sz="1300" dirty="0"/>
+            <a:endParaRPr lang="en-US" sz="1250" dirty="0"/>
           </a:p>
         </p:txBody>
       </p:sp>
@@ -2685,8 +2530,8 @@
         </p:nvSpPr>
         <p:spPr>
           <a:xfrm>
-            <a:off x="640080" y="5148072"/>
-            <a:ext cx="4937760" cy="603504"/>
+            <a:off x="640080" y="4718304"/>
+            <a:ext cx="4937760" cy="512064"/>
           </a:xfrm>
           <a:prstGeom prst="rect">
             <a:avLst/>
@@ -2710,8 +2555,8 @@
         </p:nvSpPr>
         <p:spPr>
           <a:xfrm>
-            <a:off x="640080" y="5148072"/>
-            <a:ext cx="73152" cy="603504"/>
+            <a:off x="640080" y="4718304"/>
+            <a:ext cx="73152" cy="512064"/>
           </a:xfrm>
           <a:prstGeom prst="rect">
             <a:avLst/>
@@ -2730,8 +2575,8 @@
         </p:nvSpPr>
         <p:spPr>
           <a:xfrm>
-            <a:off x="914400" y="5148072"/>
-            <a:ext cx="2743200" cy="603504"/>
+            <a:off x="914400" y="4718304"/>
+            <a:ext cx="2743200" cy="512064"/>
           </a:xfrm>
           <a:prstGeom prst="rect">
             <a:avLst/>
@@ -2743,11 +2588,11 @@
           <a:bodyPr wrap="square" lIns="0" tIns="0" rIns="0" bIns="0" rtlCol="0" anchor="ctr"/>
           <a:lstStyle/>
           <a:p>
-            <a:pPr indent="0" marL="0">
+            <a:pPr marL="0" indent="0">
               <a:buNone/>
             </a:pPr>
             <a:r>
-              <a:rPr lang="en-US" sz="1300" b="1" dirty="0">
+              <a:rPr lang="en-US" sz="1250" b="1" dirty="0">
                 <a:solidFill>
                   <a:srgbClr val="16323A"/>
                 </a:solidFill>
@@ -2757,7 +2602,7 @@
               </a:rPr>
               <a:t>NeoTImmuML</a:t>
             </a:r>
-            <a:endParaRPr lang="en-US" sz="1300" dirty="0"/>
+            <a:endParaRPr lang="en-US" sz="1250" dirty="0"/>
           </a:p>
         </p:txBody>
       </p:sp>
@@ -2769,8 +2614,8 @@
         </p:nvSpPr>
         <p:spPr>
           <a:xfrm>
-            <a:off x="3383280" y="5148072"/>
-            <a:ext cx="2011680" cy="603504"/>
+            <a:off x="3383280" y="4718304"/>
+            <a:ext cx="2011680" cy="512064"/>
           </a:xfrm>
           <a:prstGeom prst="rect">
             <a:avLst/>
@@ -2782,11 +2627,11 @@
           <a:bodyPr wrap="square" lIns="0" tIns="0" rIns="0" bIns="0" rtlCol="0" anchor="ctr"/>
           <a:lstStyle/>
           <a:p>
-            <a:pPr algn="r" indent="0" marL="0">
+            <a:pPr marL="0" indent="0" algn="r">
               <a:buNone/>
             </a:pPr>
             <a:r>
-              <a:rPr lang="en-US" sz="1300" b="1" dirty="0">
+              <a:rPr lang="en-US" sz="1250" b="1" dirty="0">
                 <a:solidFill>
                   <a:srgbClr val="028090"/>
                 </a:solidFill>
@@ -2796,13 +2641,136 @@
               </a:rPr>
               <a:t>10,536  行</a:t>
             </a:r>
-            <a:endParaRPr lang="en-US" sz="1300" dirty="0"/>
-          </a:p>
-        </p:txBody>
-      </p:sp>
-      <p:sp>
-        <p:nvSpPr>
-          <p:cNvPr id="22" name="Text 20"/>
+            <a:endParaRPr lang="en-US" sz="1250" dirty="0"/>
+          </a:p>
+        </p:txBody>
+      </p:sp>
+      <p:sp>
+        <p:nvSpPr>
+          <p:cNvPr id="22" name="Shape 20"/>
+          <p:cNvSpPr/>
+          <p:nvPr/>
+        </p:nvSpPr>
+        <p:spPr>
+          <a:xfrm>
+            <a:off x="640080" y="5321808"/>
+            <a:ext cx="4937760" cy="512064"/>
+          </a:xfrm>
+          <a:prstGeom prst="rect">
+            <a:avLst/>
+          </a:prstGeom>
+          <a:solidFill>
+            <a:srgbClr val="FFFFFF"/>
+          </a:solidFill>
+          <a:ln w="12700">
+            <a:solidFill>
+              <a:srgbClr val="D5E3E4"/>
+            </a:solidFill>
+            <a:prstDash val="solid"/>
+          </a:ln>
+        </p:spPr>
+      </p:sp>
+      <p:sp>
+        <p:nvSpPr>
+          <p:cNvPr id="23" name="Shape 21"/>
+          <p:cNvSpPr/>
+          <p:nvPr/>
+        </p:nvSpPr>
+        <p:spPr>
+          <a:xfrm>
+            <a:off x="640080" y="5321808"/>
+            <a:ext cx="73152" cy="512064"/>
+          </a:xfrm>
+          <a:prstGeom prst="rect">
+            <a:avLst/>
+          </a:prstGeom>
+          <a:solidFill>
+            <a:srgbClr val="02C39A"/>
+          </a:solidFill>
+          <a:ln/>
+        </p:spPr>
+      </p:sp>
+      <p:sp>
+        <p:nvSpPr>
+          <p:cNvPr id="24" name="Text 22"/>
+          <p:cNvSpPr/>
+          <p:nvPr/>
+        </p:nvSpPr>
+        <p:spPr>
+          <a:xfrm>
+            <a:off x="914400" y="5321808"/>
+            <a:ext cx="2743200" cy="512064"/>
+          </a:xfrm>
+          <a:prstGeom prst="rect">
+            <a:avLst/>
+          </a:prstGeom>
+          <a:noFill/>
+          <a:ln/>
+        </p:spPr>
+        <p:txBody>
+          <a:bodyPr wrap="square" lIns="0" tIns="0" rIns="0" bIns="0" rtlCol="0" anchor="ctr"/>
+          <a:lstStyle/>
+          <a:p>
+            <a:pPr marL="0" indent="0">
+              <a:buNone/>
+            </a:pPr>
+            <a:r>
+              <a:rPr lang="en-US" sz="1250" b="1" dirty="0">
+                <a:solidFill>
+                  <a:srgbClr val="16323A"/>
+                </a:solidFill>
+                <a:latin typeface="Microsoft YaHei" pitchFamily="34" charset="0"/>
+                <a:ea typeface="Microsoft YaHei" pitchFamily="34" charset="-122"/>
+                <a:cs typeface="Microsoft YaHei" pitchFamily="34" charset="-120"/>
+              </a:rPr>
+              <a:t>pTuneos</a:t>
+            </a:r>
+            <a:endParaRPr lang="en-US" sz="1250" dirty="0"/>
+          </a:p>
+        </p:txBody>
+      </p:sp>
+      <p:sp>
+        <p:nvSpPr>
+          <p:cNvPr id="25" name="Text 23"/>
+          <p:cNvSpPr/>
+          <p:nvPr/>
+        </p:nvSpPr>
+        <p:spPr>
+          <a:xfrm>
+            <a:off x="3383280" y="5321808"/>
+            <a:ext cx="2011680" cy="512064"/>
+          </a:xfrm>
+          <a:prstGeom prst="rect">
+            <a:avLst/>
+          </a:prstGeom>
+          <a:noFill/>
+          <a:ln/>
+        </p:spPr>
+        <p:txBody>
+          <a:bodyPr wrap="square" lIns="0" tIns="0" rIns="0" bIns="0" rtlCol="0" anchor="ctr"/>
+          <a:lstStyle/>
+          <a:p>
+            <a:pPr marL="0" indent="0" algn="r">
+              <a:buNone/>
+            </a:pPr>
+            <a:r>
+              <a:rPr lang="en-US" sz="1250" b="1" dirty="0">
+                <a:solidFill>
+                  <a:srgbClr val="028090"/>
+                </a:solidFill>
+                <a:latin typeface="Microsoft YaHei" pitchFamily="34" charset="0"/>
+                <a:ea typeface="Microsoft YaHei" pitchFamily="34" charset="-122"/>
+                <a:cs typeface="Microsoft YaHei" pitchFamily="34" charset="-120"/>
+              </a:rPr>
+              <a:t>34,247  行</a:t>
+            </a:r>
+            <a:endParaRPr lang="en-US" sz="1250" dirty="0"/>
+          </a:p>
+        </p:txBody>
+      </p:sp>
+      <p:sp>
+        <p:nvSpPr>
+          <p:cNvPr id="26" name="Text 24"/>
           <p:cNvSpPr/>
           <p:nvPr/>
         </p:nvSpPr>
@@ -2821,7 +2789,7 @@
           <a:bodyPr wrap="square" lIns="0" tIns="0" rIns="0" bIns="0" rtlCol="0" anchor="t"/>
           <a:lstStyle/>
           <a:p>
-            <a:pPr indent="0" marL="0">
+            <a:pPr marL="0" indent="0">
               <a:buNone/>
             </a:pPr>
             <a:r>
@@ -2833,7 +2801,7 @@
                 <a:ea typeface="Microsoft YaHei" pitchFamily="34" charset="-122"/>
                 <a:cs typeface="Microsoft YaHei" pitchFamily="34" charset="-120"/>
               </a:rPr>
-              <a:t>4 / 5 工具产出 ELISpot 真实免疫原性分数 (pTuneos 架构吃测序数据，喂不了纯肽)</a:t>
+              <a:t>5 / 5 工具产出 ELISpot 真实免疫原性分数 (pTuneos 用 Pre&amp;RecNeo 子模型跑肽段，对账官方 r=1.0)</a:t>
             </a:r>
             <a:endParaRPr lang="en-US" sz="1050" dirty="0"/>
           </a:p>
@@ -2841,7 +2809,7 @@
       </p:sp>
       <p:sp>
         <p:nvSpPr>
-          <p:cNvPr id="23" name="Shape 21"/>
+          <p:cNvPr id="27" name="Shape 25"/>
           <p:cNvSpPr/>
           <p:nvPr/>
         </p:nvSpPr>
@@ -2863,7 +2831,7 @@
             <a:prstDash val="solid"/>
           </a:ln>
           <a:effectLst>
-            <a:outerShdw sx="100000" sy="100000" kx="0" ky="0" algn="bl" rotWithShape="0" blurRad="114300" dist="38100" dir="8100000">
+            <a:outerShdw blurRad="114300" dist="38100" dir="8100000" algn="bl" rotWithShape="0">
               <a:srgbClr val="0B3C49">
                 <a:alpha val="12000"/>
               </a:srgbClr>
@@ -2873,14 +2841,14 @@
       </p:sp>
       <p:pic>
         <p:nvPicPr>
-          <p:cNvPr id="24" name="Image 0" descr="D:/YJ-Agent/project/meeting/QuantImmuBench/analysis/figures/fig1_roc_curves_ds2.png">    </p:cNvPr>
+          <p:cNvPr id="28" name="Image 0" descr="D:/YJ-Agent/project/meeting/QuantImmuBench/analysis/figures/fig1_roc_curves_ds2.png"/>
           <p:cNvPicPr>
             <a:picLocks noChangeAspect="1"/>
           </p:cNvPicPr>
           <p:nvPr/>
         </p:nvPicPr>
         <p:blipFill>
-          <a:blip r:embed="rId1"/>
+          <a:blip r:embed="rId3"/>
           <a:stretch>
             <a:fillRect/>
           </a:stretch>
@@ -2897,7 +2865,7 @@
       </p:pic>
       <p:sp>
         <p:nvSpPr>
-          <p:cNvPr id="25" name="Text 22"/>
+          <p:cNvPr id="29" name="Text 26"/>
           <p:cNvSpPr/>
           <p:nvPr/>
         </p:nvSpPr>
@@ -2916,11 +2884,11 @@
           <a:bodyPr wrap="square" lIns="0" tIns="0" rIns="0" bIns="0" rtlCol="0" anchor="ctr"/>
           <a:lstStyle/>
           <a:p>
-            <a:pPr algn="ctr" indent="0" marL="0">
+            <a:pPr marL="0" indent="0" algn="ctr">
               <a:buNone/>
             </a:pPr>
             <a:r>
-              <a:rPr lang="en-US" sz="1000" i="1" dirty="0">
+              <a:rPr lang="en-US" sz="950" i="1" dirty="0">
                 <a:solidFill>
                   <a:srgbClr val="5E7B83"/>
                 </a:solidFill>
@@ -2928,15 +2896,31 @@
                 <a:ea typeface="Microsoft YaHei" pitchFamily="34" charset="-122"/>
                 <a:cs typeface="Microsoft YaHei" pitchFamily="34" charset="-120"/>
               </a:rPr>
-              <a:t>初步 ROC (DS2)，仅工具部署演示用，非最终 benchmark 结论</a:t>
-            </a:r>
-            <a:endParaRPr lang="en-US" sz="1000" dirty="0"/>
-          </a:p>
-        </p:txBody>
-      </p:sp>
-      <p:sp>
-        <p:nvSpPr>
-          <p:cNvPr id="26" name="Text 23"/>
+              <a:t>5 工具 ROC (DS2, max 聚合, ELISpot&gt;0)；pTuneos AUC 最高 0.75。</a:t>
+            </a:r>
+          </a:p>
+          <a:p>
+            <a:pPr marL="0" indent="0" algn="ctr">
+              <a:buNone/>
+            </a:pPr>
+            <a:r>
+              <a:rPr lang="en-US" sz="950" i="1" dirty="0">
+                <a:solidFill>
+                  <a:srgbClr val="5E7B83"/>
+                </a:solidFill>
+                <a:latin typeface="Microsoft YaHei" pitchFamily="34" charset="0"/>
+                <a:ea typeface="Microsoft YaHei" pitchFamily="34" charset="-122"/>
+                <a:cs typeface="Microsoft YaHei" pitchFamily="34" charset="-120"/>
+              </a:rPr>
+              <a:t>DS2 阴性仅 11 → 非统计显著，演示用</a:t>
+            </a:r>
+            <a:endParaRPr lang="en-US" sz="950" dirty="0"/>
+          </a:p>
+        </p:txBody>
+      </p:sp>
+      <p:sp>
+        <p:nvSpPr>
+          <p:cNvPr id="30" name="Text 27"/>
           <p:cNvSpPr/>
           <p:nvPr/>
         </p:nvSpPr>
@@ -2955,7 +2939,7 @@
           <a:bodyPr wrap="square" lIns="0" tIns="0" rIns="0" bIns="0" rtlCol="0" anchor="ctr"/>
           <a:lstStyle/>
           <a:p>
-            <a:pPr algn="r" indent="0" marL="0">
+            <a:pPr marL="0" indent="0" algn="r">
               <a:buNone/>
             </a:pPr>
             <a:r>
@@ -2987,8 +2971,9 @@
     <p:bg>
       <p:bgPr>
         <a:solidFill>
-          <a:srgbClr val="0B3C49"/>
+          <a:srgbClr val="F2F7F7"/>
         </a:solidFill>
+        <a:effectLst/>
       </p:bgPr>
     </p:bg>
     <p:spTree>
@@ -3014,6 +2999,540 @@
         <p:spPr>
           <a:xfrm>
             <a:off x="0" y="0"/>
+            <a:ext cx="256032" cy="6858000"/>
+          </a:xfrm>
+          <a:prstGeom prst="rect">
+            <a:avLst/>
+          </a:prstGeom>
+          <a:solidFill>
+            <a:srgbClr val="028090"/>
+          </a:solidFill>
+          <a:ln/>
+        </p:spPr>
+      </p:sp>
+      <p:sp>
+        <p:nvSpPr>
+          <p:cNvPr id="3" name="Text 1"/>
+          <p:cNvSpPr/>
+          <p:nvPr/>
+        </p:nvSpPr>
+        <p:spPr>
+          <a:xfrm>
+            <a:off x="640080" y="384048"/>
+            <a:ext cx="10058400" cy="274320"/>
+          </a:xfrm>
+          <a:prstGeom prst="rect">
+            <a:avLst/>
+          </a:prstGeom>
+          <a:noFill/>
+          <a:ln/>
+        </p:spPr>
+        <p:txBody>
+          <a:bodyPr wrap="square" lIns="0" tIns="0" rIns="0" bIns="0" rtlCol="0" anchor="ctr"/>
+          <a:lstStyle/>
+          <a:p>
+            <a:pPr marL="0" indent="0">
+              <a:buNone/>
+            </a:pPr>
+            <a:r>
+              <a:rPr lang="en-US" sz="1200" b="1" kern="0" spc="300" dirty="0">
+                <a:solidFill>
+                  <a:srgbClr val="028090"/>
+                </a:solidFill>
+                <a:latin typeface="Microsoft YaHei" pitchFamily="34" charset="0"/>
+                <a:ea typeface="Microsoft YaHei" pitchFamily="34" charset="-122"/>
+                <a:cs typeface="Microsoft YaHei" pitchFamily="34" charset="-120"/>
+              </a:rPr>
+              <a:t>BENCHMARK 深入</a:t>
+            </a:r>
+            <a:endParaRPr lang="en-US" sz="1200" dirty="0"/>
+          </a:p>
+        </p:txBody>
+      </p:sp>
+      <p:sp>
+        <p:nvSpPr>
+          <p:cNvPr id="4" name="Text 2"/>
+          <p:cNvSpPr/>
+          <p:nvPr/>
+        </p:nvSpPr>
+        <p:spPr>
+          <a:xfrm>
+            <a:off x="640080" y="658368"/>
+            <a:ext cx="10972800" cy="640080"/>
+          </a:xfrm>
+          <a:prstGeom prst="rect">
+            <a:avLst/>
+          </a:prstGeom>
+          <a:noFill/>
+          <a:ln/>
+        </p:spPr>
+        <p:txBody>
+          <a:bodyPr wrap="square" lIns="0" tIns="0" rIns="0" bIns="0" rtlCol="0" anchor="ctr"/>
+          <a:lstStyle/>
+          <a:p>
+            <a:pPr marL="0" indent="0">
+              <a:buNone/>
+            </a:pPr>
+            <a:r>
+              <a:rPr lang="en-US" sz="3000" b="1" dirty="0">
+                <a:solidFill>
+                  <a:srgbClr val="16323A"/>
+                </a:solidFill>
+                <a:latin typeface="Microsoft YaHei" pitchFamily="34" charset="0"/>
+                <a:ea typeface="Microsoft YaHei" pitchFamily="34" charset="-122"/>
+                <a:cs typeface="Microsoft YaHei" pitchFamily="34" charset="-120"/>
+              </a:rPr>
+              <a:t>阈值敏感性 · 定量相关 · 官方/改动透明</a:t>
+            </a:r>
+            <a:endParaRPr lang="en-US" sz="3000" dirty="0"/>
+          </a:p>
+        </p:txBody>
+      </p:sp>
+      <p:sp>
+        <p:nvSpPr>
+          <p:cNvPr id="5" name="Shape 3"/>
+          <p:cNvSpPr/>
+          <p:nvPr/>
+        </p:nvSpPr>
+        <p:spPr>
+          <a:xfrm>
+            <a:off x="640080" y="1508760"/>
+            <a:ext cx="5349240" cy="3063240"/>
+          </a:xfrm>
+          <a:prstGeom prst="rect">
+            <a:avLst/>
+          </a:prstGeom>
+          <a:solidFill>
+            <a:srgbClr val="FFFFFF"/>
+          </a:solidFill>
+          <a:ln w="12700">
+            <a:solidFill>
+              <a:srgbClr val="D5E3E4"/>
+            </a:solidFill>
+            <a:prstDash val="solid"/>
+          </a:ln>
+          <a:effectLst>
+            <a:outerShdw blurRad="114300" dist="38100" dir="8100000" algn="bl" rotWithShape="0">
+              <a:srgbClr val="0B3C49">
+                <a:alpha val="12000"/>
+              </a:srgbClr>
+            </a:outerShdw>
+          </a:effectLst>
+        </p:spPr>
+      </p:sp>
+      <p:pic>
+        <p:nvPicPr>
+          <p:cNvPr id="6" name="Image 0" descr="D:/YJ-Agent/project/meeting/QuantImmuBench/analysis/figures_R_v3/fig2_bar_v3.png"/>
+          <p:cNvPicPr>
+            <a:picLocks noChangeAspect="1"/>
+          </p:cNvPicPr>
+          <p:nvPr/>
+        </p:nvPicPr>
+        <p:blipFill>
+          <a:blip r:embed="rId3"/>
+          <a:srcRect/>
+          <a:stretch/>
+        </p:blipFill>
+        <p:spPr>
+          <a:xfrm>
+            <a:off x="777240" y="1627632"/>
+            <a:ext cx="5074920" cy="2834640"/>
+          </a:xfrm>
+          <a:prstGeom prst="rect">
+            <a:avLst/>
+          </a:prstGeom>
+        </p:spPr>
+      </p:pic>
+      <p:sp>
+        <p:nvSpPr>
+          <p:cNvPr id="7" name="Text 4"/>
+          <p:cNvSpPr/>
+          <p:nvPr/>
+        </p:nvSpPr>
+        <p:spPr>
+          <a:xfrm>
+            <a:off x="640080" y="4590288"/>
+            <a:ext cx="5349240" cy="502920"/>
+          </a:xfrm>
+          <a:prstGeom prst="rect">
+            <a:avLst/>
+          </a:prstGeom>
+          <a:noFill/>
+          <a:ln/>
+        </p:spPr>
+        <p:txBody>
+          <a:bodyPr wrap="square" lIns="0" tIns="0" rIns="0" bIns="0" rtlCol="0" anchor="t"/>
+          <a:lstStyle/>
+          <a:p>
+            <a:pPr marL="0" indent="0">
+              <a:buNone/>
+            </a:pPr>
+            <a:r>
+              <a:rPr lang="en-US" sz="950" dirty="0">
+                <a:solidFill>
+                  <a:srgbClr val="5E7B83"/>
+                </a:solidFill>
+                <a:latin typeface="Microsoft YaHei" pitchFamily="34" charset="0"/>
+                <a:ea typeface="Microsoft YaHei" pitchFamily="34" charset="-122"/>
+                <a:cs typeface="Microsoft YaHei" pitchFamily="34" charset="-120"/>
+              </a:rPr>
+              <a:t>① 阈值敏感：pTuneos &gt;0 最高 (0.78)，但 &gt;10/&gt;median 跌到 0.51/0.46 = 门槛效应；PredIG/IMPROVE 跨阈值稳</a:t>
+            </a:r>
+            <a:endParaRPr lang="en-US" sz="950" dirty="0"/>
+          </a:p>
+        </p:txBody>
+      </p:sp>
+      <p:sp>
+        <p:nvSpPr>
+          <p:cNvPr id="8" name="Shape 5"/>
+          <p:cNvSpPr/>
+          <p:nvPr/>
+        </p:nvSpPr>
+        <p:spPr>
+          <a:xfrm>
+            <a:off x="6172200" y="1508760"/>
+            <a:ext cx="5349240" cy="3063240"/>
+          </a:xfrm>
+          <a:prstGeom prst="rect">
+            <a:avLst/>
+          </a:prstGeom>
+          <a:solidFill>
+            <a:srgbClr val="FFFFFF"/>
+          </a:solidFill>
+          <a:ln w="12700">
+            <a:solidFill>
+              <a:srgbClr val="D5E3E4"/>
+            </a:solidFill>
+            <a:prstDash val="solid"/>
+          </a:ln>
+          <a:effectLst>
+            <a:outerShdw blurRad="114300" dist="38100" dir="8100000" algn="bl" rotWithShape="0">
+              <a:srgbClr val="0B3C49">
+                <a:alpha val="12000"/>
+              </a:srgbClr>
+            </a:outerShdw>
+          </a:effectLst>
+        </p:spPr>
+      </p:sp>
+      <p:pic>
+        <p:nvPicPr>
+          <p:cNvPr id="9" name="Image 1" descr="D:/YJ-Agent/project/meeting/QuantImmuBench/analysis/figures_R_v3/fig3_scatter_v3.png"/>
+          <p:cNvPicPr>
+            <a:picLocks noChangeAspect="1"/>
+          </p:cNvPicPr>
+          <p:nvPr/>
+        </p:nvPicPr>
+        <p:blipFill>
+          <a:blip r:embed="rId4"/>
+          <a:srcRect/>
+          <a:stretch/>
+        </p:blipFill>
+        <p:spPr>
+          <a:xfrm>
+            <a:off x="6309360" y="1627632"/>
+            <a:ext cx="5074920" cy="2834640"/>
+          </a:xfrm>
+          <a:prstGeom prst="rect">
+            <a:avLst/>
+          </a:prstGeom>
+        </p:spPr>
+      </p:pic>
+      <p:sp>
+        <p:nvSpPr>
+          <p:cNvPr id="10" name="Text 6"/>
+          <p:cNvSpPr/>
+          <p:nvPr/>
+        </p:nvSpPr>
+        <p:spPr>
+          <a:xfrm>
+            <a:off x="6172200" y="4590288"/>
+            <a:ext cx="5349240" cy="502920"/>
+          </a:xfrm>
+          <a:prstGeom prst="rect">
+            <a:avLst/>
+          </a:prstGeom>
+          <a:noFill/>
+          <a:ln/>
+        </p:spPr>
+        <p:txBody>
+          <a:bodyPr wrap="square" lIns="0" tIns="0" rIns="0" bIns="0" rtlCol="0" anchor="t"/>
+          <a:lstStyle/>
+          <a:p>
+            <a:pPr marL="0" indent="0">
+              <a:buNone/>
+            </a:pPr>
+            <a:r>
+              <a:rPr lang="en-US" sz="950" dirty="0">
+                <a:solidFill>
+                  <a:srgbClr val="5E7B83"/>
+                </a:solidFill>
+                <a:latin typeface="Microsoft YaHei" pitchFamily="34" charset="0"/>
+                <a:ea typeface="Microsoft YaHei" pitchFamily="34" charset="-122"/>
+                <a:cs typeface="Microsoft YaHei" pitchFamily="34" charset="-120"/>
+              </a:rPr>
+              <a:t>② 定量相关 (分数 vs ELISpot SFU)：PredIG ρ=0.28** / IMPROVE ρ=0.21* 能跟踪强度；pTuneos ρ=0.03 (ns) 不跟踪</a:t>
+            </a:r>
+            <a:endParaRPr lang="en-US" sz="950" dirty="0"/>
+          </a:p>
+        </p:txBody>
+      </p:sp>
+      <p:sp>
+        <p:nvSpPr>
+          <p:cNvPr id="11" name="Shape 7"/>
+          <p:cNvSpPr/>
+          <p:nvPr/>
+        </p:nvSpPr>
+        <p:spPr>
+          <a:xfrm>
+            <a:off x="640080" y="5230368"/>
+            <a:ext cx="5349240" cy="1325880"/>
+          </a:xfrm>
+          <a:prstGeom prst="rect">
+            <a:avLst/>
+          </a:prstGeom>
+          <a:solidFill>
+            <a:srgbClr val="E6F4F1"/>
+          </a:solidFill>
+          <a:ln w="12700">
+            <a:solidFill>
+              <a:srgbClr val="00A896"/>
+            </a:solidFill>
+            <a:prstDash val="solid"/>
+          </a:ln>
+        </p:spPr>
+      </p:sp>
+      <p:sp>
+        <p:nvSpPr>
+          <p:cNvPr id="12" name="Text 8"/>
+          <p:cNvSpPr/>
+          <p:nvPr/>
+        </p:nvSpPr>
+        <p:spPr>
+          <a:xfrm>
+            <a:off x="822960" y="5349240"/>
+            <a:ext cx="5029200" cy="1143000"/>
+          </a:xfrm>
+          <a:prstGeom prst="rect">
+            <a:avLst/>
+          </a:prstGeom>
+          <a:noFill/>
+          <a:ln/>
+        </p:spPr>
+        <p:txBody>
+          <a:bodyPr wrap="square" lIns="0" tIns="0" rIns="0" bIns="0" rtlCol="0" anchor="t"/>
+          <a:lstStyle/>
+          <a:p>
+            <a:pPr marL="0" indent="0">
+              <a:lnSpc>
+                <a:spcPct val="105000"/>
+              </a:lnSpc>
+              <a:buNone/>
+            </a:pPr>
+            <a:r>
+              <a:rPr lang="en-US" sz="1150" b="1" dirty="0">
+                <a:solidFill>
+                  <a:srgbClr val="028090"/>
+                </a:solidFill>
+                <a:latin typeface="Microsoft YaHei" pitchFamily="34" charset="0"/>
+                <a:ea typeface="Microsoft YaHei" pitchFamily="34" charset="-122"/>
+                <a:cs typeface="Microsoft YaHei" pitchFamily="34" charset="-120"/>
+              </a:rPr>
+              <a:t>✅ 完全官方 (算法/分数没动)
+</a:t>
+            </a:r>
+            <a:endParaRPr lang="en-US" sz="1150" dirty="0"/>
+          </a:p>
+          <a:p>
+            <a:pPr marL="0" indent="0">
+              <a:lnSpc>
+                <a:spcPct val="105000"/>
+              </a:lnSpc>
+              <a:buNone/>
+            </a:pPr>
+            <a:r>
+              <a:rPr lang="en-US" sz="1000" dirty="0">
+                <a:solidFill>
+                  <a:srgbClr val="16323A"/>
+                </a:solidFill>
+                <a:latin typeface="Microsoft YaHei" pitchFamily="34" charset="0"/>
+                <a:ea typeface="Microsoft YaHei" pitchFamily="34" charset="-122"/>
+                <a:cs typeface="Microsoft YaHei" pitchFamily="34" charset="-120"/>
+              </a:rPr>
+              <a:t>5 工具模型/权重/评分；pTuneos model_pro 数值 (r=1.0 对账证)；netMHCpan/blastp/VEP 等外部工具</a:t>
+            </a:r>
+            <a:endParaRPr lang="en-US" sz="1150" dirty="0"/>
+          </a:p>
+        </p:txBody>
+      </p:sp>
+      <p:sp>
+        <p:nvSpPr>
+          <p:cNvPr id="13" name="Shape 9"/>
+          <p:cNvSpPr/>
+          <p:nvPr/>
+        </p:nvSpPr>
+        <p:spPr>
+          <a:xfrm>
+            <a:off x="6172200" y="5230368"/>
+            <a:ext cx="5349240" cy="1325880"/>
+          </a:xfrm>
+          <a:prstGeom prst="rect">
+            <a:avLst/>
+          </a:prstGeom>
+          <a:solidFill>
+            <a:srgbClr val="FBEEE4"/>
+          </a:solidFill>
+          <a:ln w="12700">
+            <a:solidFill>
+              <a:srgbClr val="C9743D"/>
+            </a:solidFill>
+            <a:prstDash val="solid"/>
+          </a:ln>
+        </p:spPr>
+      </p:sp>
+      <p:sp>
+        <p:nvSpPr>
+          <p:cNvPr id="14" name="Text 10"/>
+          <p:cNvSpPr/>
+          <p:nvPr/>
+        </p:nvSpPr>
+        <p:spPr>
+          <a:xfrm>
+            <a:off x="6355080" y="5349240"/>
+            <a:ext cx="5029200" cy="1143000"/>
+          </a:xfrm>
+          <a:prstGeom prst="rect">
+            <a:avLst/>
+          </a:prstGeom>
+          <a:noFill/>
+          <a:ln/>
+        </p:spPr>
+        <p:txBody>
+          <a:bodyPr wrap="square" lIns="0" tIns="0" rIns="0" bIns="0" rtlCol="0" anchor="t"/>
+          <a:lstStyle/>
+          <a:p>
+            <a:pPr marL="0" indent="0">
+              <a:lnSpc>
+                <a:spcPct val="105000"/>
+              </a:lnSpc>
+              <a:buNone/>
+            </a:pPr>
+            <a:r>
+              <a:rPr lang="en-US" sz="1150" b="1" dirty="0">
+                <a:solidFill>
+                  <a:srgbClr val="C9743D"/>
+                </a:solidFill>
+                <a:latin typeface="Microsoft YaHei" pitchFamily="34" charset="0"/>
+                <a:ea typeface="Microsoft YaHei" pitchFamily="34" charset="-122"/>
+                <a:cs typeface="Microsoft YaHei" pitchFamily="34" charset="-120"/>
+              </a:rPr>
+              <a:t>🔧 我们的改动 (需标清)
+</a:t>
+            </a:r>
+            <a:endParaRPr lang="en-US" sz="1150" dirty="0"/>
+          </a:p>
+          <a:p>
+            <a:pPr marL="0" indent="0">
+              <a:lnSpc>
+                <a:spcPct val="105000"/>
+              </a:lnSpc>
+              <a:buNone/>
+            </a:pPr>
+            <a:r>
+              <a:rPr lang="en-US" sz="1000" dirty="0">
+                <a:solidFill>
+                  <a:srgbClr val="16323A"/>
+                </a:solidFill>
+                <a:latin typeface="Microsoft YaHei" pitchFamily="34" charset="0"/>
+                <a:ea typeface="Microsoft YaHei" pitchFamily="34" charset="-122"/>
+                <a:cs typeface="Microsoft YaHei" pitchFamily="34" charset="-120"/>
+              </a:rPr>
+              <a:t>ELISpot 滑窗/格式转换 · benchmark 评估框架 + 所有图 · ⚠️pTuneos 喂肽段 (抠识别子模型，合法但非官方标准流程) · 批处理加速 (结果同) · 修部署 8 坑 (不改算法)</a:t>
+            </a:r>
+            <a:endParaRPr lang="en-US" sz="1150" dirty="0"/>
+          </a:p>
+        </p:txBody>
+      </p:sp>
+      <p:sp>
+        <p:nvSpPr>
+          <p:cNvPr id="15" name="Text 11"/>
+          <p:cNvSpPr/>
+          <p:nvPr/>
+        </p:nvSpPr>
+        <p:spPr>
+          <a:xfrm>
+            <a:off x="11457432" y="6400800"/>
+            <a:ext cx="457200" cy="274320"/>
+          </a:xfrm>
+          <a:prstGeom prst="rect">
+            <a:avLst/>
+          </a:prstGeom>
+          <a:noFill/>
+          <a:ln/>
+        </p:spPr>
+        <p:txBody>
+          <a:bodyPr wrap="square" lIns="0" tIns="0" rIns="0" bIns="0" rtlCol="0" anchor="ctr"/>
+          <a:lstStyle/>
+          <a:p>
+            <a:pPr marL="0" indent="0" algn="r">
+              <a:buNone/>
+            </a:pPr>
+            <a:r>
+              <a:rPr lang="en-US" sz="1100" dirty="0">
+                <a:solidFill>
+                  <a:srgbClr val="5E7B83"/>
+                </a:solidFill>
+                <a:latin typeface="Microsoft YaHei" pitchFamily="34" charset="0"/>
+                <a:ea typeface="Microsoft YaHei" pitchFamily="34" charset="-122"/>
+                <a:cs typeface="Microsoft YaHei" pitchFamily="34" charset="-120"/>
+              </a:rPr>
+              <a:t>11</a:t>
+            </a:r>
+            <a:endParaRPr lang="en-US" sz="1100" dirty="0"/>
+          </a:p>
+        </p:txBody>
+      </p:sp>
+    </p:spTree>
+  </p:cSld>
+  <p:clrMapOvr>
+    <a:masterClrMapping/>
+  </p:clrMapOvr>
+</p:sld>
+</file>
+
+<file path=ppt/slides/slide12.xml><?xml version="1.0" encoding="utf-8"?>
+<p:sld xmlns:a="http://schemas.openxmlformats.org/drawingml/2006/main" xmlns:r="http://schemas.openxmlformats.org/officeDocument/2006/relationships" xmlns:p="http://schemas.openxmlformats.org/presentationml/2006/main">
+  <p:cSld name="Slide 12">
+    <p:bg>
+      <p:bgPr>
+        <a:solidFill>
+          <a:srgbClr val="0B3C49"/>
+        </a:solidFill>
+        <a:effectLst/>
+      </p:bgPr>
+    </p:bg>
+    <p:spTree>
+      <p:nvGrpSpPr>
+        <p:cNvPr id="1" name=""/>
+        <p:cNvGrpSpPr/>
+        <p:nvPr/>
+      </p:nvGrpSpPr>
+      <p:grpSpPr>
+        <a:xfrm>
+          <a:off x="0" y="0"/>
+          <a:ext cx="0" cy="0"/>
+          <a:chOff x="0" y="0"/>
+          <a:chExt cx="0" cy="0"/>
+        </a:xfrm>
+      </p:grpSpPr>
+      <p:sp>
+        <p:nvSpPr>
+          <p:cNvPr id="2" name="Shape 0"/>
+          <p:cNvSpPr/>
+          <p:nvPr/>
+        </p:nvSpPr>
+        <p:spPr>
+          <a:xfrm>
+            <a:off x="0" y="0"/>
             <a:ext cx="12188952" cy="164592"/>
           </a:xfrm>
           <a:prstGeom prst="rect">
@@ -3046,7 +3565,7 @@
           <a:bodyPr wrap="square" lIns="0" tIns="0" rIns="0" bIns="0" rtlCol="0" anchor="ctr"/>
           <a:lstStyle/>
           <a:p>
-            <a:pPr indent="0" marL="0">
+            <a:pPr marL="0" indent="0">
               <a:buNone/>
             </a:pPr>
             <a:r>
@@ -3085,7 +3604,7 @@
           <a:bodyPr wrap="square" lIns="0" tIns="0" rIns="0" bIns="0" rtlCol="0" anchor="ctr"/>
           <a:lstStyle/>
           <a:p>
-            <a:pPr indent="0" marL="0">
+            <a:pPr marL="0" indent="0">
               <a:buNone/>
             </a:pPr>
             <a:r>
@@ -3182,7 +3701,7 @@
                 <a:ea typeface="Microsoft YaHei" pitchFamily="34" charset="-122"/>
                 <a:cs typeface="Microsoft YaHei" pitchFamily="34" charset="-120"/>
               </a:rPr>
-              <a:t>4 / 5 产出 ELISpot 真实分数</a:t>
+              <a:t>5 / 5 产出 ELISpot 真实分数 + benchmark (pTuneos 用 Pre&amp;RecNeo 子模型，pTuneos AUC 最高 0.75)</a:t>
             </a:r>
             <a:endParaRPr lang="en-US" sz="1350" dirty="0"/>
           </a:p>
@@ -3227,7 +3746,7 @@
           <a:bodyPr wrap="square" lIns="0" tIns="0" rIns="0" bIns="0" rtlCol="0" anchor="ctr"/>
           <a:lstStyle/>
           <a:p>
-            <a:pPr indent="0" marL="0">
+            <a:pPr marL="0" indent="0">
               <a:buNone/>
             </a:pPr>
             <a:r>
@@ -3311,7 +3830,7 @@
           <a:bodyPr wrap="square" lIns="0" tIns="0" rIns="0" bIns="0" rtlCol="0" anchor="ctr"/>
           <a:lstStyle/>
           <a:p>
-            <a:pPr indent="0" marL="0">
+            <a:pPr marL="0" indent="0">
               <a:buNone/>
             </a:pPr>
             <a:r>
@@ -3350,7 +3869,7 @@
           <a:bodyPr wrap="square" lIns="0" tIns="0" rIns="0" bIns="0" rtlCol="0" anchor="t"/>
           <a:lstStyle/>
           <a:p>
-            <a:pPr indent="0" marL="0">
+            <a:pPr marL="0" indent="0">
               <a:buNone/>
             </a:pPr>
             <a:r>
@@ -3434,7 +3953,7 @@
           <a:bodyPr wrap="square" lIns="0" tIns="0" rIns="0" bIns="0" rtlCol="0" anchor="ctr"/>
           <a:lstStyle/>
           <a:p>
-            <a:pPr indent="0" marL="0">
+            <a:pPr marL="0" indent="0">
               <a:buNone/>
             </a:pPr>
             <a:r>
@@ -3473,7 +3992,7 @@
           <a:bodyPr wrap="square" lIns="0" tIns="0" rIns="0" bIns="0" rtlCol="0" anchor="t"/>
           <a:lstStyle/>
           <a:p>
-            <a:pPr indent="0" marL="0">
+            <a:pPr marL="0" indent="0">
               <a:buNone/>
             </a:pPr>
             <a:r>
@@ -3557,7 +4076,7 @@
           <a:bodyPr wrap="square" lIns="0" tIns="0" rIns="0" bIns="0" rtlCol="0" anchor="ctr"/>
           <a:lstStyle/>
           <a:p>
-            <a:pPr indent="0" marL="0">
+            <a:pPr marL="0" indent="0">
               <a:buNone/>
             </a:pPr>
             <a:r>
@@ -3569,7 +4088,7 @@
                 <a:ea typeface="Microsoft YaHei" pitchFamily="34" charset="-122"/>
                 <a:cs typeface="Microsoft YaHei" pitchFamily="34" charset="-120"/>
               </a:rPr>
-              <a:t>pTuneos VEP cache</a:t>
+              <a:t>pTuneos HPC 真跑</a:t>
             </a:r>
             <a:endParaRPr lang="en-US" sz="1300" dirty="0"/>
           </a:p>
@@ -3596,7 +4115,7 @@
           <a:bodyPr wrap="square" lIns="0" tIns="0" rIns="0" bIns="0" rtlCol="0" anchor="t"/>
           <a:lstStyle/>
           <a:p>
-            <a:pPr indent="0" marL="0">
+            <a:pPr marL="0" indent="0">
               <a:buNone/>
             </a:pPr>
             <a:r>
@@ -3608,7 +4127,7 @@
                 <a:ea typeface="Microsoft YaHei" pitchFamily="34" charset="-122"/>
                 <a:cs typeface="Microsoft YaHei" pitchFamily="34" charset="-120"/>
               </a:rPr>
-              <a:t>~15-25G 注释库待下；端到端停在注释步</a:t>
+              <a:t>本地 docker 已端到端；HPC singularity 非 root/fakeroot 受限，待重打包</a:t>
             </a:r>
             <a:endParaRPr lang="en-US" sz="1050" dirty="0"/>
           </a:p>
@@ -3680,11 +4199,11 @@
           <a:bodyPr wrap="square" lIns="0" tIns="0" rIns="0" bIns="0" rtlCol="0" anchor="ctr"/>
           <a:lstStyle/>
           <a:p>
-            <a:pPr indent="0" marL="0">
+            <a:pPr marL="0" indent="0">
               <a:buNone/>
             </a:pPr>
             <a:r>
-              <a:rPr lang="en-US" sz="1300" b="1" dirty="0">
+              <a:rPr lang="en-US" sz="1300" b="1">
                 <a:solidFill>
                   <a:srgbClr val="FFFFFF"/>
                 </a:solidFill>
@@ -3692,7 +4211,7 @@
                 <a:ea typeface="Microsoft YaHei" pitchFamily="34" charset="-122"/>
                 <a:cs typeface="Microsoft YaHei" pitchFamily="34" charset="-120"/>
               </a:rPr>
-              <a:t>袁老师正式数据</a:t>
+              <a:t>正式数据</a:t>
             </a:r>
             <a:endParaRPr lang="en-US" sz="1300" dirty="0"/>
           </a:p>
@@ -3719,7 +4238,7 @@
           <a:bodyPr wrap="square" lIns="0" tIns="0" rIns="0" bIns="0" rtlCol="0" anchor="t"/>
           <a:lstStyle/>
           <a:p>
-            <a:pPr indent="0" marL="0">
+            <a:pPr marL="0" indent="0">
               <a:buNone/>
             </a:pPr>
             <a:r>
@@ -3758,7 +4277,7 @@
           <a:bodyPr wrap="square" lIns="0" tIns="0" rIns="0" bIns="0" rtlCol="0" anchor="ctr"/>
           <a:lstStyle/>
           <a:p>
-            <a:pPr indent="0" marL="0">
+            <a:pPr marL="0" indent="0">
               <a:buNone/>
             </a:pPr>
             <a:r>
@@ -3792,6 +4311,7 @@
         <a:solidFill>
           <a:srgbClr val="F2F7F7"/>
         </a:solidFill>
+        <a:effectLst/>
       </p:bgPr>
     </p:bg>
     <p:spTree>
@@ -3849,11 +4369,11 @@
           <a:bodyPr wrap="square" lIns="0" tIns="0" rIns="0" bIns="0" rtlCol="0" anchor="ctr"/>
           <a:lstStyle/>
           <a:p>
-            <a:pPr indent="0" marL="0">
+            <a:pPr marL="0" indent="0">
               <a:buNone/>
             </a:pPr>
             <a:r>
-              <a:rPr lang="en-US" sz="1200" b="1" spc="300" kern="0" dirty="0">
+              <a:rPr lang="en-US" sz="1200" b="1" kern="0" spc="300" dirty="0">
                 <a:solidFill>
                   <a:srgbClr val="028090"/>
                 </a:solidFill>
@@ -3888,7 +4408,7 @@
           <a:bodyPr wrap="square" lIns="0" tIns="0" rIns="0" bIns="0" rtlCol="0" anchor="ctr"/>
           <a:lstStyle/>
           <a:p>
-            <a:pPr indent="0" marL="0">
+            <a:pPr marL="0" indent="0">
               <a:buNone/>
             </a:pPr>
             <a:r>
@@ -3925,7 +4445,7 @@
           </a:solidFill>
           <a:ln/>
           <a:effectLst>
-            <a:outerShdw sx="100000" sy="100000" kx="0" ky="0" algn="bl" rotWithShape="0" blurRad="114300" dist="38100" dir="8100000">
+            <a:outerShdw blurRad="114300" dist="38100" dir="8100000" algn="bl" rotWithShape="0">
               <a:srgbClr val="0B3C49">
                 <a:alpha val="12000"/>
               </a:srgbClr>
@@ -3954,7 +4474,7 @@
           <a:bodyPr wrap="square" lIns="0" tIns="0" rIns="0" bIns="0" rtlCol="0" anchor="ctr"/>
           <a:lstStyle/>
           <a:p>
-            <a:pPr indent="0" marL="0">
+            <a:pPr marL="0" indent="0">
               <a:buNone/>
             </a:pPr>
             <a:r>
@@ -3993,7 +4513,7 @@
           <a:bodyPr wrap="square" lIns="0" tIns="0" rIns="0" bIns="0" rtlCol="0" anchor="t"/>
           <a:lstStyle/>
           <a:p>
-            <a:pPr indent="0" marL="0">
+            <a:pPr marL="0" indent="0">
               <a:lnSpc>
                 <a:spcPct val="115000"/>
               </a:lnSpc>
@@ -4013,7 +4533,7 @@
             <a:endParaRPr lang="en-US" sz="1500" dirty="0"/>
           </a:p>
           <a:p>
-            <a:pPr indent="0" marL="0">
+            <a:pPr marL="0" indent="0">
               <a:lnSpc>
                 <a:spcPct val="115000"/>
               </a:lnSpc>
@@ -4033,7 +4553,7 @@
             <a:endParaRPr lang="en-US" sz="1500" dirty="0"/>
           </a:p>
           <a:p>
-            <a:pPr indent="0" marL="0">
+            <a:pPr marL="0" indent="0">
               <a:lnSpc>
                 <a:spcPct val="115000"/>
               </a:lnSpc>
@@ -4075,7 +4595,7 @@
           <a:bodyPr wrap="square" lIns="0" tIns="0" rIns="0" bIns="0" rtlCol="0" anchor="t"/>
           <a:lstStyle/>
           <a:p>
-            <a:pPr indent="0" marL="0">
+            <a:pPr marL="0" indent="0">
               <a:buNone/>
             </a:pPr>
             <a:r>
@@ -4093,7 +4613,7 @@
             <a:endParaRPr lang="en-US" sz="1300" dirty="0"/>
           </a:p>
           <a:p>
-            <a:pPr indent="0" marL="0">
+            <a:pPr marL="0" indent="0">
               <a:buNone/>
             </a:pPr>
             <a:r>
@@ -4132,7 +4652,7 @@
           <a:bodyPr wrap="square" lIns="0" tIns="0" rIns="0" bIns="0" rtlCol="0" anchor="t"/>
           <a:lstStyle/>
           <a:p>
-            <a:pPr indent="0" marL="0">
+            <a:pPr marL="0" indent="0">
               <a:buNone/>
             </a:pPr>
             <a:r>
@@ -4171,7 +4691,7 @@
           <a:bodyPr wrap="square" lIns="0" tIns="0" rIns="0" bIns="0" rtlCol="0" anchor="ctr"/>
           <a:lstStyle/>
           <a:p>
-            <a:pPr indent="0" marL="0">
+            <a:pPr marL="0" indent="0">
               <a:buNone/>
             </a:pPr>
             <a:r>
@@ -4213,7 +4733,7 @@
             <a:prstDash val="solid"/>
           </a:ln>
           <a:effectLst>
-            <a:outerShdw sx="100000" sy="100000" kx="0" ky="0" algn="bl" rotWithShape="0" blurRad="114300" dist="38100" dir="8100000">
+            <a:outerShdw blurRad="114300" dist="38100" dir="8100000" algn="bl" rotWithShape="0">
               <a:srgbClr val="0B3C49">
                 <a:alpha val="12000"/>
               </a:srgbClr>
@@ -4262,7 +4782,7 @@
           <a:bodyPr wrap="square" lIns="0" tIns="0" rIns="0" bIns="0" rtlCol="0" anchor="ctr"/>
           <a:lstStyle/>
           <a:p>
-            <a:pPr algn="ctr" indent="0" marL="0">
+            <a:pPr marL="0" indent="0" algn="ctr">
               <a:buNone/>
             </a:pPr>
             <a:r>
@@ -4301,7 +4821,7 @@
           <a:bodyPr wrap="square" lIns="0" tIns="0" rIns="0" bIns="0" rtlCol="0" anchor="ctr"/>
           <a:lstStyle/>
           <a:p>
-            <a:pPr indent="0" marL="0">
+            <a:pPr marL="0" indent="0">
               <a:buNone/>
             </a:pPr>
             <a:r>
@@ -4340,7 +4860,7 @@
           <a:bodyPr wrap="square" lIns="0" tIns="0" rIns="0" bIns="0" rtlCol="0" anchor="ctr"/>
           <a:lstStyle/>
           <a:p>
-            <a:pPr indent="0" marL="0">
+            <a:pPr marL="0" indent="0">
               <a:buNone/>
             </a:pPr>
             <a:r>
@@ -4382,7 +4902,7 @@
             <a:prstDash val="solid"/>
           </a:ln>
           <a:effectLst>
-            <a:outerShdw sx="100000" sy="100000" kx="0" ky="0" algn="bl" rotWithShape="0" blurRad="114300" dist="38100" dir="8100000">
+            <a:outerShdw blurRad="114300" dist="38100" dir="8100000" algn="bl" rotWithShape="0">
               <a:srgbClr val="0B3C49">
                 <a:alpha val="12000"/>
               </a:srgbClr>
@@ -4431,7 +4951,7 @@
           <a:bodyPr wrap="square" lIns="0" tIns="0" rIns="0" bIns="0" rtlCol="0" anchor="ctr"/>
           <a:lstStyle/>
           <a:p>
-            <a:pPr algn="ctr" indent="0" marL="0">
+            <a:pPr marL="0" indent="0" algn="ctr">
               <a:buNone/>
             </a:pPr>
             <a:r>
@@ -4470,7 +4990,7 @@
           <a:bodyPr wrap="square" lIns="0" tIns="0" rIns="0" bIns="0" rtlCol="0" anchor="ctr"/>
           <a:lstStyle/>
           <a:p>
-            <a:pPr indent="0" marL="0">
+            <a:pPr marL="0" indent="0">
               <a:buNone/>
             </a:pPr>
             <a:r>
@@ -4509,7 +5029,7 @@
           <a:bodyPr wrap="square" lIns="0" tIns="0" rIns="0" bIns="0" rtlCol="0" anchor="ctr"/>
           <a:lstStyle/>
           <a:p>
-            <a:pPr indent="0" marL="0">
+            <a:pPr marL="0" indent="0">
               <a:buNone/>
             </a:pPr>
             <a:r>
@@ -4551,7 +5071,7 @@
             <a:prstDash val="solid"/>
           </a:ln>
           <a:effectLst>
-            <a:outerShdw sx="100000" sy="100000" kx="0" ky="0" algn="bl" rotWithShape="0" blurRad="114300" dist="38100" dir="8100000">
+            <a:outerShdw blurRad="114300" dist="38100" dir="8100000" algn="bl" rotWithShape="0">
               <a:srgbClr val="0B3C49">
                 <a:alpha val="12000"/>
               </a:srgbClr>
@@ -4600,7 +5120,7 @@
           <a:bodyPr wrap="square" lIns="0" tIns="0" rIns="0" bIns="0" rtlCol="0" anchor="ctr"/>
           <a:lstStyle/>
           <a:p>
-            <a:pPr algn="ctr" indent="0" marL="0">
+            <a:pPr marL="0" indent="0" algn="ctr">
               <a:buNone/>
             </a:pPr>
             <a:r>
@@ -4639,7 +5159,7 @@
           <a:bodyPr wrap="square" lIns="0" tIns="0" rIns="0" bIns="0" rtlCol="0" anchor="ctr"/>
           <a:lstStyle/>
           <a:p>
-            <a:pPr indent="0" marL="0">
+            <a:pPr marL="0" indent="0">
               <a:buNone/>
             </a:pPr>
             <a:r>
@@ -4678,7 +5198,7 @@
           <a:bodyPr wrap="square" lIns="0" tIns="0" rIns="0" bIns="0" rtlCol="0" anchor="ctr"/>
           <a:lstStyle/>
           <a:p>
-            <a:pPr indent="0" marL="0">
+            <a:pPr marL="0" indent="0">
               <a:buNone/>
             </a:pPr>
             <a:r>
@@ -4720,7 +5240,7 @@
             <a:prstDash val="solid"/>
           </a:ln>
           <a:effectLst>
-            <a:outerShdw sx="100000" sy="100000" kx="0" ky="0" algn="bl" rotWithShape="0" blurRad="114300" dist="38100" dir="8100000">
+            <a:outerShdw blurRad="114300" dist="38100" dir="8100000" algn="bl" rotWithShape="0">
               <a:srgbClr val="0B3C49">
                 <a:alpha val="12000"/>
               </a:srgbClr>
@@ -4769,7 +5289,7 @@
           <a:bodyPr wrap="square" lIns="0" tIns="0" rIns="0" bIns="0" rtlCol="0" anchor="ctr"/>
           <a:lstStyle/>
           <a:p>
-            <a:pPr algn="ctr" indent="0" marL="0">
+            <a:pPr marL="0" indent="0" algn="ctr">
               <a:buNone/>
             </a:pPr>
             <a:r>
@@ -4808,7 +5328,7 @@
           <a:bodyPr wrap="square" lIns="0" tIns="0" rIns="0" bIns="0" rtlCol="0" anchor="ctr"/>
           <a:lstStyle/>
           <a:p>
-            <a:pPr indent="0" marL="0">
+            <a:pPr marL="0" indent="0">
               <a:buNone/>
             </a:pPr>
             <a:r>
@@ -4847,7 +5367,7 @@
           <a:bodyPr wrap="square" lIns="0" tIns="0" rIns="0" bIns="0" rtlCol="0" anchor="ctr"/>
           <a:lstStyle/>
           <a:p>
-            <a:pPr indent="0" marL="0">
+            <a:pPr marL="0" indent="0">
               <a:buNone/>
             </a:pPr>
             <a:r>
@@ -4886,7 +5406,7 @@
           <a:bodyPr wrap="square" lIns="0" tIns="0" rIns="0" bIns="0" rtlCol="0" anchor="ctr"/>
           <a:lstStyle/>
           <a:p>
-            <a:pPr algn="r" indent="0" marL="0">
+            <a:pPr marL="0" indent="0" algn="r">
               <a:buNone/>
             </a:pPr>
             <a:r>
@@ -4920,6 +5440,7 @@
         <a:solidFill>
           <a:srgbClr val="F2F7F7"/>
         </a:solidFill>
+        <a:effectLst/>
       </p:bgPr>
     </p:bg>
     <p:spTree>
@@ -4977,11 +5498,11 @@
           <a:bodyPr wrap="square" lIns="0" tIns="0" rIns="0" bIns="0" rtlCol="0" anchor="ctr"/>
           <a:lstStyle/>
           <a:p>
-            <a:pPr indent="0" marL="0">
+            <a:pPr marL="0" indent="0">
               <a:buNone/>
             </a:pPr>
             <a:r>
-              <a:rPr lang="en-US" sz="1200" b="1" spc="300" kern="0" dirty="0">
+              <a:rPr lang="en-US" sz="1200" b="1" kern="0" spc="300" dirty="0">
                 <a:solidFill>
                   <a:srgbClr val="028090"/>
                 </a:solidFill>
@@ -5016,7 +5537,7 @@
           <a:bodyPr wrap="square" lIns="0" tIns="0" rIns="0" bIns="0" rtlCol="0" anchor="ctr"/>
           <a:lstStyle/>
           <a:p>
-            <a:pPr indent="0" marL="0">
+            <a:pPr marL="0" indent="0">
               <a:buNone/>
             </a:pPr>
             <a:r>
@@ -5036,7 +5557,7 @@
       </p:sp>
       <p:graphicFrame>
         <p:nvGraphicFramePr>
-          <p:cNvPr id="4" name="Table 0"/>
+          <p:cNvPr id="5" name="Table 0"/>
           <p:cNvGraphicFramePr>
             <a:graphicFrameLocks noGrp="1"/>
           </p:cNvGraphicFramePr>
@@ -5050,19 +5571,55 @@
         </p:nvGraphicFramePr>
         <p:xfrm>
           <a:off x="640080" y="1783080"/>
-          <a:ext cx="10881360" cy="914400"/>
+          <a:ext cx="10881360" cy="3337560"/>
         </p:xfrm>
         <a:graphic>
           <a:graphicData uri="http://schemas.openxmlformats.org/drawingml/2006/table">
             <a:tbl>
               <a:tblPr/>
               <a:tblGrid>
-                <a:gridCol w="1828800"/>
-                <a:gridCol w="1737360"/>
-                <a:gridCol w="2103120"/>
-                <a:gridCol w="1691640"/>
-                <a:gridCol w="1554480"/>
-                <a:gridCol w="1965960"/>
+                <a:gridCol w="1828800">
+                  <a:extLst>
+                    <a:ext uri="{9D8B030D-6E8A-4147-A177-3AD203B41FA5}">
+                      <a16:colId xmlns:a16="http://schemas.microsoft.com/office/drawing/2014/main" val="20000"/>
+                    </a:ext>
+                  </a:extLst>
+                </a:gridCol>
+                <a:gridCol w="1737360">
+                  <a:extLst>
+                    <a:ext uri="{9D8B030D-6E8A-4147-A177-3AD203B41FA5}">
+                      <a16:colId xmlns:a16="http://schemas.microsoft.com/office/drawing/2014/main" val="20001"/>
+                    </a:ext>
+                  </a:extLst>
+                </a:gridCol>
+                <a:gridCol w="2103120">
+                  <a:extLst>
+                    <a:ext uri="{9D8B030D-6E8A-4147-A177-3AD203B41FA5}">
+                      <a16:colId xmlns:a16="http://schemas.microsoft.com/office/drawing/2014/main" val="20002"/>
+                    </a:ext>
+                  </a:extLst>
+                </a:gridCol>
+                <a:gridCol w="1691640">
+                  <a:extLst>
+                    <a:ext uri="{9D8B030D-6E8A-4147-A177-3AD203B41FA5}">
+                      <a16:colId xmlns:a16="http://schemas.microsoft.com/office/drawing/2014/main" val="20003"/>
+                    </a:ext>
+                  </a:extLst>
+                </a:gridCol>
+                <a:gridCol w="1554480">
+                  <a:extLst>
+                    <a:ext uri="{9D8B030D-6E8A-4147-A177-3AD203B41FA5}">
+                      <a16:colId xmlns:a16="http://schemas.microsoft.com/office/drawing/2014/main" val="20004"/>
+                    </a:ext>
+                  </a:extLst>
+                </a:gridCol>
+                <a:gridCol w="1965960">
+                  <a:extLst>
+                    <a:ext uri="{9D8B030D-6E8A-4147-A177-3AD203B41FA5}">
+                      <a16:colId xmlns:a16="http://schemas.microsoft.com/office/drawing/2014/main" val="20005"/>
+                    </a:ext>
+                  </a:extLst>
+                </a:gridCol>
               </a:tblGrid>
               <a:tr h="502920">
                 <a:tc>
@@ -5070,7 +5627,7 @@
                     <a:bodyPr/>
                     <a:lstStyle/>
                     <a:p>
-                      <a:pPr algn="ctr" indent="0" marL="0">
+                      <a:pPr marL="0" indent="0" algn="ctr">
                         <a:buNone/>
                       </a:pPr>
                       <a:r>
@@ -5091,7 +5648,7 @@
                       </a:endParaRPr>
                     </a:p>
                   </a:txBody>
-                  <a:tcPr marL="91440" marR="91440" marT="45720" marB="45720" anchor="ctr">
+                  <a:tcPr anchor="ctr">
                     <a:lnL w="12700" cap="flat" cmpd="sng" algn="ctr">
                       <a:solidFill>
                         <a:srgbClr val="D5E3E4"/>
@@ -5138,7 +5695,7 @@
                     <a:bodyPr/>
                     <a:lstStyle/>
                     <a:p>
-                      <a:pPr algn="ctr" indent="0" marL="0">
+                      <a:pPr marL="0" indent="0" algn="ctr">
                         <a:buNone/>
                       </a:pPr>
                       <a:r>
@@ -5159,7 +5716,7 @@
                       </a:endParaRPr>
                     </a:p>
                   </a:txBody>
-                  <a:tcPr marL="91440" marR="91440" marT="45720" marB="45720" anchor="ctr">
+                  <a:tcPr anchor="ctr">
                     <a:lnL w="12700" cap="flat" cmpd="sng" algn="ctr">
                       <a:solidFill>
                         <a:srgbClr val="D5E3E4"/>
@@ -5206,7 +5763,7 @@
                     <a:bodyPr/>
                     <a:lstStyle/>
                     <a:p>
-                      <a:pPr algn="ctr" indent="0" marL="0">
+                      <a:pPr marL="0" indent="0" algn="ctr">
                         <a:buNone/>
                       </a:pPr>
                       <a:r>
@@ -5227,7 +5784,7 @@
                       </a:endParaRPr>
                     </a:p>
                   </a:txBody>
-                  <a:tcPr marL="91440" marR="91440" marT="45720" marB="45720" anchor="ctr">
+                  <a:tcPr anchor="ctr">
                     <a:lnL w="12700" cap="flat" cmpd="sng" algn="ctr">
                       <a:solidFill>
                         <a:srgbClr val="D5E3E4"/>
@@ -5274,7 +5831,7 @@
                     <a:bodyPr/>
                     <a:lstStyle/>
                     <a:p>
-                      <a:pPr algn="ctr" indent="0" marL="0">
+                      <a:pPr marL="0" indent="0" algn="ctr">
                         <a:buNone/>
                       </a:pPr>
                       <a:r>
@@ -5295,7 +5852,7 @@
                       </a:endParaRPr>
                     </a:p>
                   </a:txBody>
-                  <a:tcPr marL="91440" marR="91440" marT="45720" marB="45720" anchor="ctr">
+                  <a:tcPr anchor="ctr">
                     <a:lnL w="12700" cap="flat" cmpd="sng" algn="ctr">
                       <a:solidFill>
                         <a:srgbClr val="D5E3E4"/>
@@ -5342,7 +5899,7 @@
                     <a:bodyPr/>
                     <a:lstStyle/>
                     <a:p>
-                      <a:pPr algn="ctr" indent="0" marL="0">
+                      <a:pPr marL="0" indent="0" algn="ctr">
                         <a:buNone/>
                       </a:pPr>
                       <a:r>
@@ -5363,7 +5920,7 @@
                       </a:endParaRPr>
                     </a:p>
                   </a:txBody>
-                  <a:tcPr marL="91440" marR="91440" marT="45720" marB="45720" anchor="ctr">
+                  <a:tcPr anchor="ctr">
                     <a:lnL w="12700" cap="flat" cmpd="sng" algn="ctr">
                       <a:solidFill>
                         <a:srgbClr val="D5E3E4"/>
@@ -5410,7 +5967,7 @@
                     <a:bodyPr/>
                     <a:lstStyle/>
                     <a:p>
-                      <a:pPr algn="ctr" indent="0" marL="0">
+                      <a:pPr marL="0" indent="0" algn="ctr">
                         <a:buNone/>
                       </a:pPr>
                       <a:r>
@@ -5431,7 +5988,7 @@
                       </a:endParaRPr>
                     </a:p>
                   </a:txBody>
-                  <a:tcPr marL="91440" marR="91440" marT="45720" marB="45720" anchor="ctr">
+                  <a:tcPr anchor="ctr">
                     <a:lnL w="12700" cap="flat" cmpd="sng" algn="ctr">
                       <a:solidFill>
                         <a:srgbClr val="D5E3E4"/>
@@ -5473,6 +6030,11 @@
                     </a:solidFill>
                   </a:tcPr>
                 </a:tc>
+                <a:extLst>
+                  <a:ext uri="{0D108BD9-81ED-4DB2-BD59-A6C34878D82A}">
+                    <a16:rowId xmlns:a16="http://schemas.microsoft.com/office/drawing/2014/main" val="10000"/>
+                  </a:ext>
+                </a:extLst>
               </a:tr>
               <a:tr h="566928">
                 <a:tc>
@@ -5480,7 +6042,7 @@
                     <a:bodyPr/>
                     <a:lstStyle/>
                     <a:p>
-                      <a:pPr algn="l" indent="0" marL="0">
+                      <a:pPr marL="0" indent="0" algn="l">
                         <a:buNone/>
                       </a:pPr>
                       <a:r>
@@ -5501,7 +6063,7 @@
                       </a:endParaRPr>
                     </a:p>
                   </a:txBody>
-                  <a:tcPr marL="91440" marR="91440" marT="45720" marB="45720" anchor="ctr">
+                  <a:tcPr anchor="ctr">
                     <a:lnL w="12700" cap="flat" cmpd="sng" algn="ctr">
                       <a:solidFill>
                         <a:srgbClr val="D5E3E4"/>
@@ -5548,7 +6110,7 @@
                     <a:bodyPr/>
                     <a:lstStyle/>
                     <a:p>
-                      <a:pPr algn="ctr" indent="0" marL="0">
+                      <a:pPr marL="0" indent="0" algn="ctr">
                         <a:buNone/>
                       </a:pPr>
                       <a:r>
@@ -5569,7 +6131,7 @@
                       </a:endParaRPr>
                     </a:p>
                   </a:txBody>
-                  <a:tcPr marL="91440" marR="91440" marT="45720" marB="45720" anchor="ctr">
+                  <a:tcPr anchor="ctr">
                     <a:lnL w="12700" cap="flat" cmpd="sng" algn="ctr">
                       <a:solidFill>
                         <a:srgbClr val="D5E3E4"/>
@@ -5616,7 +6178,7 @@
                     <a:bodyPr/>
                     <a:lstStyle/>
                     <a:p>
-                      <a:pPr algn="ctr" indent="0" marL="0">
+                      <a:pPr marL="0" indent="0" algn="ctr">
                         <a:buNone/>
                       </a:pPr>
                       <a:r>
@@ -5637,7 +6199,7 @@
                       </a:endParaRPr>
                     </a:p>
                   </a:txBody>
-                  <a:tcPr marL="91440" marR="91440" marT="45720" marB="45720" anchor="ctr">
+                  <a:tcPr anchor="ctr">
                     <a:lnL w="12700" cap="flat" cmpd="sng" algn="ctr">
                       <a:solidFill>
                         <a:srgbClr val="D5E3E4"/>
@@ -5684,7 +6246,7 @@
                     <a:bodyPr/>
                     <a:lstStyle/>
                     <a:p>
-                      <a:pPr algn="ctr" indent="0" marL="0">
+                      <a:pPr marL="0" indent="0" algn="ctr">
                         <a:buNone/>
                       </a:pPr>
                       <a:r>
@@ -5705,7 +6267,7 @@
                       </a:endParaRPr>
                     </a:p>
                   </a:txBody>
-                  <a:tcPr marL="91440" marR="91440" marT="45720" marB="45720" anchor="ctr">
+                  <a:tcPr anchor="ctr">
                     <a:lnL w="12700" cap="flat" cmpd="sng" algn="ctr">
                       <a:solidFill>
                         <a:srgbClr val="D5E3E4"/>
@@ -5752,7 +6314,7 @@
                     <a:bodyPr/>
                     <a:lstStyle/>
                     <a:p>
-                      <a:pPr algn="ctr" indent="0" marL="0">
+                      <a:pPr marL="0" indent="0" algn="ctr">
                         <a:buNone/>
                       </a:pPr>
                       <a:r>
@@ -5773,7 +6335,7 @@
                       </a:endParaRPr>
                     </a:p>
                   </a:txBody>
-                  <a:tcPr marL="91440" marR="91440" marT="45720" marB="45720" anchor="ctr">
+                  <a:tcPr anchor="ctr">
                     <a:lnL w="12700" cap="flat" cmpd="sng" algn="ctr">
                       <a:solidFill>
                         <a:srgbClr val="D5E3E4"/>
@@ -5820,7 +6382,7 @@
                     <a:bodyPr/>
                     <a:lstStyle/>
                     <a:p>
-                      <a:pPr algn="ctr" indent="0" marL="0">
+                      <a:pPr marL="0" indent="0" algn="ctr">
                         <a:buNone/>
                       </a:pPr>
                       <a:r>
@@ -5841,7 +6403,7 @@
                       </a:endParaRPr>
                     </a:p>
                   </a:txBody>
-                  <a:tcPr marL="91440" marR="91440" marT="45720" marB="45720" anchor="ctr">
+                  <a:tcPr anchor="ctr">
                     <a:lnL w="12700" cap="flat" cmpd="sng" algn="ctr">
                       <a:solidFill>
                         <a:srgbClr val="D5E3E4"/>
@@ -5883,6 +6445,11 @@
                     </a:solidFill>
                   </a:tcPr>
                 </a:tc>
+                <a:extLst>
+                  <a:ext uri="{0D108BD9-81ED-4DB2-BD59-A6C34878D82A}">
+                    <a16:rowId xmlns:a16="http://schemas.microsoft.com/office/drawing/2014/main" val="10001"/>
+                  </a:ext>
+                </a:extLst>
               </a:tr>
               <a:tr h="566928">
                 <a:tc>
@@ -5890,7 +6457,7 @@
                     <a:bodyPr/>
                     <a:lstStyle/>
                     <a:p>
-                      <a:pPr algn="l" indent="0" marL="0">
+                      <a:pPr marL="0" indent="0" algn="l">
                         <a:buNone/>
                       </a:pPr>
                       <a:r>
@@ -5911,7 +6478,7 @@
                       </a:endParaRPr>
                     </a:p>
                   </a:txBody>
-                  <a:tcPr marL="91440" marR="91440" marT="45720" marB="45720" anchor="ctr">
+                  <a:tcPr anchor="ctr">
                     <a:lnL w="12700" cap="flat" cmpd="sng" algn="ctr">
                       <a:solidFill>
                         <a:srgbClr val="D5E3E4"/>
@@ -5958,7 +6525,7 @@
                     <a:bodyPr/>
                     <a:lstStyle/>
                     <a:p>
-                      <a:pPr algn="ctr" indent="0" marL="0">
+                      <a:pPr marL="0" indent="0" algn="ctr">
                         <a:buNone/>
                       </a:pPr>
                       <a:r>
@@ -5979,7 +6546,7 @@
                       </a:endParaRPr>
                     </a:p>
                   </a:txBody>
-                  <a:tcPr marL="91440" marR="91440" marT="45720" marB="45720" anchor="ctr">
+                  <a:tcPr anchor="ctr">
                     <a:lnL w="12700" cap="flat" cmpd="sng" algn="ctr">
                       <a:solidFill>
                         <a:srgbClr val="D5E3E4"/>
@@ -6026,7 +6593,7 @@
                     <a:bodyPr/>
                     <a:lstStyle/>
                     <a:p>
-                      <a:pPr algn="ctr" indent="0" marL="0">
+                      <a:pPr marL="0" indent="0" algn="ctr">
                         <a:buNone/>
                       </a:pPr>
                       <a:r>
@@ -6047,7 +6614,7 @@
                       </a:endParaRPr>
                     </a:p>
                   </a:txBody>
-                  <a:tcPr marL="91440" marR="91440" marT="45720" marB="45720" anchor="ctr">
+                  <a:tcPr anchor="ctr">
                     <a:lnL w="12700" cap="flat" cmpd="sng" algn="ctr">
                       <a:solidFill>
                         <a:srgbClr val="D5E3E4"/>
@@ -6094,7 +6661,7 @@
                     <a:bodyPr/>
                     <a:lstStyle/>
                     <a:p>
-                      <a:pPr algn="ctr" indent="0" marL="0">
+                      <a:pPr marL="0" indent="0" algn="ctr">
                         <a:buNone/>
                       </a:pPr>
                       <a:r>
@@ -6115,7 +6682,7 @@
                       </a:endParaRPr>
                     </a:p>
                   </a:txBody>
-                  <a:tcPr marL="91440" marR="91440" marT="45720" marB="45720" anchor="ctr">
+                  <a:tcPr anchor="ctr">
                     <a:lnL w="12700" cap="flat" cmpd="sng" algn="ctr">
                       <a:solidFill>
                         <a:srgbClr val="D5E3E4"/>
@@ -6162,7 +6729,7 @@
                     <a:bodyPr/>
                     <a:lstStyle/>
                     <a:p>
-                      <a:pPr algn="ctr" indent="0" marL="0">
+                      <a:pPr marL="0" indent="0" algn="ctr">
                         <a:buNone/>
                       </a:pPr>
                       <a:r>
@@ -6183,7 +6750,7 @@
                       </a:endParaRPr>
                     </a:p>
                   </a:txBody>
-                  <a:tcPr marL="91440" marR="91440" marT="45720" marB="45720" anchor="ctr">
+                  <a:tcPr anchor="ctr">
                     <a:lnL w="12700" cap="flat" cmpd="sng" algn="ctr">
                       <a:solidFill>
                         <a:srgbClr val="D5E3E4"/>
@@ -6230,7 +6797,7 @@
                     <a:bodyPr/>
                     <a:lstStyle/>
                     <a:p>
-                      <a:pPr algn="ctr" indent="0" marL="0">
+                      <a:pPr marL="0" indent="0" algn="ctr">
                         <a:buNone/>
                       </a:pPr>
                       <a:r>
@@ -6251,7 +6818,7 @@
                       </a:endParaRPr>
                     </a:p>
                   </a:txBody>
-                  <a:tcPr marL="91440" marR="91440" marT="45720" marB="45720" anchor="ctr">
+                  <a:tcPr anchor="ctr">
                     <a:lnL w="12700" cap="flat" cmpd="sng" algn="ctr">
                       <a:solidFill>
                         <a:srgbClr val="D5E3E4"/>
@@ -6293,6 +6860,11 @@
                     </a:solidFill>
                   </a:tcPr>
                 </a:tc>
+                <a:extLst>
+                  <a:ext uri="{0D108BD9-81ED-4DB2-BD59-A6C34878D82A}">
+                    <a16:rowId xmlns:a16="http://schemas.microsoft.com/office/drawing/2014/main" val="10002"/>
+                  </a:ext>
+                </a:extLst>
               </a:tr>
               <a:tr h="566928">
                 <a:tc>
@@ -6300,7 +6872,7 @@
                     <a:bodyPr/>
                     <a:lstStyle/>
                     <a:p>
-                      <a:pPr algn="l" indent="0" marL="0">
+                      <a:pPr marL="0" indent="0" algn="l">
                         <a:buNone/>
                       </a:pPr>
                       <a:r>
@@ -6321,7 +6893,7 @@
                       </a:endParaRPr>
                     </a:p>
                   </a:txBody>
-                  <a:tcPr marL="91440" marR="91440" marT="45720" marB="45720" anchor="ctr">
+                  <a:tcPr anchor="ctr">
                     <a:lnL w="12700" cap="flat" cmpd="sng" algn="ctr">
                       <a:solidFill>
                         <a:srgbClr val="D5E3E4"/>
@@ -6368,7 +6940,7 @@
                     <a:bodyPr/>
                     <a:lstStyle/>
                     <a:p>
-                      <a:pPr algn="ctr" indent="0" marL="0">
+                      <a:pPr marL="0" indent="0" algn="ctr">
                         <a:buNone/>
                       </a:pPr>
                       <a:r>
@@ -6389,7 +6961,7 @@
                       </a:endParaRPr>
                     </a:p>
                   </a:txBody>
-                  <a:tcPr marL="91440" marR="91440" marT="45720" marB="45720" anchor="ctr">
+                  <a:tcPr anchor="ctr">
                     <a:lnL w="12700" cap="flat" cmpd="sng" algn="ctr">
                       <a:solidFill>
                         <a:srgbClr val="D5E3E4"/>
@@ -6436,7 +7008,7 @@
                     <a:bodyPr/>
                     <a:lstStyle/>
                     <a:p>
-                      <a:pPr algn="ctr" indent="0" marL="0">
+                      <a:pPr marL="0" indent="0" algn="ctr">
                         <a:buNone/>
                       </a:pPr>
                       <a:r>
@@ -6457,7 +7029,7 @@
                       </a:endParaRPr>
                     </a:p>
                   </a:txBody>
-                  <a:tcPr marL="91440" marR="91440" marT="45720" marB="45720" anchor="ctr">
+                  <a:tcPr anchor="ctr">
                     <a:lnL w="12700" cap="flat" cmpd="sng" algn="ctr">
                       <a:solidFill>
                         <a:srgbClr val="D5E3E4"/>
@@ -6504,7 +7076,7 @@
                     <a:bodyPr/>
                     <a:lstStyle/>
                     <a:p>
-                      <a:pPr algn="ctr" indent="0" marL="0">
+                      <a:pPr marL="0" indent="0" algn="ctr">
                         <a:buNone/>
                       </a:pPr>
                       <a:r>
@@ -6525,7 +7097,7 @@
                       </a:endParaRPr>
                     </a:p>
                   </a:txBody>
-                  <a:tcPr marL="91440" marR="91440" marT="45720" marB="45720" anchor="ctr">
+                  <a:tcPr anchor="ctr">
                     <a:lnL w="12700" cap="flat" cmpd="sng" algn="ctr">
                       <a:solidFill>
                         <a:srgbClr val="D5E3E4"/>
@@ -6572,7 +7144,7 @@
                     <a:bodyPr/>
                     <a:lstStyle/>
                     <a:p>
-                      <a:pPr algn="ctr" indent="0" marL="0">
+                      <a:pPr marL="0" indent="0" algn="ctr">
                         <a:buNone/>
                       </a:pPr>
                       <a:r>
@@ -6593,7 +7165,7 @@
                       </a:endParaRPr>
                     </a:p>
                   </a:txBody>
-                  <a:tcPr marL="91440" marR="91440" marT="45720" marB="45720" anchor="ctr">
+                  <a:tcPr anchor="ctr">
                     <a:lnL w="12700" cap="flat" cmpd="sng" algn="ctr">
                       <a:solidFill>
                         <a:srgbClr val="D5E3E4"/>
@@ -6640,7 +7212,7 @@
                     <a:bodyPr/>
                     <a:lstStyle/>
                     <a:p>
-                      <a:pPr algn="ctr" indent="0" marL="0">
+                      <a:pPr marL="0" indent="0" algn="ctr">
                         <a:buNone/>
                       </a:pPr>
                       <a:r>
@@ -6661,7 +7233,7 @@
                       </a:endParaRPr>
                     </a:p>
                   </a:txBody>
-                  <a:tcPr marL="91440" marR="91440" marT="45720" marB="45720" anchor="ctr">
+                  <a:tcPr anchor="ctr">
                     <a:lnL w="12700" cap="flat" cmpd="sng" algn="ctr">
                       <a:solidFill>
                         <a:srgbClr val="D5E3E4"/>
@@ -6703,6 +7275,11 @@
                     </a:solidFill>
                   </a:tcPr>
                 </a:tc>
+                <a:extLst>
+                  <a:ext uri="{0D108BD9-81ED-4DB2-BD59-A6C34878D82A}">
+                    <a16:rowId xmlns:a16="http://schemas.microsoft.com/office/drawing/2014/main" val="10003"/>
+                  </a:ext>
+                </a:extLst>
               </a:tr>
               <a:tr h="566928">
                 <a:tc>
@@ -6710,7 +7287,7 @@
                     <a:bodyPr/>
                     <a:lstStyle/>
                     <a:p>
-                      <a:pPr algn="l" indent="0" marL="0">
+                      <a:pPr marL="0" indent="0" algn="l">
                         <a:buNone/>
                       </a:pPr>
                       <a:r>
@@ -6731,7 +7308,7 @@
                       </a:endParaRPr>
                     </a:p>
                   </a:txBody>
-                  <a:tcPr marL="91440" marR="91440" marT="45720" marB="45720" anchor="ctr">
+                  <a:tcPr anchor="ctr">
                     <a:lnL w="12700" cap="flat" cmpd="sng" algn="ctr">
                       <a:solidFill>
                         <a:srgbClr val="D5E3E4"/>
@@ -6778,7 +7355,7 @@
                     <a:bodyPr/>
                     <a:lstStyle/>
                     <a:p>
-                      <a:pPr algn="ctr" indent="0" marL="0">
+                      <a:pPr marL="0" indent="0" algn="ctr">
                         <a:buNone/>
                       </a:pPr>
                       <a:r>
@@ -6799,7 +7376,7 @@
                       </a:endParaRPr>
                     </a:p>
                   </a:txBody>
-                  <a:tcPr marL="91440" marR="91440" marT="45720" marB="45720" anchor="ctr">
+                  <a:tcPr anchor="ctr">
                     <a:lnL w="12700" cap="flat" cmpd="sng" algn="ctr">
                       <a:solidFill>
                         <a:srgbClr val="D5E3E4"/>
@@ -6846,7 +7423,7 @@
                     <a:bodyPr/>
                     <a:lstStyle/>
                     <a:p>
-                      <a:pPr algn="ctr" indent="0" marL="0">
+                      <a:pPr marL="0" indent="0" algn="ctr">
                         <a:buNone/>
                       </a:pPr>
                       <a:r>
@@ -6867,7 +7444,7 @@
                       </a:endParaRPr>
                     </a:p>
                   </a:txBody>
-                  <a:tcPr marL="91440" marR="91440" marT="45720" marB="45720" anchor="ctr">
+                  <a:tcPr anchor="ctr">
                     <a:lnL w="12700" cap="flat" cmpd="sng" algn="ctr">
                       <a:solidFill>
                         <a:srgbClr val="D5E3E4"/>
@@ -6914,7 +7491,7 @@
                     <a:bodyPr/>
                     <a:lstStyle/>
                     <a:p>
-                      <a:pPr algn="ctr" indent="0" marL="0">
+                      <a:pPr marL="0" indent="0" algn="ctr">
                         <a:buNone/>
                       </a:pPr>
                       <a:r>
@@ -6935,7 +7512,7 @@
                       </a:endParaRPr>
                     </a:p>
                   </a:txBody>
-                  <a:tcPr marL="91440" marR="91440" marT="45720" marB="45720" anchor="ctr">
+                  <a:tcPr anchor="ctr">
                     <a:lnL w="12700" cap="flat" cmpd="sng" algn="ctr">
                       <a:solidFill>
                         <a:srgbClr val="D5E3E4"/>
@@ -6982,7 +7559,7 @@
                     <a:bodyPr/>
                     <a:lstStyle/>
                     <a:p>
-                      <a:pPr algn="ctr" indent="0" marL="0">
+                      <a:pPr marL="0" indent="0" algn="ctr">
                         <a:buNone/>
                       </a:pPr>
                       <a:r>
@@ -7003,7 +7580,7 @@
                       </a:endParaRPr>
                     </a:p>
                   </a:txBody>
-                  <a:tcPr marL="91440" marR="91440" marT="45720" marB="45720" anchor="ctr">
+                  <a:tcPr anchor="ctr">
                     <a:lnL w="12700" cap="flat" cmpd="sng" algn="ctr">
                       <a:solidFill>
                         <a:srgbClr val="D5E3E4"/>
@@ -7050,7 +7627,7 @@
                     <a:bodyPr/>
                     <a:lstStyle/>
                     <a:p>
-                      <a:pPr algn="ctr" indent="0" marL="0">
+                      <a:pPr marL="0" indent="0" algn="ctr">
                         <a:buNone/>
                       </a:pPr>
                       <a:r>
@@ -7071,7 +7648,7 @@
                       </a:endParaRPr>
                     </a:p>
                   </a:txBody>
-                  <a:tcPr marL="91440" marR="91440" marT="45720" marB="45720" anchor="ctr">
+                  <a:tcPr anchor="ctr">
                     <a:lnL w="12700" cap="flat" cmpd="sng" algn="ctr">
                       <a:solidFill>
                         <a:srgbClr val="D5E3E4"/>
@@ -7113,6 +7690,11 @@
                     </a:solidFill>
                   </a:tcPr>
                 </a:tc>
+                <a:extLst>
+                  <a:ext uri="{0D108BD9-81ED-4DB2-BD59-A6C34878D82A}">
+                    <a16:rowId xmlns:a16="http://schemas.microsoft.com/office/drawing/2014/main" val="10004"/>
+                  </a:ext>
+                </a:extLst>
               </a:tr>
               <a:tr h="566928">
                 <a:tc>
@@ -7120,7 +7702,7 @@
                     <a:bodyPr/>
                     <a:lstStyle/>
                     <a:p>
-                      <a:pPr algn="l" indent="0" marL="0">
+                      <a:pPr marL="0" indent="0" algn="l">
                         <a:buNone/>
                       </a:pPr>
                       <a:r>
@@ -7141,7 +7723,7 @@
                       </a:endParaRPr>
                     </a:p>
                   </a:txBody>
-                  <a:tcPr marL="91440" marR="91440" marT="45720" marB="45720" anchor="ctr">
+                  <a:tcPr anchor="ctr">
                     <a:lnL w="12700" cap="flat" cmpd="sng" algn="ctr">
                       <a:solidFill>
                         <a:srgbClr val="D5E3E4"/>
@@ -7188,7 +7770,7 @@
                     <a:bodyPr/>
                     <a:lstStyle/>
                     <a:p>
-                      <a:pPr algn="ctr" indent="0" marL="0">
+                      <a:pPr marL="0" indent="0" algn="ctr">
                         <a:buNone/>
                       </a:pPr>
                       <a:r>
@@ -7209,7 +7791,7 @@
                       </a:endParaRPr>
                     </a:p>
                   </a:txBody>
-                  <a:tcPr marL="91440" marR="91440" marT="45720" marB="45720" anchor="ctr">
+                  <a:tcPr anchor="ctr">
                     <a:lnL w="12700" cap="flat" cmpd="sng" algn="ctr">
                       <a:solidFill>
                         <a:srgbClr val="D5E3E4"/>
@@ -7256,7 +7838,7 @@
                     <a:bodyPr/>
                     <a:lstStyle/>
                     <a:p>
-                      <a:pPr algn="ctr" indent="0" marL="0">
+                      <a:pPr marL="0" indent="0" algn="ctr">
                         <a:buNone/>
                       </a:pPr>
                       <a:r>
@@ -7277,7 +7859,7 @@
                       </a:endParaRPr>
                     </a:p>
                   </a:txBody>
-                  <a:tcPr marL="91440" marR="91440" marT="45720" marB="45720" anchor="ctr">
+                  <a:tcPr anchor="ctr">
                     <a:lnL w="12700" cap="flat" cmpd="sng" algn="ctr">
                       <a:solidFill>
                         <a:srgbClr val="D5E3E4"/>
@@ -7324,19 +7906,19 @@
                     <a:bodyPr/>
                     <a:lstStyle/>
                     <a:p>
-                      <a:pPr algn="ctr" indent="0" marL="0">
+                      <a:pPr marL="0" indent="0" algn="ctr">
                         <a:buNone/>
                       </a:pPr>
                       <a:r>
                         <a:rPr lang="en-US" sz="1250" dirty="0">
                           <a:solidFill>
-                            <a:srgbClr val="C9743D"/>
+                            <a:srgbClr val="00A896"/>
                           </a:solidFill>
                           <a:latin typeface="Microsoft YaHei" pitchFamily="34" charset="0"/>
                           <a:ea typeface="Microsoft YaHei" pitchFamily="34" charset="-122"/>
                           <a:cs typeface="Microsoft YaHei" pitchFamily="34" charset="-120"/>
                         </a:rPr>
-                        <a:t>🟡 部署验证</a:t>
+                        <a:t>✅ 端到端</a:t>
                       </a:r>
                       <a:endParaRPr lang="en-US" sz="1250" dirty="0">
                         <a:latin typeface="Microsoft YaHei" charset="0"/>
@@ -7345,7 +7927,7 @@
                       </a:endParaRPr>
                     </a:p>
                   </a:txBody>
-                  <a:tcPr marL="91440" marR="91440" marT="45720" marB="45720" anchor="ctr">
+                  <a:tcPr anchor="ctr">
                     <a:lnL w="12700" cap="flat" cmpd="sng" algn="ctr">
                       <a:solidFill>
                         <a:srgbClr val="D5E3E4"/>
@@ -7392,7 +7974,7 @@
                     <a:bodyPr/>
                     <a:lstStyle/>
                     <a:p>
-                      <a:pPr algn="ctr" indent="0" marL="0">
+                      <a:pPr marL="0" indent="0" algn="ctr">
                         <a:buNone/>
                       </a:pPr>
                       <a:r>
@@ -7404,7 +7986,7 @@
                           <a:ea typeface="Microsoft YaHei" pitchFamily="34" charset="-122"/>
                           <a:cs typeface="Microsoft YaHei" pitchFamily="34" charset="-120"/>
                         </a:rPr>
-                        <a:t>🟡 sif 建成</a:t>
+                        <a:t>🟡 sif 受限</a:t>
                       </a:r>
                       <a:endParaRPr lang="en-US" sz="1250" dirty="0">
                         <a:latin typeface="Microsoft YaHei" charset="0"/>
@@ -7413,7 +7995,7 @@
                       </a:endParaRPr>
                     </a:p>
                   </a:txBody>
-                  <a:tcPr marL="91440" marR="91440" marT="45720" marB="45720" anchor="ctr">
+                  <a:tcPr anchor="ctr">
                     <a:lnL w="12700" cap="flat" cmpd="sng" algn="ctr">
                       <a:solidFill>
                         <a:srgbClr val="D5E3E4"/>
@@ -7460,19 +8042,19 @@
                     <a:bodyPr/>
                     <a:lstStyle/>
                     <a:p>
-                      <a:pPr algn="ctr" indent="0" marL="0">
+                      <a:pPr marL="0" indent="0" algn="ctr">
                         <a:buNone/>
                       </a:pPr>
                       <a:r>
                         <a:rPr lang="en-US" sz="1250" dirty="0">
                           <a:solidFill>
-                            <a:srgbClr val="C9743D"/>
+                            <a:srgbClr val="00A896"/>
                           </a:solidFill>
                           <a:latin typeface="Microsoft YaHei" pitchFamily="34" charset="0"/>
                           <a:ea typeface="Microsoft YaHei" pitchFamily="34" charset="-122"/>
                           <a:cs typeface="Microsoft YaHei" pitchFamily="34" charset="-120"/>
                         </a:rPr>
-                        <a:t>⚠️ 部分(VEP cache)</a:t>
+                        <a:t>✅ Pre&amp;RecNeo</a:t>
                       </a:r>
                       <a:endParaRPr lang="en-US" sz="1250" dirty="0">
                         <a:latin typeface="Microsoft YaHei" charset="0"/>
@@ -7481,7 +8063,7 @@
                       </a:endParaRPr>
                     </a:p>
                   </a:txBody>
-                  <a:tcPr marL="91440" marR="91440" marT="45720" marB="45720" anchor="ctr">
+                  <a:tcPr anchor="ctr">
                     <a:lnL w="12700" cap="flat" cmpd="sng" algn="ctr">
                       <a:solidFill>
                         <a:srgbClr val="D5E3E4"/>
@@ -7523,6 +8105,11 @@
                     </a:solidFill>
                   </a:tcPr>
                 </a:tc>
+                <a:extLst>
+                  <a:ext uri="{0D108BD9-81ED-4DB2-BD59-A6C34878D82A}">
+                    <a16:rowId xmlns:a16="http://schemas.microsoft.com/office/drawing/2014/main" val="10005"/>
+                  </a:ext>
+                </a:extLst>
               </a:tr>
             </a:tbl>
           </a:graphicData>
@@ -7536,8 +8123,8 @@
         </p:nvSpPr>
         <p:spPr>
           <a:xfrm>
-            <a:off x="640080" y="5486400"/>
-            <a:ext cx="10881360" cy="868680"/>
+            <a:off x="640080" y="5440680"/>
+            <a:ext cx="10881360" cy="658368"/>
           </a:xfrm>
           <a:prstGeom prst="rect">
             <a:avLst/>
@@ -7561,8 +8148,8 @@
         </p:nvSpPr>
         <p:spPr>
           <a:xfrm>
-            <a:off x="868680" y="5559552"/>
-            <a:ext cx="10424160" cy="731520"/>
+            <a:off x="868680" y="5486400"/>
+            <a:ext cx="10424160" cy="566928"/>
           </a:xfrm>
           <a:prstGeom prst="rect">
             <a:avLst/>
@@ -7574,14 +8161,14 @@
           <a:bodyPr wrap="square" lIns="0" tIns="0" rIns="0" bIns="0" rtlCol="0" anchor="ctr"/>
           <a:lstStyle/>
           <a:p>
-            <a:pPr indent="0" marL="0">
+            <a:pPr marL="0" indent="0">
               <a:lnSpc>
-                <a:spcPct val="105000"/>
+                <a:spcPct val="102000"/>
               </a:lnSpc>
               <a:buNone/>
             </a:pPr>
             <a:r>
-              <a:rPr lang="en-US" sz="1350" b="1" dirty="0">
+              <a:rPr lang="en-US" sz="1300" b="1" dirty="0">
                 <a:solidFill>
                   <a:srgbClr val="028090"/>
                 </a:solidFill>
@@ -7591,14 +8178,108 @@
               </a:rPr>
               <a:t>结论：</a:t>
             </a:r>
-            <a:pPr indent="0" marL="0">
+            <a:r>
+              <a:rPr lang="en-US" sz="1250" dirty="0">
+                <a:solidFill>
+                  <a:srgbClr val="16323A"/>
+                </a:solidFill>
+                <a:latin typeface="Microsoft YaHei" pitchFamily="34" charset="0"/>
+                <a:ea typeface="Microsoft YaHei" pitchFamily="34" charset="-122"/>
+                <a:cs typeface="Microsoft YaHei" pitchFamily="34" charset="-120"/>
+              </a:rPr>
+              <a:t>5 工具全部部署 / 环境就绪；其中 </a:t>
+            </a:r>
+            <a:r>
+              <a:rPr lang="en-US" sz="1250" b="1" dirty="0">
+                <a:solidFill>
+                  <a:srgbClr val="0B3C49"/>
+                </a:solidFill>
+                <a:latin typeface="Microsoft YaHei" pitchFamily="34" charset="0"/>
+                <a:ea typeface="Microsoft YaHei" pitchFamily="34" charset="-122"/>
+                <a:cs typeface="Microsoft YaHei" pitchFamily="34" charset="-120"/>
+              </a:rPr>
+              <a:t>5 / 5 均产出 ELISpot 真实分数并完成 benchmark</a:t>
+            </a:r>
+            <a:r>
+              <a:rPr lang="en-US" sz="1250" dirty="0">
+                <a:solidFill>
+                  <a:srgbClr val="16323A"/>
+                </a:solidFill>
+                <a:latin typeface="Microsoft YaHei" pitchFamily="34" charset="0"/>
+                <a:ea typeface="Microsoft YaHei" pitchFamily="34" charset="-122"/>
+                <a:cs typeface="Microsoft YaHei" pitchFamily="34" charset="-120"/>
+              </a:rPr>
+              <a:t>。DeepImmuno、PredIG 本地+HPC 双验证完全端到端；pTuneos 本地 docker 端到端 (Pre&amp;RecNeo 子模型跑 ELISpot)；IMPROVE/NeoTImmuML 部分 (缺口明确，非「装不上」)。5 个均输出连续 / 概率分数 → 都支持「强弱定量」。</a:t>
+            </a:r>
+            <a:endParaRPr lang="en-US" sz="1300" dirty="0"/>
+          </a:p>
+        </p:txBody>
+      </p:sp>
+      <p:sp>
+        <p:nvSpPr>
+          <p:cNvPr id="8" name="Shape 5"/>
+          <p:cNvSpPr/>
+          <p:nvPr/>
+        </p:nvSpPr>
+        <p:spPr>
+          <a:xfrm>
+            <a:off x="640080" y="6163056"/>
+            <a:ext cx="10881360" cy="603504"/>
+          </a:xfrm>
+          <a:prstGeom prst="rect">
+            <a:avLst/>
+          </a:prstGeom>
+          <a:solidFill>
+            <a:srgbClr val="FBEEE4"/>
+          </a:solidFill>
+          <a:ln w="12700">
+            <a:solidFill>
+              <a:srgbClr val="C9743D"/>
+            </a:solidFill>
+            <a:prstDash val="solid"/>
+          </a:ln>
+        </p:spPr>
+      </p:sp>
+      <p:sp>
+        <p:nvSpPr>
+          <p:cNvPr id="9" name="Text 6"/>
+          <p:cNvSpPr/>
+          <p:nvPr/>
+        </p:nvSpPr>
+        <p:spPr>
+          <a:xfrm>
+            <a:off x="868680" y="6208776"/>
+            <a:ext cx="10424160" cy="512064"/>
+          </a:xfrm>
+          <a:prstGeom prst="rect">
+            <a:avLst/>
+          </a:prstGeom>
+          <a:noFill/>
+          <a:ln/>
+        </p:spPr>
+        <p:txBody>
+          <a:bodyPr wrap="square" lIns="0" tIns="0" rIns="0" bIns="0" rtlCol="0" anchor="ctr"/>
+          <a:lstStyle/>
+          <a:p>
+            <a:pPr marL="0" indent="0">
               <a:lnSpc>
-                <a:spcPct val="105000"/>
+                <a:spcPct val="100000"/>
               </a:lnSpc>
               <a:buNone/>
             </a:pPr>
             <a:r>
-              <a:rPr lang="en-US" sz="1300" dirty="0">
+              <a:rPr lang="en-US" sz="1100" b="1" dirty="0">
+                <a:solidFill>
+                  <a:srgbClr val="C9743D"/>
+                </a:solidFill>
+                <a:latin typeface="Microsoft YaHei" pitchFamily="34" charset="0"/>
+                <a:ea typeface="Microsoft YaHei" pitchFamily="34" charset="-122"/>
+                <a:cs typeface="Microsoft YaHei" pitchFamily="34" charset="-120"/>
+              </a:rPr>
+              <a:t>「部分完成」= 工具自身限制，非部署失败：</a:t>
+            </a:r>
+            <a:r>
+              <a:rPr lang="en-US" sz="1100" dirty="0">
                 <a:solidFill>
                   <a:srgbClr val="16323A"/>
                 </a:solidFill>
@@ -7606,49 +8287,15 @@
                 <a:ea typeface="Microsoft YaHei" pitchFamily="34" charset="-122"/>
                 <a:cs typeface="Microsoft YaHei" pitchFamily="34" charset="-120"/>
               </a:rPr>
-              <a:t>5 工具全部部署 / 环境就绪；其中 </a:t>
-            </a:r>
-            <a:pPr indent="0" marL="0">
-              <a:lnSpc>
-                <a:spcPct val="105000"/>
-              </a:lnSpc>
-              <a:buNone/>
-            </a:pPr>
-            <a:r>
-              <a:rPr lang="en-US" sz="1300" b="1" dirty="0">
-                <a:solidFill>
-                  <a:srgbClr val="0B3C49"/>
-                </a:solidFill>
-                <a:latin typeface="Microsoft YaHei" pitchFamily="34" charset="0"/>
-                <a:ea typeface="Microsoft YaHei" pitchFamily="34" charset="-122"/>
-                <a:cs typeface="Microsoft YaHei" pitchFamily="34" charset="-120"/>
-              </a:rPr>
-              <a:t>2 个 (DeepImmuno、PredIG) 已完全端到端跑通</a:t>
-            </a:r>
-            <a:pPr indent="0" marL="0">
-              <a:lnSpc>
-                <a:spcPct val="105000"/>
-              </a:lnSpc>
-              <a:buNone/>
-            </a:pPr>
-            <a:r>
-              <a:rPr lang="en-US" sz="1300" dirty="0">
-                <a:solidFill>
-                  <a:srgbClr val="16323A"/>
-                </a:solidFill>
-                <a:latin typeface="Microsoft YaHei" pitchFamily="34" charset="0"/>
-                <a:ea typeface="Microsoft YaHei" pitchFamily="34" charset="-122"/>
-                <a:cs typeface="Microsoft YaHei" pitchFamily="34" charset="-120"/>
-              </a:rPr>
-              <a:t>，本地 + HPC 双验证、数值一致；3 个部分完成 (缺口明确，非「装不上」)。5 个均能输出连续 / 概率分数 → 都支持「强弱定量」。</a:t>
-            </a:r>
-            <a:endParaRPr lang="en-US" sz="1350" dirty="0"/>
-          </a:p>
-        </p:txBody>
-      </p:sp>
-      <p:sp>
-        <p:nvSpPr>
-          <p:cNvPr id="8" name="Text 5"/>
+              <a:t>IMPROVE 缺 ELISpot 没有的 RNA-seq 表达量 → Expression 特征降级、排序精度打折；NeoTImmuML 无官方预训练权重 → 用公开数据自训版 (不对标原论文数值)。两者均能出分、不影响进 benchmark。</a:t>
+            </a:r>
+            <a:endParaRPr lang="en-US" sz="1100" dirty="0"/>
+          </a:p>
+        </p:txBody>
+      </p:sp>
+      <p:sp>
+        <p:nvSpPr>
+          <p:cNvPr id="10" name="Text 7"/>
           <p:cNvSpPr/>
           <p:nvPr/>
         </p:nvSpPr>
@@ -7667,7 +8314,7 @@
           <a:bodyPr wrap="square" lIns="0" tIns="0" rIns="0" bIns="0" rtlCol="0" anchor="ctr"/>
           <a:lstStyle/>
           <a:p>
-            <a:pPr algn="r" indent="0" marL="0">
+            <a:pPr marL="0" indent="0" algn="r">
               <a:buNone/>
             </a:pPr>
             <a:r>
@@ -7701,6 +8348,7 @@
         <a:solidFill>
           <a:srgbClr val="F2F7F7"/>
         </a:solidFill>
+        <a:effectLst/>
       </p:bgPr>
     </p:bg>
     <p:spTree>
@@ -7758,11 +8406,11 @@
           <a:bodyPr wrap="square" lIns="0" tIns="0" rIns="0" bIns="0" rtlCol="0" anchor="ctr"/>
           <a:lstStyle/>
           <a:p>
-            <a:pPr indent="0" marL="0">
+            <a:pPr marL="0" indent="0">
               <a:buNone/>
             </a:pPr>
             <a:r>
-              <a:rPr lang="en-US" sz="1200" b="1" spc="300" kern="0" dirty="0">
+              <a:rPr lang="en-US" sz="1200" b="1" kern="0" spc="300" dirty="0">
                 <a:solidFill>
                   <a:srgbClr val="028090"/>
                 </a:solidFill>
@@ -7797,7 +8445,7 @@
           <a:bodyPr wrap="square" lIns="0" tIns="0" rIns="0" bIns="0" rtlCol="0" anchor="ctr"/>
           <a:lstStyle/>
           <a:p>
-            <a:pPr indent="0" marL="0">
+            <a:pPr marL="0" indent="0">
               <a:buNone/>
             </a:pPr>
             <a:r>
@@ -7836,7 +8484,7 @@
           <a:bodyPr wrap="square" lIns="0" tIns="0" rIns="0" bIns="0" rtlCol="0" anchor="ctr"/>
           <a:lstStyle/>
           <a:p>
-            <a:pPr indent="0" marL="0">
+            <a:pPr marL="0" indent="0">
               <a:buNone/>
             </a:pPr>
             <a:r>
@@ -7897,7 +8545,7 @@
           <a:bodyPr wrap="square" lIns="0" tIns="0" rIns="0" bIns="0" rtlCol="0" anchor="ctr"/>
           <a:lstStyle/>
           <a:p>
-            <a:pPr algn="ctr" indent="0" marL="0">
+            <a:pPr marL="0" indent="0" algn="ctr">
               <a:buNone/>
             </a:pPr>
             <a:r>
@@ -7936,7 +8584,7 @@
           <a:bodyPr wrap="square" lIns="0" tIns="0" rIns="0" bIns="0" rtlCol="0" anchor="ctr"/>
           <a:lstStyle/>
           <a:p>
-            <a:pPr algn="ctr" indent="0" marL="0">
+            <a:pPr marL="0" indent="0" algn="ctr">
               <a:buNone/>
             </a:pPr>
             <a:r>
@@ -7978,7 +8626,7 @@
             <a:prstDash val="solid"/>
           </a:ln>
           <a:effectLst>
-            <a:outerShdw sx="100000" sy="100000" kx="0" ky="0" algn="bl" rotWithShape="0" blurRad="114300" dist="38100" dir="8100000">
+            <a:outerShdw blurRad="114300" dist="38100" dir="8100000" algn="bl" rotWithShape="0">
               <a:srgbClr val="0B3C49">
                 <a:alpha val="12000"/>
               </a:srgbClr>
@@ -8027,7 +8675,7 @@
           <a:bodyPr wrap="square" lIns="0" tIns="0" rIns="0" bIns="0" rtlCol="0" anchor="ctr"/>
           <a:lstStyle/>
           <a:p>
-            <a:pPr indent="0" marL="0">
+            <a:pPr marL="0" indent="0">
               <a:buNone/>
             </a:pPr>
             <a:r>
@@ -8175,7 +8823,7 @@
             <a:prstDash val="solid"/>
           </a:ln>
           <a:effectLst>
-            <a:outerShdw sx="100000" sy="100000" kx="0" ky="0" algn="bl" rotWithShape="0" blurRad="114300" dist="38100" dir="8100000">
+            <a:outerShdw blurRad="114300" dist="38100" dir="8100000" algn="bl" rotWithShape="0">
               <a:srgbClr val="0B3C49">
                 <a:alpha val="12000"/>
               </a:srgbClr>
@@ -8224,7 +8872,7 @@
           <a:bodyPr wrap="square" lIns="0" tIns="0" rIns="0" bIns="0" rtlCol="0" anchor="ctr"/>
           <a:lstStyle/>
           <a:p>
-            <a:pPr indent="0" marL="0">
+            <a:pPr marL="0" indent="0">
               <a:buNone/>
             </a:pPr>
             <a:r>
@@ -8351,7 +8999,7 @@
             <a:prstDash val="solid"/>
           </a:ln>
           <a:effectLst>
-            <a:outerShdw sx="100000" sy="100000" kx="0" ky="0" algn="bl" rotWithShape="0" blurRad="114300" dist="38100" dir="8100000">
+            <a:outerShdw blurRad="114300" dist="38100" dir="8100000" algn="bl" rotWithShape="0">
               <a:srgbClr val="0B3C49">
                 <a:alpha val="12000"/>
               </a:srgbClr>
@@ -8400,7 +9048,7 @@
           <a:bodyPr wrap="square" lIns="0" tIns="0" rIns="0" bIns="0" rtlCol="0" anchor="ctr"/>
           <a:lstStyle/>
           <a:p>
-            <a:pPr indent="0" marL="0">
+            <a:pPr marL="0" indent="0">
               <a:buNone/>
             </a:pPr>
             <a:r>
@@ -8527,7 +9175,7 @@
             <a:prstDash val="solid"/>
           </a:ln>
           <a:effectLst>
-            <a:outerShdw sx="100000" sy="100000" kx="0" ky="0" algn="bl" rotWithShape="0" blurRad="114300" dist="38100" dir="8100000">
+            <a:outerShdw blurRad="114300" dist="38100" dir="8100000" algn="bl" rotWithShape="0">
               <a:srgbClr val="0B3C49">
                 <a:alpha val="12000"/>
               </a:srgbClr>
@@ -8576,7 +9224,7 @@
           <a:bodyPr wrap="square" lIns="0" tIns="0" rIns="0" bIns="0" rtlCol="0" anchor="ctr"/>
           <a:lstStyle/>
           <a:p>
-            <a:pPr indent="0" marL="0">
+            <a:pPr marL="0" indent="0">
               <a:buNone/>
             </a:pPr>
             <a:r>
@@ -8700,7 +9348,7 @@
           <a:bodyPr wrap="square" lIns="0" tIns="0" rIns="0" bIns="0" rtlCol="0" anchor="ctr"/>
           <a:lstStyle/>
           <a:p>
-            <a:pPr algn="r" indent="0" marL="0">
+            <a:pPr marL="0" indent="0" algn="r">
               <a:buNone/>
             </a:pPr>
             <a:r>
@@ -8734,6 +9382,7 @@
         <a:solidFill>
           <a:srgbClr val="F2F7F7"/>
         </a:solidFill>
+        <a:effectLst/>
       </p:bgPr>
     </p:bg>
     <p:spTree>
@@ -8791,11 +9440,11 @@
           <a:bodyPr wrap="square" lIns="0" tIns="0" rIns="0" bIns="0" rtlCol="0" anchor="ctr"/>
           <a:lstStyle/>
           <a:p>
-            <a:pPr indent="0" marL="0">
+            <a:pPr marL="0" indent="0">
               <a:buNone/>
             </a:pPr>
             <a:r>
-              <a:rPr lang="en-US" sz="1200" b="1" spc="300" kern="0" dirty="0">
+              <a:rPr lang="en-US" sz="1200" b="1" kern="0" spc="300" dirty="0">
                 <a:solidFill>
                   <a:srgbClr val="1C7293"/>
                 </a:solidFill>
@@ -8830,7 +9479,7 @@
           <a:bodyPr wrap="square" lIns="0" tIns="0" rIns="0" bIns="0" rtlCol="0" anchor="ctr"/>
           <a:lstStyle/>
           <a:p>
-            <a:pPr indent="0" marL="0">
+            <a:pPr marL="0" indent="0">
               <a:buNone/>
             </a:pPr>
             <a:r>
@@ -8869,7 +9518,7 @@
           <a:bodyPr wrap="square" lIns="0" tIns="0" rIns="0" bIns="0" rtlCol="0" anchor="ctr"/>
           <a:lstStyle/>
           <a:p>
-            <a:pPr indent="0" marL="0">
+            <a:pPr marL="0" indent="0">
               <a:buNone/>
             </a:pPr>
             <a:r>
@@ -8930,7 +9579,7 @@
           <a:bodyPr wrap="square" lIns="0" tIns="0" rIns="0" bIns="0" rtlCol="0" anchor="ctr"/>
           <a:lstStyle/>
           <a:p>
-            <a:pPr algn="ctr" indent="0" marL="0">
+            <a:pPr marL="0" indent="0" algn="ctr">
               <a:buNone/>
             </a:pPr>
             <a:r>
@@ -8969,7 +9618,7 @@
           <a:bodyPr wrap="square" lIns="0" tIns="0" rIns="0" bIns="0" rtlCol="0" anchor="ctr"/>
           <a:lstStyle/>
           <a:p>
-            <a:pPr algn="ctr" indent="0" marL="0">
+            <a:pPr marL="0" indent="0" algn="ctr">
               <a:buNone/>
             </a:pPr>
             <a:r>
@@ -9011,7 +9660,7 @@
             <a:prstDash val="solid"/>
           </a:ln>
           <a:effectLst>
-            <a:outerShdw sx="100000" sy="100000" kx="0" ky="0" algn="bl" rotWithShape="0" blurRad="114300" dist="38100" dir="8100000">
+            <a:outerShdw blurRad="114300" dist="38100" dir="8100000" algn="bl" rotWithShape="0">
               <a:srgbClr val="0B3C49">
                 <a:alpha val="12000"/>
               </a:srgbClr>
@@ -9060,7 +9709,7 @@
           <a:bodyPr wrap="square" lIns="0" tIns="0" rIns="0" bIns="0" rtlCol="0" anchor="ctr"/>
           <a:lstStyle/>
           <a:p>
-            <a:pPr indent="0" marL="0">
+            <a:pPr marL="0" indent="0">
               <a:buNone/>
             </a:pPr>
             <a:r>
@@ -9187,7 +9836,7 @@
             <a:prstDash val="solid"/>
           </a:ln>
           <a:effectLst>
-            <a:outerShdw sx="100000" sy="100000" kx="0" ky="0" algn="bl" rotWithShape="0" blurRad="114300" dist="38100" dir="8100000">
+            <a:outerShdw blurRad="114300" dist="38100" dir="8100000" algn="bl" rotWithShape="0">
               <a:srgbClr val="0B3C49">
                 <a:alpha val="12000"/>
               </a:srgbClr>
@@ -9236,7 +9885,7 @@
           <a:bodyPr wrap="square" lIns="0" tIns="0" rIns="0" bIns="0" rtlCol="0" anchor="ctr"/>
           <a:lstStyle/>
           <a:p>
-            <a:pPr indent="0" marL="0">
+            <a:pPr marL="0" indent="0">
               <a:buNone/>
             </a:pPr>
             <a:r>
@@ -9363,7 +10012,7 @@
             <a:prstDash val="solid"/>
           </a:ln>
           <a:effectLst>
-            <a:outerShdw sx="100000" sy="100000" kx="0" ky="0" algn="bl" rotWithShape="0" blurRad="114300" dist="38100" dir="8100000">
+            <a:outerShdw blurRad="114300" dist="38100" dir="8100000" algn="bl" rotWithShape="0">
               <a:srgbClr val="0B3C49">
                 <a:alpha val="12000"/>
               </a:srgbClr>
@@ -9412,7 +10061,7 @@
           <a:bodyPr wrap="square" lIns="0" tIns="0" rIns="0" bIns="0" rtlCol="0" anchor="ctr"/>
           <a:lstStyle/>
           <a:p>
-            <a:pPr indent="0" marL="0">
+            <a:pPr marL="0" indent="0">
               <a:buNone/>
             </a:pPr>
             <a:r>
@@ -9539,7 +10188,7 @@
             <a:prstDash val="solid"/>
           </a:ln>
           <a:effectLst>
-            <a:outerShdw sx="100000" sy="100000" kx="0" ky="0" algn="bl" rotWithShape="0" blurRad="114300" dist="38100" dir="8100000">
+            <a:outerShdw blurRad="114300" dist="38100" dir="8100000" algn="bl" rotWithShape="0">
               <a:srgbClr val="0B3C49">
                 <a:alpha val="12000"/>
               </a:srgbClr>
@@ -9588,7 +10237,7 @@
           <a:bodyPr wrap="square" lIns="0" tIns="0" rIns="0" bIns="0" rtlCol="0" anchor="ctr"/>
           <a:lstStyle/>
           <a:p>
-            <a:pPr indent="0" marL="0">
+            <a:pPr marL="0" indent="0">
               <a:buNone/>
             </a:pPr>
             <a:r>
@@ -9712,7 +10361,7 @@
           <a:bodyPr wrap="square" lIns="0" tIns="0" rIns="0" bIns="0" rtlCol="0" anchor="ctr"/>
           <a:lstStyle/>
           <a:p>
-            <a:pPr algn="r" indent="0" marL="0">
+            <a:pPr marL="0" indent="0" algn="r">
               <a:buNone/>
             </a:pPr>
             <a:r>
@@ -9746,6 +10395,7 @@
         <a:solidFill>
           <a:srgbClr val="F2F7F7"/>
         </a:solidFill>
+        <a:effectLst/>
       </p:bgPr>
     </p:bg>
     <p:spTree>
@@ -9803,11 +10453,11 @@
           <a:bodyPr wrap="square" lIns="0" tIns="0" rIns="0" bIns="0" rtlCol="0" anchor="ctr"/>
           <a:lstStyle/>
           <a:p>
-            <a:pPr indent="0" marL="0">
+            <a:pPr marL="0" indent="0">
               <a:buNone/>
             </a:pPr>
             <a:r>
-              <a:rPr lang="en-US" sz="1200" b="1" spc="300" kern="0" dirty="0">
+              <a:rPr lang="en-US" sz="1200" b="1" kern="0" spc="300" dirty="0">
                 <a:solidFill>
                   <a:srgbClr val="028090"/>
                 </a:solidFill>
@@ -9842,7 +10492,7 @@
           <a:bodyPr wrap="square" lIns="0" tIns="0" rIns="0" bIns="0" rtlCol="0" anchor="ctr"/>
           <a:lstStyle/>
           <a:p>
-            <a:pPr indent="0" marL="0">
+            <a:pPr marL="0" indent="0">
               <a:buNone/>
             </a:pPr>
             <a:r>
@@ -9881,7 +10531,7 @@
           <a:bodyPr wrap="square" lIns="0" tIns="0" rIns="0" bIns="0" rtlCol="0" anchor="ctr"/>
           <a:lstStyle/>
           <a:p>
-            <a:pPr indent="0" marL="0">
+            <a:pPr marL="0" indent="0">
               <a:buNone/>
             </a:pPr>
             <a:r>
@@ -9942,7 +10592,7 @@
           <a:bodyPr wrap="square" lIns="0" tIns="0" rIns="0" bIns="0" rtlCol="0" anchor="ctr"/>
           <a:lstStyle/>
           <a:p>
-            <a:pPr algn="ctr" indent="0" marL="0">
+            <a:pPr marL="0" indent="0" algn="ctr">
               <a:buNone/>
             </a:pPr>
             <a:r>
@@ -9981,7 +10631,7 @@
           <a:bodyPr wrap="square" lIns="0" tIns="0" rIns="0" bIns="0" rtlCol="0" anchor="ctr"/>
           <a:lstStyle/>
           <a:p>
-            <a:pPr algn="ctr" indent="0" marL="0">
+            <a:pPr marL="0" indent="0" algn="ctr">
               <a:buNone/>
             </a:pPr>
             <a:r>
@@ -10023,7 +10673,7 @@
             <a:prstDash val="solid"/>
           </a:ln>
           <a:effectLst>
-            <a:outerShdw sx="100000" sy="100000" kx="0" ky="0" algn="bl" rotWithShape="0" blurRad="114300" dist="38100" dir="8100000">
+            <a:outerShdw blurRad="114300" dist="38100" dir="8100000" algn="bl" rotWithShape="0">
               <a:srgbClr val="0B3C49">
                 <a:alpha val="12000"/>
               </a:srgbClr>
@@ -10072,7 +10722,7 @@
           <a:bodyPr wrap="square" lIns="0" tIns="0" rIns="0" bIns="0" rtlCol="0" anchor="ctr"/>
           <a:lstStyle/>
           <a:p>
-            <a:pPr indent="0" marL="0">
+            <a:pPr marL="0" indent="0">
               <a:buNone/>
             </a:pPr>
             <a:r>
@@ -10199,7 +10849,7 @@
             <a:prstDash val="solid"/>
           </a:ln>
           <a:effectLst>
-            <a:outerShdw sx="100000" sy="100000" kx="0" ky="0" algn="bl" rotWithShape="0" blurRad="114300" dist="38100" dir="8100000">
+            <a:outerShdw blurRad="114300" dist="38100" dir="8100000" algn="bl" rotWithShape="0">
               <a:srgbClr val="0B3C49">
                 <a:alpha val="12000"/>
               </a:srgbClr>
@@ -10248,7 +10898,7 @@
           <a:bodyPr wrap="square" lIns="0" tIns="0" rIns="0" bIns="0" rtlCol="0" anchor="ctr"/>
           <a:lstStyle/>
           <a:p>
-            <a:pPr indent="0" marL="0">
+            <a:pPr marL="0" indent="0">
               <a:buNone/>
             </a:pPr>
             <a:r>
@@ -10354,7 +11004,7 @@
             <a:prstDash val="solid"/>
           </a:ln>
           <a:effectLst>
-            <a:outerShdw sx="100000" sy="100000" kx="0" ky="0" algn="bl" rotWithShape="0" blurRad="114300" dist="38100" dir="8100000">
+            <a:outerShdw blurRad="114300" dist="38100" dir="8100000" algn="bl" rotWithShape="0">
               <a:srgbClr val="0B3C49">
                 <a:alpha val="12000"/>
               </a:srgbClr>
@@ -10403,7 +11053,7 @@
           <a:bodyPr wrap="square" lIns="0" tIns="0" rIns="0" bIns="0" rtlCol="0" anchor="ctr"/>
           <a:lstStyle/>
           <a:p>
-            <a:pPr indent="0" marL="0">
+            <a:pPr marL="0" indent="0">
               <a:buNone/>
             </a:pPr>
             <a:r>
@@ -10530,7 +11180,7 @@
             <a:prstDash val="solid"/>
           </a:ln>
           <a:effectLst>
-            <a:outerShdw sx="100000" sy="100000" kx="0" ky="0" algn="bl" rotWithShape="0" blurRad="114300" dist="38100" dir="8100000">
+            <a:outerShdw blurRad="114300" dist="38100" dir="8100000" algn="bl" rotWithShape="0">
               <a:srgbClr val="0B3C49">
                 <a:alpha val="12000"/>
               </a:srgbClr>
@@ -10579,7 +11229,7 @@
           <a:bodyPr wrap="square" lIns="0" tIns="0" rIns="0" bIns="0" rtlCol="0" anchor="ctr"/>
           <a:lstStyle/>
           <a:p>
-            <a:pPr indent="0" marL="0">
+            <a:pPr marL="0" indent="0">
               <a:buNone/>
             </a:pPr>
             <a:r>
@@ -10703,7 +11353,7 @@
           <a:bodyPr wrap="square" lIns="0" tIns="0" rIns="0" bIns="0" rtlCol="0" anchor="ctr"/>
           <a:lstStyle/>
           <a:p>
-            <a:pPr algn="r" indent="0" marL="0">
+            <a:pPr marL="0" indent="0" algn="r">
               <a:buNone/>
             </a:pPr>
             <a:r>
@@ -10737,6 +11387,7 @@
         <a:solidFill>
           <a:srgbClr val="F2F7F7"/>
         </a:solidFill>
+        <a:effectLst/>
       </p:bgPr>
     </p:bg>
     <p:spTree>
@@ -10794,11 +11445,11 @@
           <a:bodyPr wrap="square" lIns="0" tIns="0" rIns="0" bIns="0" rtlCol="0" anchor="ctr"/>
           <a:lstStyle/>
           <a:p>
-            <a:pPr indent="0" marL="0">
+            <a:pPr marL="0" indent="0">
               <a:buNone/>
             </a:pPr>
             <a:r>
-              <a:rPr lang="en-US" sz="1200" b="1" spc="300" kern="0" dirty="0">
+              <a:rPr lang="en-US" sz="1200" b="1" kern="0" spc="300" dirty="0">
                 <a:solidFill>
                   <a:srgbClr val="1C7293"/>
                 </a:solidFill>
@@ -10833,7 +11484,7 @@
           <a:bodyPr wrap="square" lIns="0" tIns="0" rIns="0" bIns="0" rtlCol="0" anchor="ctr"/>
           <a:lstStyle/>
           <a:p>
-            <a:pPr indent="0" marL="0">
+            <a:pPr marL="0" indent="0">
               <a:buNone/>
             </a:pPr>
             <a:r>
@@ -10872,7 +11523,7 @@
           <a:bodyPr wrap="square" lIns="0" tIns="0" rIns="0" bIns="0" rtlCol="0" anchor="ctr"/>
           <a:lstStyle/>
           <a:p>
-            <a:pPr indent="0" marL="0">
+            <a:pPr marL="0" indent="0">
               <a:buNone/>
             </a:pPr>
             <a:r>
@@ -10933,7 +11584,7 @@
           <a:bodyPr wrap="square" lIns="0" tIns="0" rIns="0" bIns="0" rtlCol="0" anchor="ctr"/>
           <a:lstStyle/>
           <a:p>
-            <a:pPr algn="ctr" indent="0" marL="0">
+            <a:pPr marL="0" indent="0" algn="ctr">
               <a:buNone/>
             </a:pPr>
             <a:r>
@@ -10972,7 +11623,7 @@
           <a:bodyPr wrap="square" lIns="0" tIns="0" rIns="0" bIns="0" rtlCol="0" anchor="ctr"/>
           <a:lstStyle/>
           <a:p>
-            <a:pPr algn="ctr" indent="0" marL="0">
+            <a:pPr marL="0" indent="0" algn="ctr">
               <a:buNone/>
             </a:pPr>
             <a:r>
@@ -11014,7 +11665,7 @@
             <a:prstDash val="solid"/>
           </a:ln>
           <a:effectLst>
-            <a:outerShdw sx="100000" sy="100000" kx="0" ky="0" algn="bl" rotWithShape="0" blurRad="114300" dist="38100" dir="8100000">
+            <a:outerShdw blurRad="114300" dist="38100" dir="8100000" algn="bl" rotWithShape="0">
               <a:srgbClr val="0B3C49">
                 <a:alpha val="12000"/>
               </a:srgbClr>
@@ -11063,7 +11714,7 @@
           <a:bodyPr wrap="square" lIns="0" tIns="0" rIns="0" bIns="0" rtlCol="0" anchor="ctr"/>
           <a:lstStyle/>
           <a:p>
-            <a:pPr indent="0" marL="0">
+            <a:pPr marL="0" indent="0">
               <a:buNone/>
             </a:pPr>
             <a:r>
@@ -11190,7 +11841,7 @@
             <a:prstDash val="solid"/>
           </a:ln>
           <a:effectLst>
-            <a:outerShdw sx="100000" sy="100000" kx="0" ky="0" algn="bl" rotWithShape="0" blurRad="114300" dist="38100" dir="8100000">
+            <a:outerShdw blurRad="114300" dist="38100" dir="8100000" algn="bl" rotWithShape="0">
               <a:srgbClr val="0B3C49">
                 <a:alpha val="12000"/>
               </a:srgbClr>
@@ -11239,7 +11890,7 @@
           <a:bodyPr wrap="square" lIns="0" tIns="0" rIns="0" bIns="0" rtlCol="0" anchor="ctr"/>
           <a:lstStyle/>
           <a:p>
-            <a:pPr indent="0" marL="0">
+            <a:pPr marL="0" indent="0">
               <a:buNone/>
             </a:pPr>
             <a:r>
@@ -11345,7 +11996,7 @@
             <a:prstDash val="solid"/>
           </a:ln>
           <a:effectLst>
-            <a:outerShdw sx="100000" sy="100000" kx="0" ky="0" algn="bl" rotWithShape="0" blurRad="114300" dist="38100" dir="8100000">
+            <a:outerShdw blurRad="114300" dist="38100" dir="8100000" algn="bl" rotWithShape="0">
               <a:srgbClr val="0B3C49">
                 <a:alpha val="12000"/>
               </a:srgbClr>
@@ -11394,7 +12045,7 @@
           <a:bodyPr wrap="square" lIns="0" tIns="0" rIns="0" bIns="0" rtlCol="0" anchor="ctr"/>
           <a:lstStyle/>
           <a:p>
-            <a:pPr indent="0" marL="0">
+            <a:pPr marL="0" indent="0">
               <a:buNone/>
             </a:pPr>
             <a:r>
@@ -11521,7 +12172,7 @@
             <a:prstDash val="solid"/>
           </a:ln>
           <a:effectLst>
-            <a:outerShdw sx="100000" sy="100000" kx="0" ky="0" algn="bl" rotWithShape="0" blurRad="114300" dist="38100" dir="8100000">
+            <a:outerShdw blurRad="114300" dist="38100" dir="8100000" algn="bl" rotWithShape="0">
               <a:srgbClr val="0B3C49">
                 <a:alpha val="12000"/>
               </a:srgbClr>
@@ -11570,7 +12221,7 @@
           <a:bodyPr wrap="square" lIns="0" tIns="0" rIns="0" bIns="0" rtlCol="0" anchor="ctr"/>
           <a:lstStyle/>
           <a:p>
-            <a:pPr indent="0" marL="0">
+            <a:pPr marL="0" indent="0">
               <a:buNone/>
             </a:pPr>
             <a:r>
@@ -11694,7 +12345,7 @@
           <a:bodyPr wrap="square" lIns="0" tIns="0" rIns="0" bIns="0" rtlCol="0" anchor="ctr"/>
           <a:lstStyle/>
           <a:p>
-            <a:pPr algn="r" indent="0" marL="0">
+            <a:pPr marL="0" indent="0" algn="r">
               <a:buNone/>
             </a:pPr>
             <a:r>
@@ -11728,6 +12379,7 @@
         <a:solidFill>
           <a:srgbClr val="F2F7F7"/>
         </a:solidFill>
+        <a:effectLst/>
       </p:bgPr>
     </p:bg>
     <p:spTree>
@@ -11785,11 +12437,11 @@
           <a:bodyPr wrap="square" lIns="0" tIns="0" rIns="0" bIns="0" rtlCol="0" anchor="ctr"/>
           <a:lstStyle/>
           <a:p>
-            <a:pPr indent="0" marL="0">
+            <a:pPr marL="0" indent="0">
               <a:buNone/>
             </a:pPr>
             <a:r>
-              <a:rPr lang="en-US" sz="1200" b="1" spc="300" kern="0" dirty="0">
+              <a:rPr lang="en-US" sz="1200" b="1" kern="0" spc="300" dirty="0">
                 <a:solidFill>
                   <a:srgbClr val="028090"/>
                 </a:solidFill>
@@ -11824,7 +12476,7 @@
           <a:bodyPr wrap="square" lIns="0" tIns="0" rIns="0" bIns="0" rtlCol="0" anchor="ctr"/>
           <a:lstStyle/>
           <a:p>
-            <a:pPr indent="0" marL="0">
+            <a:pPr marL="0" indent="0">
               <a:buNone/>
             </a:pPr>
             <a:r>
@@ -11863,7 +12515,7 @@
           <a:bodyPr wrap="square" lIns="0" tIns="0" rIns="0" bIns="0" rtlCol="0" anchor="ctr"/>
           <a:lstStyle/>
           <a:p>
-            <a:pPr indent="0" marL="0">
+            <a:pPr marL="0" indent="0">
               <a:buNone/>
             </a:pPr>
             <a:r>
@@ -11875,7 +12527,7 @@
                 <a:ea typeface="Microsoft YaHei" pitchFamily="34" charset="-122"/>
                 <a:cs typeface="Microsoft YaHei" pitchFamily="34" charset="-120"/>
               </a:rPr>
-              <a:t>个性化新抗原全流程 pipeline (WES/RNA-seq 或 VCF → 排名)，非单一评分工具</a:t>
+              <a:t>个性化新抗原全流程 pipeline (WES/RNA-seq 或 VCF → 排名)；识别子模型可单独跑肽段</a:t>
             </a:r>
             <a:endParaRPr lang="en-US" sz="1300" dirty="0"/>
           </a:p>
@@ -11898,7 +12550,7 @@
             </a:avLst>
           </a:prstGeom>
           <a:solidFill>
-            <a:srgbClr val="C9743D"/>
+            <a:srgbClr val="00A896"/>
           </a:solidFill>
           <a:ln/>
         </p:spPr>
@@ -11924,7 +12576,7 @@
           <a:bodyPr wrap="square" lIns="0" tIns="0" rIns="0" bIns="0" rtlCol="0" anchor="ctr"/>
           <a:lstStyle/>
           <a:p>
-            <a:pPr algn="ctr" indent="0" marL="0">
+            <a:pPr marL="0" indent="0" algn="ctr">
               <a:buNone/>
             </a:pPr>
             <a:r>
@@ -11936,7 +12588,7 @@
                 <a:ea typeface="Microsoft YaHei" pitchFamily="34" charset="-122"/>
                 <a:cs typeface="Microsoft YaHei" pitchFamily="34" charset="-120"/>
               </a:rPr>
-              <a:t>⚠️ 部分完成</a:t>
+              <a:t>✅ 端到端跑通</a:t>
             </a:r>
             <a:endParaRPr lang="en-US" sz="1200" dirty="0"/>
           </a:p>
@@ -11963,7 +12615,7 @@
           <a:bodyPr wrap="square" lIns="0" tIns="0" rIns="0" bIns="0" rtlCol="0" anchor="ctr"/>
           <a:lstStyle/>
           <a:p>
-            <a:pPr algn="ctr" indent="0" marL="0">
+            <a:pPr marL="0" indent="0" algn="ctr">
               <a:buNone/>
             </a:pPr>
             <a:r>
@@ -12005,7 +12657,7 @@
             <a:prstDash val="solid"/>
           </a:ln>
           <a:effectLst>
-            <a:outerShdw sx="100000" sy="100000" kx="0" ky="0" algn="bl" rotWithShape="0" blurRad="114300" dist="38100" dir="8100000">
+            <a:outerShdw blurRad="114300" dist="38100" dir="8100000" algn="bl" rotWithShape="0">
               <a:srgbClr val="0B3C49">
                 <a:alpha val="12000"/>
               </a:srgbClr>
@@ -12054,7 +12706,7 @@
           <a:bodyPr wrap="square" lIns="0" tIns="0" rIns="0" bIns="0" rtlCol="0" anchor="ctr"/>
           <a:lstStyle/>
           <a:p>
-            <a:pPr indent="0" marL="0">
+            <a:pPr marL="0" indent="0">
               <a:buNone/>
             </a:pPr>
             <a:r>
@@ -12109,7 +12761,7 @@
                 <a:ea typeface="Microsoft YaHei" pitchFamily="34" charset="-122"/>
                 <a:cs typeface="Microsoft YaHei" pitchFamily="34" charset="-120"/>
               </a:rPr>
-              <a:t>WES 模式：FASTQ + RNA-seq  或  VCF 模式：VCF+表达+拷贝数+纯度</a:t>
+              <a:t>完整 pipeline：VCF + 表达谱 + 拷贝数 + 纯度 + HLA (需全基因组，吃不了纯肽)</a:t>
             </a:r>
             <a:endParaRPr lang="en-US" sz="1150" dirty="0"/>
           </a:p>
@@ -12130,7 +12782,7 @@
                 <a:ea typeface="Microsoft YaHei" pitchFamily="34" charset="-122"/>
                 <a:cs typeface="Microsoft YaHei" pitchFamily="34" charset="-120"/>
               </a:rPr>
-              <a:t>不接受单纯肽段 CSV，需配套患者基因组数据</a:t>
+              <a:t>⭐ Pre&amp;RecNeo 子模型：仅 MT_pep + WT_pep + HLA 三列 (可跑 ELISpot 肽)</a:t>
             </a:r>
             <a:endParaRPr lang="en-US" sz="1150" dirty="0"/>
           </a:p>
@@ -12160,7 +12812,7 @@
             <a:prstDash val="solid"/>
           </a:ln>
           <a:effectLst>
-            <a:outerShdw sx="100000" sy="100000" kx="0" ky="0" algn="bl" rotWithShape="0" blurRad="114300" dist="38100" dir="8100000">
+            <a:outerShdw blurRad="114300" dist="38100" dir="8100000" algn="bl" rotWithShape="0">
               <a:srgbClr val="0B3C49">
                 <a:alpha val="12000"/>
               </a:srgbClr>
@@ -12209,7 +12861,7 @@
           <a:bodyPr wrap="square" lIns="0" tIns="0" rIns="0" bIns="0" rtlCol="0" anchor="ctr"/>
           <a:lstStyle/>
           <a:p>
-            <a:pPr indent="0" marL="0">
+            <a:pPr marL="0" indent="0">
               <a:buNone/>
             </a:pPr>
             <a:r>
@@ -12264,7 +12916,7 @@
                 <a:ea typeface="Microsoft YaHei" pitchFamily="34" charset="-122"/>
                 <a:cs typeface="Microsoft YaHei" pitchFamily="34" charset="-120"/>
               </a:rPr>
-              <a:t>python pTuneos.py {WES | VCF} -i config.yaml</a:t>
+              <a:t>完整：python pTuneos.py {WES|VCF} -i config.yaml</a:t>
             </a:r>
             <a:endParaRPr lang="en-US" sz="1150" dirty="0"/>
           </a:p>
@@ -12285,7 +12937,28 @@
                 <a:ea typeface="Microsoft YaHei" pitchFamily="34" charset="-122"/>
                 <a:cs typeface="Microsoft YaHei" pitchFamily="34" charset="-120"/>
               </a:rPr>
-              <a:t>YAML 配各模块参数路径</a:t>
+              <a:t>Pre&amp;RecNeo：自写 wrapper 调 InVivoModelAndScore</a:t>
+            </a:r>
+            <a:endParaRPr lang="en-US" sz="1150" dirty="0"/>
+          </a:p>
+          <a:p>
+            <a:pPr marL="152400" indent="-152400">
+              <a:spcAft>
+                <a:spcPts val="500"/>
+              </a:spcAft>
+              <a:buSzPct val="100000"/>
+              <a:buChar char="•"/>
+            </a:pPr>
+            <a:r>
+              <a:rPr lang="en-US" sz="1150" dirty="0">
+                <a:solidFill>
+                  <a:srgbClr val="16323A"/>
+                </a:solidFill>
+                <a:latin typeface="Microsoft YaHei" pitchFamily="34" charset="0"/>
+                <a:ea typeface="Microsoft YaHei" pitchFamily="34" charset="-122"/>
+                <a:cs typeface="Microsoft YaHei" pitchFamily="34" charset="-120"/>
+              </a:rPr>
+              <a:t>批 netMHCpan/blastp 加速 + nproc 并行</a:t>
             </a:r>
             <a:endParaRPr lang="en-US" sz="1150" dirty="0"/>
           </a:p>
@@ -12315,7 +12988,7 @@
             <a:prstDash val="solid"/>
           </a:ln>
           <a:effectLst>
-            <a:outerShdw sx="100000" sy="100000" kx="0" ky="0" algn="bl" rotWithShape="0" blurRad="114300" dist="38100" dir="8100000">
+            <a:outerShdw blurRad="114300" dist="38100" dir="8100000" algn="bl" rotWithShape="0">
               <a:srgbClr val="0B3C49">
                 <a:alpha val="12000"/>
               </a:srgbClr>
@@ -12364,7 +13037,7 @@
           <a:bodyPr wrap="square" lIns="0" tIns="0" rIns="0" bIns="0" rtlCol="0" anchor="ctr"/>
           <a:lstStyle/>
           <a:p>
-            <a:pPr indent="0" marL="0">
+            <a:pPr marL="0" indent="0">
               <a:buNone/>
             </a:pPr>
             <a:r>
@@ -12419,7 +13092,7 @@
                 <a:ea typeface="Microsoft YaHei" pitchFamily="34" charset="-122"/>
                 <a:cs typeface="Microsoft YaHei" pitchFamily="34" charset="-120"/>
               </a:rPr>
-              <a:t>Pre&amp;RecNeo = T 细胞识别概率 (0-1)</a:t>
+              <a:t>RefinedNeo = 患者级排名分 (乘表达/VAF/克隆性，需测序)</a:t>
             </a:r>
             <a:endParaRPr lang="en-US" sz="1150" dirty="0"/>
           </a:p>
@@ -12440,7 +13113,7 @@
                 <a:ea typeface="Microsoft YaHei" pitchFamily="34" charset="-122"/>
                 <a:cs typeface="Microsoft YaHei" pitchFamily="34" charset="-120"/>
               </a:rPr>
-              <a:t>RefinedNeo = 连续综合排名分 (整合表达/加工/自身相似/识别)</a:t>
+              <a:t>Pre&amp;RecNeo (model_pro) = 纯肽免疫原性识别分 → 与其他 4 工具可比</a:t>
             </a:r>
             <a:endParaRPr lang="en-US" sz="1150" dirty="0"/>
           </a:p>
@@ -12461,7 +13134,7 @@
                 <a:ea typeface="Microsoft YaHei" pitchFamily="34" charset="-122"/>
                 <a:cs typeface="Microsoft YaHei" pitchFamily="34" charset="-120"/>
               </a:rPr>
-              <a:t>患者级：所有 RefinedNeo 之和 = 总体免疫原性</a:t>
+              <a:t>example VCF 出 40 新抗原 (RefinedNeo 0.42–1.13)</a:t>
             </a:r>
             <a:endParaRPr lang="en-US" sz="1150" dirty="0"/>
           </a:p>
@@ -12491,7 +13164,7 @@
             <a:prstDash val="solid"/>
           </a:ln>
           <a:effectLst>
-            <a:outerShdw sx="100000" sy="100000" kx="0" ky="0" algn="bl" rotWithShape="0" blurRad="114300" dist="38100" dir="8100000">
+            <a:outerShdw blurRad="114300" dist="38100" dir="8100000" algn="bl" rotWithShape="0">
               <a:srgbClr val="0B3C49">
                 <a:alpha val="12000"/>
               </a:srgbClr>
@@ -12540,7 +13213,7 @@
           <a:bodyPr wrap="square" lIns="0" tIns="0" rIns="0" bIns="0" rtlCol="0" anchor="ctr"/>
           <a:lstStyle/>
           <a:p>
-            <a:pPr indent="0" marL="0">
+            <a:pPr marL="0" indent="0">
               <a:buNone/>
             </a:pPr>
             <a:r>
@@ -12595,7 +13268,7 @@
                 <a:ea typeface="Microsoft YaHei" pitchFamily="34" charset="-122"/>
                 <a:cs typeface="Microsoft YaHei" pitchFamily="34" charset="-120"/>
               </a:rPr>
-              <a:t>端到端 pipeline，镜像自带 netMHCpan-4.0 / VEP / GATK / BWA 全套</a:t>
+              <a:t>镜像自带 netMHCpan-4.0 / VEP / GATK / BWA 全套；修 8 坑 + VEP cache 14G 端到端跑通</a:t>
             </a:r>
             <a:endParaRPr lang="en-US" sz="1150" dirty="0"/>
           </a:p>
@@ -12616,7 +13289,7 @@
                 <a:ea typeface="Microsoft YaHei" pitchFamily="34" charset="-122"/>
                 <a:cs typeface="Microsoft YaHei" pitchFamily="34" charset="-120"/>
               </a:rPr>
-              <a:t>部署难度最高：Python2.7 老链 + 需全基因组</a:t>
+              <a:t>Pre&amp;RecNeo 跑 ELISpot 32178 肽对 → 进 5 工具 benchmark (对账官方 r=1.0)</a:t>
             </a:r>
             <a:endParaRPr lang="en-US" sz="1150" dirty="0"/>
           </a:p>
@@ -12637,7 +13310,7 @@
                 <a:ea typeface="Microsoft YaHei" pitchFamily="34" charset="-122"/>
                 <a:cs typeface="Microsoft YaHei" pitchFamily="34" charset="-120"/>
               </a:rPr>
-              <a:t>⚠️ 停在 VEP cache (~15-25G)；架构喂不了纯肽 ELISpot</a:t>
+              <a:t>⚠️ 诚实：本地 docker 跑 (HPC sif 受限 singularity 非 root)；疏水模型仅 9/10/11mer</a:t>
             </a:r>
             <a:endParaRPr lang="en-US" sz="1150" dirty="0"/>
           </a:p>
@@ -12664,7 +13337,7 @@
           <a:bodyPr wrap="square" lIns="0" tIns="0" rIns="0" bIns="0" rtlCol="0" anchor="ctr"/>
           <a:lstStyle/>
           <a:p>
-            <a:pPr algn="r" indent="0" marL="0">
+            <a:pPr marL="0" indent="0" algn="r">
               <a:buNone/>
             </a:pPr>
             <a:r>
@@ -12698,6 +13371,7 @@
         <a:solidFill>
           <a:srgbClr val="F2F7F7"/>
         </a:solidFill>
+        <a:effectLst/>
       </p:bgPr>
     </p:bg>
     <p:spTree>
@@ -12755,11 +13429,11 @@
           <a:bodyPr wrap="square" lIns="0" tIns="0" rIns="0" bIns="0" rtlCol="0" anchor="ctr"/>
           <a:lstStyle/>
           <a:p>
-            <a:pPr indent="0" marL="0">
+            <a:pPr marL="0" indent="0">
               <a:buNone/>
             </a:pPr>
             <a:r>
-              <a:rPr lang="en-US" sz="1200" b="1" spc="300" kern="0" dirty="0">
+              <a:rPr lang="en-US" sz="1200" b="1" kern="0" spc="300" dirty="0">
                 <a:solidFill>
                   <a:srgbClr val="028090"/>
                 </a:solidFill>
@@ -12794,7 +13468,7 @@
           <a:bodyPr wrap="square" lIns="0" tIns="0" rIns="0" bIns="0" rtlCol="0" anchor="ctr"/>
           <a:lstStyle/>
           <a:p>
-            <a:pPr indent="0" marL="0">
+            <a:pPr marL="0" indent="0">
               <a:buNone/>
             </a:pPr>
             <a:r>
@@ -12831,7 +13505,7 @@
           </a:solidFill>
           <a:ln/>
           <a:effectLst>
-            <a:outerShdw sx="100000" sy="100000" kx="0" ky="0" algn="bl" rotWithShape="0" blurRad="114300" dist="38100" dir="8100000">
+            <a:outerShdw blurRad="114300" dist="38100" dir="8100000" algn="bl" rotWithShape="0">
               <a:srgbClr val="0B3C49">
                 <a:alpha val="12000"/>
               </a:srgbClr>
@@ -12860,7 +13534,7 @@
           <a:bodyPr wrap="square" lIns="0" tIns="0" rIns="0" bIns="0" rtlCol="0" anchor="ctr"/>
           <a:lstStyle/>
           <a:p>
-            <a:pPr indent="0" marL="0">
+            <a:pPr marL="0" indent="0">
               <a:buNone/>
             </a:pPr>
             <a:r>
@@ -12899,7 +13573,7 @@
           <a:bodyPr wrap="square" lIns="0" tIns="0" rIns="0" bIns="0" rtlCol="0" anchor="t"/>
           <a:lstStyle/>
           <a:p>
-            <a:pPr indent="0" marL="0">
+            <a:pPr marL="0" indent="0">
               <a:buNone/>
             </a:pPr>
             <a:r>
@@ -12916,7 +13590,7 @@
             <a:endParaRPr lang="en-US" sz="1350" dirty="0"/>
           </a:p>
           <a:p>
-            <a:pPr indent="0" marL="0">
+            <a:pPr marL="0" indent="0">
               <a:spcAft>
                 <a:spcPts val="1000"/>
               </a:spcAft>
@@ -12936,7 +13610,7 @@
             <a:endParaRPr lang="en-US" sz="1350" dirty="0"/>
           </a:p>
           <a:p>
-            <a:pPr indent="0" marL="0">
+            <a:pPr marL="0" indent="0">
               <a:buNone/>
             </a:pPr>
             <a:r>
@@ -12953,7 +13627,7 @@
             <a:endParaRPr lang="en-US" sz="1350" dirty="0"/>
           </a:p>
           <a:p>
-            <a:pPr indent="0" marL="0">
+            <a:pPr marL="0" indent="0">
               <a:buNone/>
             </a:pPr>
             <a:r>
@@ -12970,7 +13644,7 @@
             <a:endParaRPr lang="en-US" sz="1350" dirty="0"/>
           </a:p>
           <a:p>
-            <a:pPr indent="0" marL="0">
+            <a:pPr marL="0" indent="0">
               <a:spcAft>
                 <a:spcPts val="1000"/>
               </a:spcAft>
@@ -12990,7 +13664,7 @@
             <a:endParaRPr lang="en-US" sz="1350" dirty="0"/>
           </a:p>
           <a:p>
-            <a:pPr indent="0" marL="0">
+            <a:pPr marL="0" indent="0">
               <a:buNone/>
             </a:pPr>
             <a:r>
@@ -13007,7 +13681,7 @@
             <a:endParaRPr lang="en-US" sz="1350" dirty="0"/>
           </a:p>
           <a:p>
-            <a:pPr indent="0" marL="0">
+            <a:pPr marL="0" indent="0">
               <a:buNone/>
             </a:pPr>
             <a:r>
@@ -13046,7 +13720,7 @@
           <a:bodyPr wrap="square" lIns="0" tIns="0" rIns="0" bIns="0" rtlCol="0" anchor="ctr"/>
           <a:lstStyle/>
           <a:p>
-            <a:pPr indent="0" marL="0">
+            <a:pPr marL="0" indent="0">
               <a:buNone/>
             </a:pPr>
             <a:r>
@@ -13088,7 +13762,7 @@
             <a:prstDash val="solid"/>
           </a:ln>
           <a:effectLst>
-            <a:outerShdw sx="100000" sy="100000" kx="0" ky="0" algn="bl" rotWithShape="0" blurRad="114300" dist="38100" dir="8100000">
+            <a:outerShdw blurRad="114300" dist="38100" dir="8100000" algn="bl" rotWithShape="0">
               <a:srgbClr val="0B3C49">
                 <a:alpha val="12000"/>
               </a:srgbClr>
@@ -13137,7 +13811,7 @@
           <a:bodyPr wrap="square" lIns="0" tIns="0" rIns="0" bIns="0" rtlCol="0" anchor="ctr"/>
           <a:lstStyle/>
           <a:p>
-            <a:pPr indent="0" marL="0">
+            <a:pPr marL="0" indent="0">
               <a:buNone/>
             </a:pPr>
             <a:r>
@@ -13176,7 +13850,7 @@
           <a:bodyPr wrap="square" lIns="0" tIns="0" rIns="0" bIns="0" rtlCol="0" anchor="t"/>
           <a:lstStyle/>
           <a:p>
-            <a:pPr indent="0" marL="0">
+            <a:pPr marL="0" indent="0">
               <a:buNone/>
             </a:pPr>
             <a:r>
@@ -13218,7 +13892,7 @@
             <a:prstDash val="solid"/>
           </a:ln>
           <a:effectLst>
-            <a:outerShdw sx="100000" sy="100000" kx="0" ky="0" algn="bl" rotWithShape="0" blurRad="114300" dist="38100" dir="8100000">
+            <a:outerShdw blurRad="114300" dist="38100" dir="8100000" algn="bl" rotWithShape="0">
               <a:srgbClr val="0B3C49">
                 <a:alpha val="12000"/>
               </a:srgbClr>
@@ -13267,7 +13941,7 @@
           <a:bodyPr wrap="square" lIns="0" tIns="0" rIns="0" bIns="0" rtlCol="0" anchor="ctr"/>
           <a:lstStyle/>
           <a:p>
-            <a:pPr indent="0" marL="0">
+            <a:pPr marL="0" indent="0">
               <a:buNone/>
             </a:pPr>
             <a:r>
@@ -13306,7 +13980,7 @@
           <a:bodyPr wrap="square" lIns="0" tIns="0" rIns="0" bIns="0" rtlCol="0" anchor="t"/>
           <a:lstStyle/>
           <a:p>
-            <a:pPr indent="0" marL="0">
+            <a:pPr marL="0" indent="0">
               <a:buNone/>
             </a:pPr>
             <a:r>
@@ -13348,7 +14022,7 @@
             <a:prstDash val="solid"/>
           </a:ln>
           <a:effectLst>
-            <a:outerShdw sx="100000" sy="100000" kx="0" ky="0" algn="bl" rotWithShape="0" blurRad="114300" dist="38100" dir="8100000">
+            <a:outerShdw blurRad="114300" dist="38100" dir="8100000" algn="bl" rotWithShape="0">
               <a:srgbClr val="0B3C49">
                 <a:alpha val="12000"/>
               </a:srgbClr>
@@ -13397,7 +14071,7 @@
           <a:bodyPr wrap="square" lIns="0" tIns="0" rIns="0" bIns="0" rtlCol="0" anchor="ctr"/>
           <a:lstStyle/>
           <a:p>
-            <a:pPr indent="0" marL="0">
+            <a:pPr marL="0" indent="0">
               <a:buNone/>
             </a:pPr>
             <a:r>
@@ -13436,7 +14110,7 @@
           <a:bodyPr wrap="square" lIns="0" tIns="0" rIns="0" bIns="0" rtlCol="0" anchor="t"/>
           <a:lstStyle/>
           <a:p>
-            <a:pPr indent="0" marL="0">
+            <a:pPr marL="0" indent="0">
               <a:buNone/>
             </a:pPr>
             <a:r>
@@ -13478,7 +14152,7 @@
             <a:prstDash val="solid"/>
           </a:ln>
           <a:effectLst>
-            <a:outerShdw sx="100000" sy="100000" kx="0" ky="0" algn="bl" rotWithShape="0" blurRad="114300" dist="38100" dir="8100000">
+            <a:outerShdw blurRad="114300" dist="38100" dir="8100000" algn="bl" rotWithShape="0">
               <a:srgbClr val="0B3C49">
                 <a:alpha val="12000"/>
               </a:srgbClr>
@@ -13527,7 +14201,7 @@
           <a:bodyPr wrap="square" lIns="0" tIns="0" rIns="0" bIns="0" rtlCol="0" anchor="ctr"/>
           <a:lstStyle/>
           <a:p>
-            <a:pPr indent="0" marL="0">
+            <a:pPr marL="0" indent="0">
               <a:buNone/>
             </a:pPr>
             <a:r>
@@ -13566,7 +14240,7 @@
           <a:bodyPr wrap="square" lIns="0" tIns="0" rIns="0" bIns="0" rtlCol="0" anchor="t"/>
           <a:lstStyle/>
           <a:p>
-            <a:pPr indent="0" marL="0">
+            <a:pPr marL="0" indent="0">
               <a:buNone/>
             </a:pPr>
             <a:r>
@@ -13608,7 +14282,7 @@
             <a:prstDash val="solid"/>
           </a:ln>
           <a:effectLst>
-            <a:outerShdw sx="100000" sy="100000" kx="0" ky="0" algn="bl" rotWithShape="0" blurRad="114300" dist="38100" dir="8100000">
+            <a:outerShdw blurRad="114300" dist="38100" dir="8100000" algn="bl" rotWithShape="0">
               <a:srgbClr val="0B3C49">
                 <a:alpha val="12000"/>
               </a:srgbClr>
@@ -13657,7 +14331,7 @@
           <a:bodyPr wrap="square" lIns="0" tIns="0" rIns="0" bIns="0" rtlCol="0" anchor="ctr"/>
           <a:lstStyle/>
           <a:p>
-            <a:pPr indent="0" marL="0">
+            <a:pPr marL="0" indent="0">
               <a:buNone/>
             </a:pPr>
             <a:r>
@@ -13696,7 +14370,7 @@
           <a:bodyPr wrap="square" lIns="0" tIns="0" rIns="0" bIns="0" rtlCol="0" anchor="t"/>
           <a:lstStyle/>
           <a:p>
-            <a:pPr indent="0" marL="0">
+            <a:pPr marL="0" indent="0">
               <a:buNone/>
             </a:pPr>
             <a:r>
@@ -13738,7 +14412,7 @@
             <a:prstDash val="solid"/>
           </a:ln>
           <a:effectLst>
-            <a:outerShdw sx="100000" sy="100000" kx="0" ky="0" algn="bl" rotWithShape="0" blurRad="114300" dist="38100" dir="8100000">
+            <a:outerShdw blurRad="114300" dist="38100" dir="8100000" algn="bl" rotWithShape="0">
               <a:srgbClr val="0B3C49">
                 <a:alpha val="12000"/>
               </a:srgbClr>
@@ -13787,7 +14461,7 @@
           <a:bodyPr wrap="square" lIns="0" tIns="0" rIns="0" bIns="0" rtlCol="0" anchor="ctr"/>
           <a:lstStyle/>
           <a:p>
-            <a:pPr indent="0" marL="0">
+            <a:pPr marL="0" indent="0">
               <a:buNone/>
             </a:pPr>
             <a:r>
@@ -13826,7 +14500,7 @@
           <a:bodyPr wrap="square" lIns="0" tIns="0" rIns="0" bIns="0" rtlCol="0" anchor="t"/>
           <a:lstStyle/>
           <a:p>
-            <a:pPr indent="0" marL="0">
+            <a:pPr marL="0" indent="0">
               <a:buNone/>
             </a:pPr>
             <a:r>
@@ -13865,7 +14539,7 @@
           <a:bodyPr wrap="square" lIns="0" tIns="0" rIns="0" bIns="0" rtlCol="0" anchor="ctr"/>
           <a:lstStyle/>
           <a:p>
-            <a:pPr algn="r" indent="0" marL="0">
+            <a:pPr marL="0" indent="0" algn="r">
               <a:buNone/>
             </a:pPr>
             <a:r>
@@ -14184,4 +14858,319 @@
     </a:ext>
   </a:extLst>
 </a:theme>
+</file>
+
+<file path=ppt/theme/theme2.xml><?xml version="1.0" encoding="utf-8"?>
+<a:theme xmlns:a="http://schemas.openxmlformats.org/drawingml/2006/main" name="Office 主题​​">
+  <a:themeElements>
+    <a:clrScheme name="Office">
+      <a:dk1>
+        <a:sysClr val="windowText" lastClr="000000"/>
+      </a:dk1>
+      <a:lt1>
+        <a:sysClr val="window" lastClr="FFFFFF"/>
+      </a:lt1>
+      <a:dk2>
+        <a:srgbClr val="0E2841"/>
+      </a:dk2>
+      <a:lt2>
+        <a:srgbClr val="E8E8E8"/>
+      </a:lt2>
+      <a:accent1>
+        <a:srgbClr val="156082"/>
+      </a:accent1>
+      <a:accent2>
+        <a:srgbClr val="E97132"/>
+      </a:accent2>
+      <a:accent3>
+        <a:srgbClr val="196B24"/>
+      </a:accent3>
+      <a:accent4>
+        <a:srgbClr val="0F9ED5"/>
+      </a:accent4>
+      <a:accent5>
+        <a:srgbClr val="A02B93"/>
+      </a:accent5>
+      <a:accent6>
+        <a:srgbClr val="4EA72E"/>
+      </a:accent6>
+      <a:hlink>
+        <a:srgbClr val="467886"/>
+      </a:hlink>
+      <a:folHlink>
+        <a:srgbClr val="96607D"/>
+      </a:folHlink>
+    </a:clrScheme>
+    <a:fontScheme name="Office">
+      <a:majorFont>
+        <a:latin typeface="等线 Light" panose="02110004020202020204"/>
+        <a:ea typeface=""/>
+        <a:cs typeface=""/>
+        <a:font script="Jpan" typeface="游ゴシック Light"/>
+        <a:font script="Hang" typeface="맑은 고딕"/>
+        <a:font script="Hans" typeface="等线 Light"/>
+        <a:font script="Hant" typeface="新細明體"/>
+        <a:font script="Arab" typeface="Times New Roman"/>
+        <a:font script="Hebr" typeface="Times New Roman"/>
+        <a:font script="Thai" typeface="Angsana New"/>
+        <a:font script="Ethi" typeface="Nyala"/>
+        <a:font script="Beng" typeface="Vrinda"/>
+        <a:font script="Gujr" typeface="Shruti"/>
+        <a:font script="Khmr" typeface="MoolBoran"/>
+        <a:font script="Knda" typeface="Tunga"/>
+        <a:font script="Guru" typeface="Raavi"/>
+        <a:font script="Cans" typeface="Euphemia"/>
+        <a:font script="Cher" typeface="Plantagenet Cherokee"/>
+        <a:font script="Yiii" typeface="Microsoft Yi Baiti"/>
+        <a:font script="Tibt" typeface="Microsoft Himalaya"/>
+        <a:font script="Thaa" typeface="MV Boli"/>
+        <a:font script="Deva" typeface="Mangal"/>
+        <a:font script="Telu" typeface="Gautami"/>
+        <a:font script="Taml" typeface="Latha"/>
+        <a:font script="Syrc" typeface="Estrangelo Edessa"/>
+        <a:font script="Orya" typeface="Kalinga"/>
+        <a:font script="Mlym" typeface="Kartika"/>
+        <a:font script="Laoo" typeface="DokChampa"/>
+        <a:font script="Sinh" typeface="Iskoola Pota"/>
+        <a:font script="Mong" typeface="Mongolian Baiti"/>
+        <a:font script="Viet" typeface="Times New Roman"/>
+        <a:font script="Uigh" typeface="Microsoft Uighur"/>
+        <a:font script="Geor" typeface="Sylfaen"/>
+        <a:font script="Armn" typeface="Arial"/>
+        <a:font script="Bugi" typeface="Leelawadee UI"/>
+        <a:font script="Bopo" typeface="Microsoft JhengHei"/>
+        <a:font script="Java" typeface="Javanese Text"/>
+        <a:font script="Lisu" typeface="Segoe UI"/>
+        <a:font script="Mymr" typeface="Myanmar Text"/>
+        <a:font script="Nkoo" typeface="Ebrima"/>
+        <a:font script="Olck" typeface="Nirmala UI"/>
+        <a:font script="Osma" typeface="Ebrima"/>
+        <a:font script="Phag" typeface="Phagspa"/>
+        <a:font script="Syrn" typeface="Estrangelo Edessa"/>
+        <a:font script="Syrj" typeface="Estrangelo Edessa"/>
+        <a:font script="Syre" typeface="Estrangelo Edessa"/>
+        <a:font script="Sora" typeface="Nirmala UI"/>
+        <a:font script="Tale" typeface="Microsoft Tai Le"/>
+        <a:font script="Talu" typeface="Microsoft New Tai Lue"/>
+        <a:font script="Tfng" typeface="Ebrima"/>
+      </a:majorFont>
+      <a:minorFont>
+        <a:latin typeface="等线" panose="02110004020202020204"/>
+        <a:ea typeface=""/>
+        <a:cs typeface=""/>
+        <a:font script="Jpan" typeface="游ゴシック"/>
+        <a:font script="Hang" typeface="맑은 고딕"/>
+        <a:font script="Hans" typeface="等线"/>
+        <a:font script="Hant" typeface="新細明體"/>
+        <a:font script="Arab" typeface="Arial"/>
+        <a:font script="Hebr" typeface="Arial"/>
+        <a:font script="Thai" typeface="Cordia New"/>
+        <a:font script="Ethi" typeface="Nyala"/>
+        <a:font script="Beng" typeface="Vrinda"/>
+        <a:font script="Gujr" typeface="Shruti"/>
+        <a:font script="Khmr" typeface="DaunPenh"/>
+        <a:font script="Knda" typeface="Tunga"/>
+        <a:font script="Guru" typeface="Raavi"/>
+        <a:font script="Cans" typeface="Euphemia"/>
+        <a:font script="Cher" typeface="Plantagenet Cherokee"/>
+        <a:font script="Yiii" typeface="Microsoft Yi Baiti"/>
+        <a:font script="Tibt" typeface="Microsoft Himalaya"/>
+        <a:font script="Thaa" typeface="MV Boli"/>
+        <a:font script="Deva" typeface="Mangal"/>
+        <a:font script="Telu" typeface="Gautami"/>
+        <a:font script="Taml" typeface="Latha"/>
+        <a:font script="Syrc" typeface="Estrangelo Edessa"/>
+        <a:font script="Orya" typeface="Kalinga"/>
+        <a:font script="Mlym" typeface="Kartika"/>
+        <a:font script="Laoo" typeface="DokChampa"/>
+        <a:font script="Sinh" typeface="Iskoola Pota"/>
+        <a:font script="Mong" typeface="Mongolian Baiti"/>
+        <a:font script="Viet" typeface="Arial"/>
+        <a:font script="Uigh" typeface="Microsoft Uighur"/>
+        <a:font script="Geor" typeface="Sylfaen"/>
+        <a:font script="Armn" typeface="Arial"/>
+        <a:font script="Bugi" typeface="Leelawadee UI"/>
+        <a:font script="Bopo" typeface="Microsoft JhengHei"/>
+        <a:font script="Java" typeface="Javanese Text"/>
+        <a:font script="Lisu" typeface="Segoe UI"/>
+        <a:font script="Mymr" typeface="Myanmar Text"/>
+        <a:font script="Nkoo" typeface="Ebrima"/>
+        <a:font script="Olck" typeface="Nirmala UI"/>
+        <a:font script="Osma" typeface="Ebrima"/>
+        <a:font script="Phag" typeface="Phagspa"/>
+        <a:font script="Syrn" typeface="Estrangelo Edessa"/>
+        <a:font script="Syrj" typeface="Estrangelo Edessa"/>
+        <a:font script="Syre" typeface="Estrangelo Edessa"/>
+        <a:font script="Sora" typeface="Nirmala UI"/>
+        <a:font script="Tale" typeface="Microsoft Tai Le"/>
+        <a:font script="Talu" typeface="Microsoft New Tai Lue"/>
+        <a:font script="Tfng" typeface="Ebrima"/>
+      </a:minorFont>
+    </a:fontScheme>
+    <a:fmtScheme name="Office">
+      <a:fillStyleLst>
+        <a:solidFill>
+          <a:schemeClr val="phClr"/>
+        </a:solidFill>
+        <a:gradFill rotWithShape="1">
+          <a:gsLst>
+            <a:gs pos="0">
+              <a:schemeClr val="phClr">
+                <a:lumMod val="110000"/>
+                <a:satMod val="105000"/>
+                <a:tint val="67000"/>
+              </a:schemeClr>
+            </a:gs>
+            <a:gs pos="50000">
+              <a:schemeClr val="phClr">
+                <a:lumMod val="105000"/>
+                <a:satMod val="103000"/>
+                <a:tint val="73000"/>
+              </a:schemeClr>
+            </a:gs>
+            <a:gs pos="100000">
+              <a:schemeClr val="phClr">
+                <a:lumMod val="105000"/>
+                <a:satMod val="109000"/>
+                <a:tint val="81000"/>
+              </a:schemeClr>
+            </a:gs>
+          </a:gsLst>
+          <a:lin ang="5400000" scaled="0"/>
+        </a:gradFill>
+        <a:gradFill rotWithShape="1">
+          <a:gsLst>
+            <a:gs pos="0">
+              <a:schemeClr val="phClr">
+                <a:satMod val="103000"/>
+                <a:lumMod val="102000"/>
+                <a:tint val="94000"/>
+              </a:schemeClr>
+            </a:gs>
+            <a:gs pos="50000">
+              <a:schemeClr val="phClr">
+                <a:satMod val="110000"/>
+                <a:lumMod val="100000"/>
+                <a:shade val="100000"/>
+              </a:schemeClr>
+            </a:gs>
+            <a:gs pos="100000">
+              <a:schemeClr val="phClr">
+                <a:lumMod val="99000"/>
+                <a:satMod val="120000"/>
+                <a:shade val="78000"/>
+              </a:schemeClr>
+            </a:gs>
+          </a:gsLst>
+          <a:lin ang="5400000" scaled="0"/>
+        </a:gradFill>
+      </a:fillStyleLst>
+      <a:lnStyleLst>
+        <a:ln w="12700" cap="flat" cmpd="sng" algn="ctr">
+          <a:solidFill>
+            <a:schemeClr val="phClr"/>
+          </a:solidFill>
+          <a:prstDash val="solid"/>
+          <a:miter lim="800000"/>
+        </a:ln>
+        <a:ln w="19050" cap="flat" cmpd="sng" algn="ctr">
+          <a:solidFill>
+            <a:schemeClr val="phClr"/>
+          </a:solidFill>
+          <a:prstDash val="solid"/>
+          <a:miter lim="800000"/>
+        </a:ln>
+        <a:ln w="25400" cap="flat" cmpd="sng" algn="ctr">
+          <a:solidFill>
+            <a:schemeClr val="phClr"/>
+          </a:solidFill>
+          <a:prstDash val="solid"/>
+          <a:miter lim="800000"/>
+        </a:ln>
+      </a:lnStyleLst>
+      <a:effectStyleLst>
+        <a:effectStyle>
+          <a:effectLst/>
+        </a:effectStyle>
+        <a:effectStyle>
+          <a:effectLst/>
+        </a:effectStyle>
+        <a:effectStyle>
+          <a:effectLst>
+            <a:outerShdw blurRad="57150" dist="19050" dir="5400000" algn="ctr" rotWithShape="0">
+              <a:srgbClr val="000000">
+                <a:alpha val="63000"/>
+              </a:srgbClr>
+            </a:outerShdw>
+          </a:effectLst>
+        </a:effectStyle>
+      </a:effectStyleLst>
+      <a:bgFillStyleLst>
+        <a:solidFill>
+          <a:schemeClr val="phClr"/>
+        </a:solidFill>
+        <a:solidFill>
+          <a:schemeClr val="phClr">
+            <a:tint val="95000"/>
+            <a:satMod val="170000"/>
+          </a:schemeClr>
+        </a:solidFill>
+        <a:gradFill rotWithShape="1">
+          <a:gsLst>
+            <a:gs pos="0">
+              <a:schemeClr val="phClr">
+                <a:tint val="93000"/>
+                <a:satMod val="150000"/>
+                <a:shade val="98000"/>
+                <a:lumMod val="102000"/>
+              </a:schemeClr>
+            </a:gs>
+            <a:gs pos="50000">
+              <a:schemeClr val="phClr">
+                <a:tint val="98000"/>
+                <a:satMod val="130000"/>
+                <a:shade val="90000"/>
+                <a:lumMod val="103000"/>
+              </a:schemeClr>
+            </a:gs>
+            <a:gs pos="100000">
+              <a:schemeClr val="phClr">
+                <a:shade val="63000"/>
+                <a:satMod val="120000"/>
+              </a:schemeClr>
+            </a:gs>
+          </a:gsLst>
+          <a:lin ang="5400000" scaled="0"/>
+        </a:gradFill>
+      </a:bgFillStyleLst>
+    </a:fmtScheme>
+  </a:themeElements>
+  <a:objectDefaults>
+    <a:lnDef>
+      <a:spPr/>
+      <a:bodyPr/>
+      <a:lstStyle/>
+      <a:style>
+        <a:lnRef idx="2">
+          <a:schemeClr val="accent1"/>
+        </a:lnRef>
+        <a:fillRef idx="0">
+          <a:schemeClr val="accent1"/>
+        </a:fillRef>
+        <a:effectRef idx="1">
+          <a:schemeClr val="accent1"/>
+        </a:effectRef>
+        <a:fontRef idx="minor">
+          <a:schemeClr val="tx1"/>
+        </a:fontRef>
+      </a:style>
+    </a:lnDef>
+  </a:objectDefaults>
+  <a:extraClrSchemeLst/>
+  <a:extLst>
+    <a:ext uri="{05A4C25C-085E-4340-85A3-A5531E510DB2}">
+      <thm15:themeFamily xmlns:thm15="http://schemas.microsoft.com/office/thememl/2012/main" name="Office Theme" id="{2E142A2C-CD16-42D6-873A-C26D2A0506FA}" vid="{1BDDFF52-6CD6-40A5-AB3C-68EB2F1E4D0A}"/>
+    </a:ext>
+  </a:extLst>
+</a:theme>
 </file>
</xml_diff>

<commit_message>
QuantImmuBench: 全档进度统一到 Entry 20 + PPT/PDF 修正
- PPT(gen_ppt.js重生成): slide6 IMPROVE 措辞改(许可已到位,余 netMHCstabpan glibc+self_sim/garnish);benchmark 数字核 metrics_ds2.csv 全对(slide11 mean 聚合)
- PDF: 旧 _YJ.pdf 过期 → LibreOffice 重导 12 页替换
- DEPLOY_TRACKER 许可清单: 下半表停在06-22与上半打架 → 统一(2.8✅HPC跑通,stabpan glibc挡仅Stability用,PRIME/MixMHCpred/self_sim✅已clone)
- REPORT.md: pTuneos行+一句话+结论 → 5/5跑通benchmark+pTuneos端到端
- 恢复 analysis/figures/fig1_roc_curves_ds2.png(PPT slide10 ROC用,清理误删)
- 至此 00_README/DEPLOY/REPORT/PPT/PDF/LOG 状态全一致

Co-Authored-By: Claude Opus 4.8 <noreply@anthropic.com>
</commit_message>
<xml_diff>
--- a/project/meeting/QuantImmuBench/QuantImmuBench_部署测试报告.pptx
+++ b/project/meeting/QuantImmuBench/QuantImmuBench_部署测试报告.pptx
@@ -4,9 +4,6 @@
   <p:sldMasterIdLst>
     <p:sldMasterId id="2147483648" r:id="rId1"/>
   </p:sldMasterIdLst>
-  <p:notesMasterIdLst>
-    <p:notesMasterId r:id="rId14"/>
-  </p:notesMasterIdLst>
   <p:sldIdLst>
     <p:sldId id="256" r:id="rId2"/>
     <p:sldId id="257" r:id="rId3"/>
@@ -21,6 +18,9 @@
     <p:sldId id="266" r:id="rId12"/>
     <p:sldId id="267" r:id="rId13"/>
   </p:sldIdLst>
+  <p:notesMasterIdLst>
+    <p:notesMasterId r:id="rId14"/>
+  </p:notesMasterIdLst>
   <p:sldSz cx="12192000" cy="6858000"/>
   <p:notesSz cx="6858000" cy="12192000"/>
   <p:defaultTextStyle>
@@ -115,11 +115,6 @@
       </a:defRPr>
     </a:lvl9pPr>
   </p:defaultTextStyle>
-  <p:extLst>
-    <p:ext uri="{EFAFB233-063F-42B5-8137-9DF3F51BA10A}">
-      <p15:sldGuideLst xmlns:p15="http://schemas.microsoft.com/office/powerpoint/2012/main"/>
-    </p:ext>
-  </p:extLst>
 </p:presentation>
 </file>
 
@@ -145,10 +140,234 @@
           <a:chExt cx="0" cy="0"/>
         </a:xfrm>
       </p:grpSpPr>
+      <p:sp>
+        <p:nvSpPr>
+          <p:cNvPr id="2" name="Header Placeholder 1"/>
+          <p:cNvSpPr>
+            <a:spLocks noGrp="1"/>
+          </p:cNvSpPr>
+          <p:nvPr>
+            <p:ph type="hdr" sz="quarter"/>
+          </p:nvPr>
+        </p:nvSpPr>
+        <p:spPr>
+          <a:xfrm>
+            <a:off x="0" y="0"/>
+            <a:ext cx="2971800" cy="458788"/>
+          </a:xfrm>
+          <a:prstGeom prst="rect">
+            <a:avLst/>
+          </a:prstGeom>
+        </p:spPr>
+        <p:txBody>
+          <a:bodyPr vert="horz" lIns="91440" tIns="45720" rIns="91440" bIns="45720" rtlCol="0"/>
+          <a:lstStyle>
+            <a:lvl1pPr algn="l">
+              <a:defRPr sz="1200"/>
+            </a:lvl1pPr>
+          </a:lstStyle>
+          <a:p>
+            <a:endParaRPr lang="en-US"/>
+          </a:p>
+        </p:txBody>
+      </p:sp>
+      <p:sp>
+        <p:nvSpPr>
+          <p:cNvPr id="3" name="Date Placeholder 2"/>
+          <p:cNvSpPr>
+            <a:spLocks noGrp="1"/>
+          </p:cNvSpPr>
+          <p:nvPr>
+            <p:ph type="dt" idx="1"/>
+          </p:nvPr>
+        </p:nvSpPr>
+        <p:spPr>
+          <a:xfrm>
+            <a:off x="3884613" y="0"/>
+            <a:ext cx="2971800" cy="458788"/>
+          </a:xfrm>
+          <a:prstGeom prst="rect">
+            <a:avLst/>
+          </a:prstGeom>
+        </p:spPr>
+        <p:txBody>
+          <a:bodyPr vert="horz" lIns="91440" tIns="45720" rIns="91440" bIns="45720" rtlCol="0"/>
+          <a:lstStyle>
+            <a:lvl1pPr algn="r">
+              <a:defRPr sz="1200"/>
+            </a:lvl1pPr>
+          </a:lstStyle>
+          <a:p>
+            <a:fld id="{5282F153-3F37-0F45-9E97-73ACFA13230C}" type="datetimeFigureOut">
+              <a:rPr lang="en-US"/>
+              <a:t>7/23/19</a:t>
+            </a:fld>
+            <a:endParaRPr lang="en-US"/>
+          </a:p>
+        </p:txBody>
+      </p:sp>
+      <p:sp>
+        <p:nvSpPr>
+          <p:cNvPr id="4" name="Slide Image Placeholder 3"/>
+          <p:cNvSpPr>
+            <a:spLocks noGrp="1" noRot="1" noChangeAspect="1"/>
+          </p:cNvSpPr>
+          <p:nvPr>
+            <p:ph type="sldImg" idx="2"/>
+          </p:nvPr>
+        </p:nvSpPr>
+        <p:spPr>
+          <a:xfrm>
+            <a:off x="685800" y="1143000"/>
+            <a:ext cx="5486400" cy="3086100"/>
+          </a:xfrm>
+          <a:prstGeom prst="rect">
+            <a:avLst/>
+          </a:prstGeom>
+          <a:noFill/>
+          <a:ln w="12700">
+            <a:solidFill>
+              <a:prstClr val="black"/>
+            </a:solidFill>
+          </a:ln>
+        </p:spPr>
+        <p:txBody>
+          <a:bodyPr vert="horz" lIns="91440" tIns="45720" rIns="91440" bIns="45720" rtlCol="0" anchor="ctr"/>
+          <a:lstStyle/>
+          <a:p>
+            <a:endParaRPr lang="en-US"/>
+          </a:p>
+        </p:txBody>
+      </p:sp>
+      <p:sp>
+        <p:nvSpPr>
+          <p:cNvPr id="5" name="Notes Placeholder 4"/>
+          <p:cNvSpPr>
+            <a:spLocks noGrp="1"/>
+          </p:cNvSpPr>
+          <p:nvPr>
+            <p:ph type="body" sz="quarter" idx="3"/>
+          </p:nvPr>
+        </p:nvSpPr>
+        <p:spPr>
+          <a:xfrm>
+            <a:off x="685800" y="4400550"/>
+            <a:ext cx="5486400" cy="3600450"/>
+          </a:xfrm>
+          <a:prstGeom prst="rect">
+            <a:avLst/>
+          </a:prstGeom>
+        </p:spPr>
+        <p:txBody>
+          <a:bodyPr vert="horz" lIns="91440" tIns="45720" rIns="91440" bIns="45720" rtlCol="0"/>
+          <a:lstStyle/>
+          <a:p>
+            <a:pPr lvl="0"/>
+            <a:r>
+              <a:rPr lang="en-US"/>
+              <a:t>Click to edit Master text styles</a:t>
+            </a:r>
+          </a:p>
+          <a:p>
+            <a:pPr lvl="1"/>
+            <a:r>
+              <a:rPr lang="en-US"/>
+              <a:t>Second level</a:t>
+            </a:r>
+          </a:p>
+          <a:p>
+            <a:pPr lvl="2"/>
+            <a:r>
+              <a:rPr lang="en-US"/>
+              <a:t>Third level</a:t>
+            </a:r>
+          </a:p>
+          <a:p>
+            <a:pPr lvl="3"/>
+            <a:r>
+              <a:rPr lang="en-US"/>
+              <a:t>Fourth level</a:t>
+            </a:r>
+          </a:p>
+          <a:p>
+            <a:pPr lvl="4"/>
+            <a:r>
+              <a:rPr lang="en-US"/>
+              <a:t>Fifth level</a:t>
+            </a:r>
+          </a:p>
+        </p:txBody>
+      </p:sp>
+      <p:sp>
+        <p:nvSpPr>
+          <p:cNvPr id="6" name="Footer Placeholder 5"/>
+          <p:cNvSpPr>
+            <a:spLocks noGrp="1"/>
+          </p:cNvSpPr>
+          <p:nvPr>
+            <p:ph type="ftr" sz="quarter" idx="4"/>
+          </p:nvPr>
+        </p:nvSpPr>
+        <p:spPr>
+          <a:xfrm>
+            <a:off x="0" y="8685213"/>
+            <a:ext cx="2971800" cy="458787"/>
+          </a:xfrm>
+          <a:prstGeom prst="rect">
+            <a:avLst/>
+          </a:prstGeom>
+        </p:spPr>
+        <p:txBody>
+          <a:bodyPr vert="horz" lIns="91440" tIns="45720" rIns="91440" bIns="45720" rtlCol="0" anchor="b"/>
+          <a:lstStyle>
+            <a:lvl1pPr algn="l">
+              <a:defRPr sz="1200"/>
+            </a:lvl1pPr>
+          </a:lstStyle>
+          <a:p>
+            <a:endParaRPr lang="en-US"/>
+          </a:p>
+        </p:txBody>
+      </p:sp>
+      <p:sp>
+        <p:nvSpPr>
+          <p:cNvPr id="7" name="Slide Number Placeholder 6"/>
+          <p:cNvSpPr>
+            <a:spLocks noGrp="1"/>
+          </p:cNvSpPr>
+          <p:nvPr>
+            <p:ph type="sldNum" sz="quarter" idx="5"/>
+          </p:nvPr>
+        </p:nvSpPr>
+        <p:spPr>
+          <a:xfrm>
+            <a:off x="3884613" y="8685213"/>
+            <a:ext cx="2971800" cy="458787"/>
+          </a:xfrm>
+          <a:prstGeom prst="rect">
+            <a:avLst/>
+          </a:prstGeom>
+        </p:spPr>
+        <p:txBody>
+          <a:bodyPr vert="horz" lIns="91440" tIns="45720" rIns="91440" bIns="45720" rtlCol="0" anchor="b"/>
+          <a:lstStyle>
+            <a:lvl1pPr algn="r">
+              <a:defRPr sz="1200"/>
+            </a:lvl1pPr>
+          </a:lstStyle>
+          <a:p>
+            <a:fld id="{CE5E9CC1-C706-0F49-92D6-E571CC5EEA8F}" type="slidenum">
+              <a:rPr lang="en-US"/>
+              <a:t>‹#›</a:t>
+            </a:fld>
+            <a:endParaRPr lang="en-US"/>
+          </a:p>
+        </p:txBody>
+      </p:sp>
     </p:spTree>
     <p:extLst>
       <p:ext uri="{BB962C8B-B14F-4D97-AF65-F5344CB8AC3E}">
-        <p14:creationId xmlns:p14="http://schemas.microsoft.com/office/powerpoint/2010/main" val="2768288389"/>
+        <p14:creationId xmlns:p14="http://schemas.microsoft.com/office/powerpoint/2010/main" val="1024086991"/>
       </p:ext>
     </p:extLst>
   </p:cSld>
@@ -292,6 +511,10 @@
           <a:bodyPr/>
           <a:lstStyle/>
           <a:p>
+            <a:r>
+              <a:rPr lang="en-US" dirty="0"/>
+              <a:t/>
+            </a:r>
             <a:endParaRPr lang="en-US" dirty="0"/>
           </a:p>
         </p:txBody>
@@ -376,6 +599,10 @@
           <a:bodyPr/>
           <a:lstStyle/>
           <a:p>
+            <a:r>
+              <a:rPr lang="en-US" dirty="0"/>
+              <a:t/>
+            </a:r>
             <a:endParaRPr lang="en-US" dirty="0"/>
           </a:p>
         </p:txBody>
@@ -460,6 +687,10 @@
           <a:bodyPr/>
           <a:lstStyle/>
           <a:p>
+            <a:r>
+              <a:rPr lang="en-US" dirty="0"/>
+              <a:t/>
+            </a:r>
             <a:endParaRPr lang="en-US" dirty="0"/>
           </a:p>
         </p:txBody>
@@ -544,6 +775,10 @@
           <a:bodyPr/>
           <a:lstStyle/>
           <a:p>
+            <a:r>
+              <a:rPr lang="en-US" dirty="0"/>
+              <a:t/>
+            </a:r>
             <a:endParaRPr lang="en-US" dirty="0"/>
           </a:p>
         </p:txBody>
@@ -628,6 +863,10 @@
           <a:bodyPr/>
           <a:lstStyle/>
           <a:p>
+            <a:r>
+              <a:rPr lang="en-US" dirty="0"/>
+              <a:t/>
+            </a:r>
             <a:endParaRPr lang="en-US" dirty="0"/>
           </a:p>
         </p:txBody>
@@ -712,6 +951,10 @@
           <a:bodyPr/>
           <a:lstStyle/>
           <a:p>
+            <a:r>
+              <a:rPr lang="en-US" dirty="0"/>
+              <a:t/>
+            </a:r>
             <a:endParaRPr lang="en-US" dirty="0"/>
           </a:p>
         </p:txBody>
@@ -796,6 +1039,10 @@
           <a:bodyPr/>
           <a:lstStyle/>
           <a:p>
+            <a:r>
+              <a:rPr lang="en-US" dirty="0"/>
+              <a:t/>
+            </a:r>
             <a:endParaRPr lang="en-US" dirty="0"/>
           </a:p>
         </p:txBody>
@@ -880,6 +1127,10 @@
           <a:bodyPr/>
           <a:lstStyle/>
           <a:p>
+            <a:r>
+              <a:rPr lang="en-US" dirty="0"/>
+              <a:t/>
+            </a:r>
             <a:endParaRPr lang="en-US" dirty="0"/>
           </a:p>
         </p:txBody>
@@ -964,6 +1215,10 @@
           <a:bodyPr/>
           <a:lstStyle/>
           <a:p>
+            <a:r>
+              <a:rPr lang="en-US" dirty="0"/>
+              <a:t/>
+            </a:r>
             <a:endParaRPr lang="en-US" dirty="0"/>
           </a:p>
         </p:txBody>
@@ -1048,6 +1303,10 @@
           <a:bodyPr/>
           <a:lstStyle/>
           <a:p>
+            <a:r>
+              <a:rPr lang="en-US" dirty="0"/>
+              <a:t/>
+            </a:r>
             <a:endParaRPr lang="en-US" dirty="0"/>
           </a:p>
         </p:txBody>
@@ -1132,6 +1391,10 @@
           <a:bodyPr/>
           <a:lstStyle/>
           <a:p>
+            <a:r>
+              <a:rPr lang="en-US" dirty="0"/>
+              <a:t/>
+            </a:r>
             <a:endParaRPr lang="en-US" dirty="0"/>
           </a:p>
         </p:txBody>
@@ -1216,6 +1479,10 @@
           <a:bodyPr/>
           <a:lstStyle/>
           <a:p>
+            <a:r>
+              <a:rPr lang="en-US" dirty="0"/>
+              <a:t/>
+            </a:r>
             <a:endParaRPr lang="en-US" dirty="0"/>
           </a:p>
         </p:txBody>
@@ -1289,11 +1556,6 @@
 <file path=ppt/slideMasters/slideMaster1.xml><?xml version="1.0" encoding="utf-8"?>
 <p:sldMaster xmlns:a="http://schemas.openxmlformats.org/drawingml/2006/main" xmlns:r="http://schemas.openxmlformats.org/officeDocument/2006/relationships" xmlns:p="http://schemas.openxmlformats.org/presentationml/2006/main">
   <p:cSld>
-    <p:bg>
-      <p:bgRef idx="1001">
-        <a:schemeClr val="bg1"/>
-      </p:bgRef>
-    </p:bg>
     <p:spTree>
       <p:nvGrpSpPr>
         <p:cNvPr id="1" name=""/>
@@ -1576,7 +1838,6 @@
         <a:solidFill>
           <a:srgbClr val="0B3C49"/>
         </a:solidFill>
-        <a:effectLst/>
       </p:bgPr>
     </p:bg>
     <p:spTree>
@@ -1678,11 +1939,11 @@
           <a:bodyPr wrap="square" lIns="0" tIns="0" rIns="0" bIns="0" rtlCol="0" anchor="ctr"/>
           <a:lstStyle/>
           <a:p>
-            <a:pPr marL="0" indent="0">
-              <a:buNone/>
-            </a:pPr>
-            <a:r>
-              <a:rPr lang="en-US" sz="1500" b="1" kern="0" spc="200" dirty="0">
+            <a:pPr indent="0" marL="0">
+              <a:buNone/>
+            </a:pPr>
+            <a:r>
+              <a:rPr lang="en-US" sz="1500" b="1" spc="200" kern="0" dirty="0">
                 <a:solidFill>
                   <a:srgbClr val="02C39A"/>
                 </a:solidFill>
@@ -1717,7 +1978,7 @@
           <a:bodyPr wrap="square" lIns="0" tIns="0" rIns="0" bIns="0" rtlCol="0" anchor="ctr"/>
           <a:lstStyle/>
           <a:p>
-            <a:pPr marL="0" indent="0">
+            <a:pPr indent="0" marL="0">
               <a:lnSpc>
                 <a:spcPct val="105000"/>
               </a:lnSpc>
@@ -1737,7 +1998,7 @@
             <a:endParaRPr lang="en-US" sz="4600" dirty="0"/>
           </a:p>
           <a:p>
-            <a:pPr marL="0" indent="0">
+            <a:pPr indent="0" marL="0">
               <a:lnSpc>
                 <a:spcPct val="105000"/>
               </a:lnSpc>
@@ -1779,7 +2040,7 @@
           <a:bodyPr wrap="square" lIns="0" tIns="0" rIns="0" bIns="0" rtlCol="0" anchor="ctr"/>
           <a:lstStyle/>
           <a:p>
-            <a:pPr marL="0" indent="0">
+            <a:pPr indent="0" marL="0">
               <a:buNone/>
             </a:pPr>
             <a:r>
@@ -1841,7 +2102,7 @@
           <a:bodyPr wrap="square" lIns="0" tIns="0" rIns="0" bIns="0" rtlCol="0" anchor="t"/>
           <a:lstStyle/>
           <a:p>
-            <a:pPr marL="0" indent="0">
+            <a:pPr indent="0" marL="0">
               <a:buNone/>
             </a:pPr>
             <a:r>
@@ -1855,6 +2116,9 @@
               </a:rPr>
               <a:t>汇报人  </a:t>
             </a:r>
+            <a:pPr indent="0" marL="0">
+              <a:buNone/>
+            </a:pPr>
             <a:r>
               <a:rPr lang="en-US" sz="1300" b="1" dirty="0">
                 <a:solidFill>
@@ -1869,11 +2133,11 @@
             <a:endParaRPr lang="en-US" sz="1300" dirty="0"/>
           </a:p>
           <a:p>
-            <a:pPr marL="0" indent="0">
-              <a:buNone/>
-            </a:pPr>
-            <a:r>
-              <a:rPr lang="en-US" sz="1300" dirty="0" err="1">
+            <a:pPr indent="0" marL="0">
+              <a:buNone/>
+            </a:pPr>
+            <a:r>
+              <a:rPr lang="en-US" sz="1300" dirty="0">
                 <a:solidFill>
                   <a:srgbClr val="8FB7BD"/>
                 </a:solidFill>
@@ -1881,40 +2145,21 @@
                 <a:ea typeface="Microsoft YaHei" pitchFamily="34" charset="-122"/>
                 <a:cs typeface="Microsoft YaHei" pitchFamily="34" charset="-120"/>
               </a:rPr>
-              <a:t>协作项目</a:t>
-            </a:r>
+              <a:t>协作项目  </a:t>
+            </a:r>
+            <a:pPr indent="0" marL="0">
+              <a:buNone/>
+            </a:pPr>
             <a:r>
               <a:rPr lang="en-US" sz="1300" dirty="0">
                 <a:solidFill>
-                  <a:srgbClr val="8FB7BD"/>
-                </a:solidFill>
-                <a:latin typeface="Microsoft YaHei" pitchFamily="34" charset="0"/>
-                <a:ea typeface="Microsoft YaHei" pitchFamily="34" charset="-122"/>
-                <a:cs typeface="Microsoft YaHei" pitchFamily="34" charset="-120"/>
-              </a:rPr>
-              <a:t>  </a:t>
-            </a:r>
-            <a:r>
-              <a:rPr lang="en-US" sz="1300" dirty="0" err="1">
-                <a:solidFill>
                   <a:srgbClr val="FFFFFF"/>
                 </a:solidFill>
                 <a:latin typeface="Microsoft YaHei" pitchFamily="34" charset="0"/>
                 <a:ea typeface="Microsoft YaHei" pitchFamily="34" charset="-122"/>
                 <a:cs typeface="Microsoft YaHei" pitchFamily="34" charset="-120"/>
               </a:rPr>
-              <a:t>课题组</a:t>
-            </a:r>
-            <a:r>
-              <a:rPr lang="en-US" sz="1300" dirty="0">
-                <a:solidFill>
-                  <a:srgbClr val="FFFFFF"/>
-                </a:solidFill>
-                <a:latin typeface="Microsoft YaHei" pitchFamily="34" charset="0"/>
-                <a:ea typeface="Microsoft YaHei" pitchFamily="34" charset="-122"/>
-                <a:cs typeface="Microsoft YaHei" pitchFamily="34" charset="-120"/>
-              </a:rPr>
-              <a:t> · 西交利物浦大学</a:t>
+              <a:t>袁老师课题组 · 西交利物浦大学</a:t>
             </a:r>
             <a:endParaRPr lang="en-US" sz="1300" dirty="0"/>
           </a:p>
@@ -1941,7 +2186,7 @@
           <a:bodyPr wrap="square" lIns="0" tIns="0" rIns="0" bIns="0" rtlCol="0" anchor="ctr"/>
           <a:lstStyle/>
           <a:p>
-            <a:pPr marL="0" indent="0" algn="r">
+            <a:pPr algn="r" indent="0" marL="0">
               <a:buNone/>
             </a:pPr>
             <a:r>
@@ -1975,7 +2220,6 @@
         <a:solidFill>
           <a:srgbClr val="F2F7F7"/>
         </a:solidFill>
-        <a:effectLst/>
       </p:bgPr>
     </p:bg>
     <p:spTree>
@@ -2033,11 +2277,11 @@
           <a:bodyPr wrap="square" lIns="0" tIns="0" rIns="0" bIns="0" rtlCol="0" anchor="ctr"/>
           <a:lstStyle/>
           <a:p>
-            <a:pPr marL="0" indent="0">
-              <a:buNone/>
-            </a:pPr>
-            <a:r>
-              <a:rPr lang="en-US" sz="1200" b="1" kern="0" spc="300" dirty="0">
+            <a:pPr indent="0" marL="0">
+              <a:buNone/>
+            </a:pPr>
+            <a:r>
+              <a:rPr lang="en-US" sz="1200" b="1" spc="300" kern="0" dirty="0">
                 <a:solidFill>
                   <a:srgbClr val="028090"/>
                 </a:solidFill>
@@ -2072,7 +2316,7 @@
           <a:bodyPr wrap="square" lIns="0" tIns="0" rIns="0" bIns="0" rtlCol="0" anchor="ctr"/>
           <a:lstStyle/>
           <a:p>
-            <a:pPr marL="0" indent="0">
+            <a:pPr indent="0" marL="0">
               <a:buNone/>
             </a:pPr>
             <a:r>
@@ -2084,7 +2328,7 @@
                 <a:ea typeface="Microsoft YaHei" pitchFamily="34" charset="-122"/>
                 <a:cs typeface="Microsoft YaHei" pitchFamily="34" charset="-120"/>
               </a:rPr>
-              <a:t>ELISpot 真实数据跑通</a:t>
+              <a:t>用袁老师 ELISpot 真实数据跑通</a:t>
             </a:r>
             <a:endParaRPr lang="en-US" sz="3000" dirty="0"/>
           </a:p>
@@ -2111,7 +2355,7 @@
           <a:bodyPr wrap="square" lIns="0" tIns="0" rIns="0" bIns="0" rtlCol="0" anchor="t"/>
           <a:lstStyle/>
           <a:p>
-            <a:pPr marL="0" indent="0">
+            <a:pPr indent="0" marL="0">
               <a:lnSpc>
                 <a:spcPct val="110000"/>
               </a:lnSpc>
@@ -2132,7 +2376,7 @@
             <a:endParaRPr lang="en-US" sz="1400" dirty="0"/>
           </a:p>
           <a:p>
-            <a:pPr marL="0" indent="0">
+            <a:pPr indent="0" marL="0">
               <a:lnSpc>
                 <a:spcPct val="110000"/>
               </a:lnSpc>
@@ -2219,7 +2463,7 @@
           <a:bodyPr wrap="square" lIns="0" tIns="0" rIns="0" bIns="0" rtlCol="0" anchor="ctr"/>
           <a:lstStyle/>
           <a:p>
-            <a:pPr marL="0" indent="0">
+            <a:pPr indent="0" marL="0">
               <a:buNone/>
             </a:pPr>
             <a:r>
@@ -2258,7 +2502,7 @@
           <a:bodyPr wrap="square" lIns="0" tIns="0" rIns="0" bIns="0" rtlCol="0" anchor="ctr"/>
           <a:lstStyle/>
           <a:p>
-            <a:pPr marL="0" indent="0" algn="r">
+            <a:pPr algn="r" indent="0" marL="0">
               <a:buNone/>
             </a:pPr>
             <a:r>
@@ -2342,7 +2586,7 @@
           <a:bodyPr wrap="square" lIns="0" tIns="0" rIns="0" bIns="0" rtlCol="0" anchor="ctr"/>
           <a:lstStyle/>
           <a:p>
-            <a:pPr marL="0" indent="0">
+            <a:pPr indent="0" marL="0">
               <a:buNone/>
             </a:pPr>
             <a:r>
@@ -2381,7 +2625,7 @@
           <a:bodyPr wrap="square" lIns="0" tIns="0" rIns="0" bIns="0" rtlCol="0" anchor="ctr"/>
           <a:lstStyle/>
           <a:p>
-            <a:pPr marL="0" indent="0" algn="r">
+            <a:pPr algn="r" indent="0" marL="0">
               <a:buNone/>
             </a:pPr>
             <a:r>
@@ -2465,7 +2709,7 @@
           <a:bodyPr wrap="square" lIns="0" tIns="0" rIns="0" bIns="0" rtlCol="0" anchor="ctr"/>
           <a:lstStyle/>
           <a:p>
-            <a:pPr marL="0" indent="0">
+            <a:pPr indent="0" marL="0">
               <a:buNone/>
             </a:pPr>
             <a:r>
@@ -2504,7 +2748,7 @@
           <a:bodyPr wrap="square" lIns="0" tIns="0" rIns="0" bIns="0" rtlCol="0" anchor="ctr"/>
           <a:lstStyle/>
           <a:p>
-            <a:pPr marL="0" indent="0" algn="r">
+            <a:pPr algn="r" indent="0" marL="0">
               <a:buNone/>
             </a:pPr>
             <a:r>
@@ -2588,7 +2832,7 @@
           <a:bodyPr wrap="square" lIns="0" tIns="0" rIns="0" bIns="0" rtlCol="0" anchor="ctr"/>
           <a:lstStyle/>
           <a:p>
-            <a:pPr marL="0" indent="0">
+            <a:pPr indent="0" marL="0">
               <a:buNone/>
             </a:pPr>
             <a:r>
@@ -2627,7 +2871,7 @@
           <a:bodyPr wrap="square" lIns="0" tIns="0" rIns="0" bIns="0" rtlCol="0" anchor="ctr"/>
           <a:lstStyle/>
           <a:p>
-            <a:pPr marL="0" indent="0" algn="r">
+            <a:pPr algn="r" indent="0" marL="0">
               <a:buNone/>
             </a:pPr>
             <a:r>
@@ -2711,7 +2955,7 @@
           <a:bodyPr wrap="square" lIns="0" tIns="0" rIns="0" bIns="0" rtlCol="0" anchor="ctr"/>
           <a:lstStyle/>
           <a:p>
-            <a:pPr marL="0" indent="0">
+            <a:pPr indent="0" marL="0">
               <a:buNone/>
             </a:pPr>
             <a:r>
@@ -2750,7 +2994,7 @@
           <a:bodyPr wrap="square" lIns="0" tIns="0" rIns="0" bIns="0" rtlCol="0" anchor="ctr"/>
           <a:lstStyle/>
           <a:p>
-            <a:pPr marL="0" indent="0" algn="r">
+            <a:pPr algn="r" indent="0" marL="0">
               <a:buNone/>
             </a:pPr>
             <a:r>
@@ -2789,7 +3033,7 @@
           <a:bodyPr wrap="square" lIns="0" tIns="0" rIns="0" bIns="0" rtlCol="0" anchor="t"/>
           <a:lstStyle/>
           <a:p>
-            <a:pPr marL="0" indent="0">
+            <a:pPr indent="0" marL="0">
               <a:buNone/>
             </a:pPr>
             <a:r>
@@ -2831,7 +3075,7 @@
             <a:prstDash val="solid"/>
           </a:ln>
           <a:effectLst>
-            <a:outerShdw blurRad="114300" dist="38100" dir="8100000" algn="bl" rotWithShape="0">
+            <a:outerShdw sx="100000" sy="100000" kx="0" ky="0" algn="bl" rotWithShape="0" blurRad="114300" dist="38100" dir="8100000">
               <a:srgbClr val="0B3C49">
                 <a:alpha val="12000"/>
               </a:srgbClr>
@@ -2841,14 +3085,14 @@
       </p:sp>
       <p:pic>
         <p:nvPicPr>
-          <p:cNvPr id="28" name="Image 0" descr="D:/YJ-Agent/project/meeting/QuantImmuBench/analysis/figures/fig1_roc_curves_ds2.png"/>
+          <p:cNvPr id="28" name="Image 0" descr="D:/YJ-Agent/project/meeting/QuantImmuBench/analysis/figures/fig1_roc_curves_ds2.png">    </p:cNvPr>
           <p:cNvPicPr>
             <a:picLocks noChangeAspect="1"/>
           </p:cNvPicPr>
           <p:nvPr/>
         </p:nvPicPr>
         <p:blipFill>
-          <a:blip r:embed="rId3"/>
+          <a:blip r:embed="rId1"/>
           <a:stretch>
             <a:fillRect/>
           </a:stretch>
@@ -2884,7 +3128,7 @@
           <a:bodyPr wrap="square" lIns="0" tIns="0" rIns="0" bIns="0" rtlCol="0" anchor="ctr"/>
           <a:lstStyle/>
           <a:p>
-            <a:pPr marL="0" indent="0" algn="ctr">
+            <a:pPr algn="ctr" indent="0" marL="0">
               <a:buNone/>
             </a:pPr>
             <a:r>
@@ -2896,23 +3140,7 @@
                 <a:ea typeface="Microsoft YaHei" pitchFamily="34" charset="-122"/>
                 <a:cs typeface="Microsoft YaHei" pitchFamily="34" charset="-120"/>
               </a:rPr>
-              <a:t>5 工具 ROC (DS2, max 聚合, ELISpot&gt;0)；pTuneos AUC 最高 0.75。</a:t>
-            </a:r>
-          </a:p>
-          <a:p>
-            <a:pPr marL="0" indent="0" algn="ctr">
-              <a:buNone/>
-            </a:pPr>
-            <a:r>
-              <a:rPr lang="en-US" sz="950" i="1" dirty="0">
-                <a:solidFill>
-                  <a:srgbClr val="5E7B83"/>
-                </a:solidFill>
-                <a:latin typeface="Microsoft YaHei" pitchFamily="34" charset="0"/>
-                <a:ea typeface="Microsoft YaHei" pitchFamily="34" charset="-122"/>
-                <a:cs typeface="Microsoft YaHei" pitchFamily="34" charset="-120"/>
-              </a:rPr>
-              <a:t>DS2 阴性仅 11 → 非统计显著，演示用</a:t>
+              <a:t>5 工具 ROC (DS2, max 聚合, ELISpot&gt;0)；pTuneos AUC 最高 0.75。DS2 阴性仅 11 → 非统计显著，演示用</a:t>
             </a:r>
             <a:endParaRPr lang="en-US" sz="950" dirty="0"/>
           </a:p>
@@ -2939,7 +3167,7 @@
           <a:bodyPr wrap="square" lIns="0" tIns="0" rIns="0" bIns="0" rtlCol="0" anchor="ctr"/>
           <a:lstStyle/>
           <a:p>
-            <a:pPr marL="0" indent="0" algn="r">
+            <a:pPr algn="r" indent="0" marL="0">
               <a:buNone/>
             </a:pPr>
             <a:r>
@@ -2973,7 +3201,6 @@
         <a:solidFill>
           <a:srgbClr val="F2F7F7"/>
         </a:solidFill>
-        <a:effectLst/>
       </p:bgPr>
     </p:bg>
     <p:spTree>
@@ -3031,11 +3258,11 @@
           <a:bodyPr wrap="square" lIns="0" tIns="0" rIns="0" bIns="0" rtlCol="0" anchor="ctr"/>
           <a:lstStyle/>
           <a:p>
-            <a:pPr marL="0" indent="0">
-              <a:buNone/>
-            </a:pPr>
-            <a:r>
-              <a:rPr lang="en-US" sz="1200" b="1" kern="0" spc="300" dirty="0">
+            <a:pPr indent="0" marL="0">
+              <a:buNone/>
+            </a:pPr>
+            <a:r>
+              <a:rPr lang="en-US" sz="1200" b="1" spc="300" kern="0" dirty="0">
                 <a:solidFill>
                   <a:srgbClr val="028090"/>
                 </a:solidFill>
@@ -3070,7 +3297,7 @@
           <a:bodyPr wrap="square" lIns="0" tIns="0" rIns="0" bIns="0" rtlCol="0" anchor="ctr"/>
           <a:lstStyle/>
           <a:p>
-            <a:pPr marL="0" indent="0">
+            <a:pPr indent="0" marL="0">
               <a:buNone/>
             </a:pPr>
             <a:r>
@@ -3112,7 +3339,7 @@
             <a:prstDash val="solid"/>
           </a:ln>
           <a:effectLst>
-            <a:outerShdw blurRad="114300" dist="38100" dir="8100000" algn="bl" rotWithShape="0">
+            <a:outerShdw sx="100000" sy="100000" kx="0" ky="0" algn="bl" rotWithShape="0" blurRad="114300" dist="38100" dir="8100000">
               <a:srgbClr val="0B3C49">
                 <a:alpha val="12000"/>
               </a:srgbClr>
@@ -3122,15 +3349,15 @@
       </p:sp>
       <p:pic>
         <p:nvPicPr>
-          <p:cNvPr id="6" name="Image 0" descr="D:/YJ-Agent/project/meeting/QuantImmuBench/analysis/figures_R_v3/fig2_bar_v3.png"/>
+          <p:cNvPr id="6" name="Image 0" descr="D:/YJ-Agent/project/meeting/QuantImmuBench/analysis/figures_R_v3/fig2_bar_v3.png">    </p:cNvPr>
           <p:cNvPicPr>
             <a:picLocks noChangeAspect="1"/>
           </p:cNvPicPr>
           <p:nvPr/>
         </p:nvPicPr>
         <p:blipFill>
-          <a:blip r:embed="rId3"/>
-          <a:srcRect/>
+          <a:blip r:embed="rId1"/>
+          <a:srcRect l="0" r="0" t="0" b="0"/>
           <a:stretch/>
         </p:blipFill>
         <p:spPr>
@@ -3164,7 +3391,7 @@
           <a:bodyPr wrap="square" lIns="0" tIns="0" rIns="0" bIns="0" rtlCol="0" anchor="t"/>
           <a:lstStyle/>
           <a:p>
-            <a:pPr marL="0" indent="0">
+            <a:pPr indent="0" marL="0">
               <a:buNone/>
             </a:pPr>
             <a:r>
@@ -3206,7 +3433,7 @@
             <a:prstDash val="solid"/>
           </a:ln>
           <a:effectLst>
-            <a:outerShdw blurRad="114300" dist="38100" dir="8100000" algn="bl" rotWithShape="0">
+            <a:outerShdw sx="100000" sy="100000" kx="0" ky="0" algn="bl" rotWithShape="0" blurRad="114300" dist="38100" dir="8100000">
               <a:srgbClr val="0B3C49">
                 <a:alpha val="12000"/>
               </a:srgbClr>
@@ -3216,15 +3443,15 @@
       </p:sp>
       <p:pic>
         <p:nvPicPr>
-          <p:cNvPr id="9" name="Image 1" descr="D:/YJ-Agent/project/meeting/QuantImmuBench/analysis/figures_R_v3/fig3_scatter_v3.png"/>
+          <p:cNvPr id="9" name="Image 1" descr="D:/YJ-Agent/project/meeting/QuantImmuBench/analysis/figures_R_v3/fig3_scatter_v3.png">    </p:cNvPr>
           <p:cNvPicPr>
             <a:picLocks noChangeAspect="1"/>
           </p:cNvPicPr>
           <p:nvPr/>
         </p:nvPicPr>
         <p:blipFill>
-          <a:blip r:embed="rId4"/>
-          <a:srcRect/>
+          <a:blip r:embed="rId2"/>
+          <a:srcRect l="0" r="0" t="0" b="0"/>
           <a:stretch/>
         </p:blipFill>
         <p:spPr>
@@ -3258,7 +3485,7 @@
           <a:bodyPr wrap="square" lIns="0" tIns="0" rIns="0" bIns="0" rtlCol="0" anchor="t"/>
           <a:lstStyle/>
           <a:p>
-            <a:pPr marL="0" indent="0">
+            <a:pPr indent="0" marL="0">
               <a:buNone/>
             </a:pPr>
             <a:r>
@@ -3322,7 +3549,7 @@
           <a:bodyPr wrap="square" lIns="0" tIns="0" rIns="0" bIns="0" rtlCol="0" anchor="t"/>
           <a:lstStyle/>
           <a:p>
-            <a:pPr marL="0" indent="0">
+            <a:pPr indent="0" marL="0">
               <a:lnSpc>
                 <a:spcPct val="105000"/>
               </a:lnSpc>
@@ -3343,7 +3570,7 @@
             <a:endParaRPr lang="en-US" sz="1150" dirty="0"/>
           </a:p>
           <a:p>
-            <a:pPr marL="0" indent="0">
+            <a:pPr indent="0" marL="0">
               <a:lnSpc>
                 <a:spcPct val="105000"/>
               </a:lnSpc>
@@ -3410,7 +3637,7 @@
           <a:bodyPr wrap="square" lIns="0" tIns="0" rIns="0" bIns="0" rtlCol="0" anchor="t"/>
           <a:lstStyle/>
           <a:p>
-            <a:pPr marL="0" indent="0">
+            <a:pPr indent="0" marL="0">
               <a:lnSpc>
                 <a:spcPct val="105000"/>
               </a:lnSpc>
@@ -3431,7 +3658,7 @@
             <a:endParaRPr lang="en-US" sz="1150" dirty="0"/>
           </a:p>
           <a:p>
-            <a:pPr marL="0" indent="0">
+            <a:pPr indent="0" marL="0">
               <a:lnSpc>
                 <a:spcPct val="105000"/>
               </a:lnSpc>
@@ -3473,7 +3700,7 @@
           <a:bodyPr wrap="square" lIns="0" tIns="0" rIns="0" bIns="0" rtlCol="0" anchor="ctr"/>
           <a:lstStyle/>
           <a:p>
-            <a:pPr marL="0" indent="0" algn="r">
+            <a:pPr algn="r" indent="0" marL="0">
               <a:buNone/>
             </a:pPr>
             <a:r>
@@ -3507,7 +3734,6 @@
         <a:solidFill>
           <a:srgbClr val="0B3C49"/>
         </a:solidFill>
-        <a:effectLst/>
       </p:bgPr>
     </p:bg>
     <p:spTree>
@@ -3565,7 +3791,7 @@
           <a:bodyPr wrap="square" lIns="0" tIns="0" rIns="0" bIns="0" rtlCol="0" anchor="ctr"/>
           <a:lstStyle/>
           <a:p>
-            <a:pPr marL="0" indent="0">
+            <a:pPr indent="0" marL="0">
               <a:buNone/>
             </a:pPr>
             <a:r>
@@ -3604,7 +3830,7 @@
           <a:bodyPr wrap="square" lIns="0" tIns="0" rIns="0" bIns="0" rtlCol="0" anchor="ctr"/>
           <a:lstStyle/>
           <a:p>
-            <a:pPr marL="0" indent="0">
+            <a:pPr indent="0" marL="0">
               <a:buNone/>
             </a:pPr>
             <a:r>
@@ -3746,7 +3972,7 @@
           <a:bodyPr wrap="square" lIns="0" tIns="0" rIns="0" bIns="0" rtlCol="0" anchor="ctr"/>
           <a:lstStyle/>
           <a:p>
-            <a:pPr marL="0" indent="0">
+            <a:pPr indent="0" marL="0">
               <a:buNone/>
             </a:pPr>
             <a:r>
@@ -3830,7 +4056,7 @@
           <a:bodyPr wrap="square" lIns="0" tIns="0" rIns="0" bIns="0" rtlCol="0" anchor="ctr"/>
           <a:lstStyle/>
           <a:p>
-            <a:pPr marL="0" indent="0">
+            <a:pPr indent="0" marL="0">
               <a:buNone/>
             </a:pPr>
             <a:r>
@@ -3869,7 +4095,7 @@
           <a:bodyPr wrap="square" lIns="0" tIns="0" rIns="0" bIns="0" rtlCol="0" anchor="t"/>
           <a:lstStyle/>
           <a:p>
-            <a:pPr marL="0" indent="0">
+            <a:pPr indent="0" marL="0">
               <a:buNone/>
             </a:pPr>
             <a:r>
@@ -3953,7 +4179,7 @@
           <a:bodyPr wrap="square" lIns="0" tIns="0" rIns="0" bIns="0" rtlCol="0" anchor="ctr"/>
           <a:lstStyle/>
           <a:p>
-            <a:pPr marL="0" indent="0">
+            <a:pPr indent="0" marL="0">
               <a:buNone/>
             </a:pPr>
             <a:r>
@@ -3992,7 +4218,7 @@
           <a:bodyPr wrap="square" lIns="0" tIns="0" rIns="0" bIns="0" rtlCol="0" anchor="t"/>
           <a:lstStyle/>
           <a:p>
-            <a:pPr marL="0" indent="0">
+            <a:pPr indent="0" marL="0">
               <a:buNone/>
             </a:pPr>
             <a:r>
@@ -4076,7 +4302,7 @@
           <a:bodyPr wrap="square" lIns="0" tIns="0" rIns="0" bIns="0" rtlCol="0" anchor="ctr"/>
           <a:lstStyle/>
           <a:p>
-            <a:pPr marL="0" indent="0">
+            <a:pPr indent="0" marL="0">
               <a:buNone/>
             </a:pPr>
             <a:r>
@@ -4115,7 +4341,7 @@
           <a:bodyPr wrap="square" lIns="0" tIns="0" rIns="0" bIns="0" rtlCol="0" anchor="t"/>
           <a:lstStyle/>
           <a:p>
-            <a:pPr marL="0" indent="0">
+            <a:pPr indent="0" marL="0">
               <a:buNone/>
             </a:pPr>
             <a:r>
@@ -4199,11 +4425,11 @@
           <a:bodyPr wrap="square" lIns="0" tIns="0" rIns="0" bIns="0" rtlCol="0" anchor="ctr"/>
           <a:lstStyle/>
           <a:p>
-            <a:pPr marL="0" indent="0">
-              <a:buNone/>
-            </a:pPr>
-            <a:r>
-              <a:rPr lang="en-US" sz="1300" b="1" dirty="0" err="1">
+            <a:pPr indent="0" marL="0">
+              <a:buNone/>
+            </a:pPr>
+            <a:r>
+              <a:rPr lang="en-US" sz="1300" b="1" dirty="0">
                 <a:solidFill>
                   <a:srgbClr val="FFFFFF"/>
                 </a:solidFill>
@@ -4211,7 +4437,7 @@
                 <a:ea typeface="Microsoft YaHei" pitchFamily="34" charset="-122"/>
                 <a:cs typeface="Microsoft YaHei" pitchFamily="34" charset="-120"/>
               </a:rPr>
-              <a:t>正式数据</a:t>
+              <a:t>袁老师正式数据</a:t>
             </a:r>
             <a:endParaRPr lang="en-US" sz="1300" dirty="0"/>
           </a:p>
@@ -4238,7 +4464,7 @@
           <a:bodyPr wrap="square" lIns="0" tIns="0" rIns="0" bIns="0" rtlCol="0" anchor="t"/>
           <a:lstStyle/>
           <a:p>
-            <a:pPr marL="0" indent="0">
+            <a:pPr indent="0" marL="0">
               <a:buNone/>
             </a:pPr>
             <a:r>
@@ -4277,7 +4503,7 @@
           <a:bodyPr wrap="square" lIns="0" tIns="0" rIns="0" bIns="0" rtlCol="0" anchor="ctr"/>
           <a:lstStyle/>
           <a:p>
-            <a:pPr marL="0" indent="0">
+            <a:pPr indent="0" marL="0">
               <a:buNone/>
             </a:pPr>
             <a:r>
@@ -4311,7 +4537,6 @@
         <a:solidFill>
           <a:srgbClr val="F2F7F7"/>
         </a:solidFill>
-        <a:effectLst/>
       </p:bgPr>
     </p:bg>
     <p:spTree>
@@ -4369,11 +4594,11 @@
           <a:bodyPr wrap="square" lIns="0" tIns="0" rIns="0" bIns="0" rtlCol="0" anchor="ctr"/>
           <a:lstStyle/>
           <a:p>
-            <a:pPr marL="0" indent="0">
-              <a:buNone/>
-            </a:pPr>
-            <a:r>
-              <a:rPr lang="en-US" sz="1200" b="1" kern="0" spc="300" dirty="0">
+            <a:pPr indent="0" marL="0">
+              <a:buNone/>
+            </a:pPr>
+            <a:r>
+              <a:rPr lang="en-US" sz="1200" b="1" spc="300" kern="0" dirty="0">
                 <a:solidFill>
                   <a:srgbClr val="028090"/>
                 </a:solidFill>
@@ -4408,7 +4633,7 @@
           <a:bodyPr wrap="square" lIns="0" tIns="0" rIns="0" bIns="0" rtlCol="0" anchor="ctr"/>
           <a:lstStyle/>
           <a:p>
-            <a:pPr marL="0" indent="0">
+            <a:pPr indent="0" marL="0">
               <a:buNone/>
             </a:pPr>
             <a:r>
@@ -4445,7 +4670,7 @@
           </a:solidFill>
           <a:ln/>
           <a:effectLst>
-            <a:outerShdw blurRad="114300" dist="38100" dir="8100000" algn="bl" rotWithShape="0">
+            <a:outerShdw sx="100000" sy="100000" kx="0" ky="0" algn="bl" rotWithShape="0" blurRad="114300" dist="38100" dir="8100000">
               <a:srgbClr val="0B3C49">
                 <a:alpha val="12000"/>
               </a:srgbClr>
@@ -4474,7 +4699,7 @@
           <a:bodyPr wrap="square" lIns="0" tIns="0" rIns="0" bIns="0" rtlCol="0" anchor="ctr"/>
           <a:lstStyle/>
           <a:p>
-            <a:pPr marL="0" indent="0">
+            <a:pPr indent="0" marL="0">
               <a:buNone/>
             </a:pPr>
             <a:r>
@@ -4513,7 +4738,7 @@
           <a:bodyPr wrap="square" lIns="0" tIns="0" rIns="0" bIns="0" rtlCol="0" anchor="t"/>
           <a:lstStyle/>
           <a:p>
-            <a:pPr marL="0" indent="0">
+            <a:pPr indent="0" marL="0">
               <a:lnSpc>
                 <a:spcPct val="115000"/>
               </a:lnSpc>
@@ -4533,7 +4758,7 @@
             <a:endParaRPr lang="en-US" sz="1500" dirty="0"/>
           </a:p>
           <a:p>
-            <a:pPr marL="0" indent="0">
+            <a:pPr indent="0" marL="0">
               <a:lnSpc>
                 <a:spcPct val="115000"/>
               </a:lnSpc>
@@ -4553,7 +4778,7 @@
             <a:endParaRPr lang="en-US" sz="1500" dirty="0"/>
           </a:p>
           <a:p>
-            <a:pPr marL="0" indent="0">
+            <a:pPr indent="0" marL="0">
               <a:lnSpc>
                 <a:spcPct val="115000"/>
               </a:lnSpc>
@@ -4595,7 +4820,7 @@
           <a:bodyPr wrap="square" lIns="0" tIns="0" rIns="0" bIns="0" rtlCol="0" anchor="t"/>
           <a:lstStyle/>
           <a:p>
-            <a:pPr marL="0" indent="0">
+            <a:pPr indent="0" marL="0">
               <a:buNone/>
             </a:pPr>
             <a:r>
@@ -4613,7 +4838,7 @@
             <a:endParaRPr lang="en-US" sz="1300" dirty="0"/>
           </a:p>
           <a:p>
-            <a:pPr marL="0" indent="0">
+            <a:pPr indent="0" marL="0">
               <a:buNone/>
             </a:pPr>
             <a:r>
@@ -4652,7 +4877,7 @@
           <a:bodyPr wrap="square" lIns="0" tIns="0" rIns="0" bIns="0" rtlCol="0" anchor="t"/>
           <a:lstStyle/>
           <a:p>
-            <a:pPr marL="0" indent="0">
+            <a:pPr indent="0" marL="0">
               <a:buNone/>
             </a:pPr>
             <a:r>
@@ -4691,7 +4916,7 @@
           <a:bodyPr wrap="square" lIns="0" tIns="0" rIns="0" bIns="0" rtlCol="0" anchor="ctr"/>
           <a:lstStyle/>
           <a:p>
-            <a:pPr marL="0" indent="0">
+            <a:pPr indent="0" marL="0">
               <a:buNone/>
             </a:pPr>
             <a:r>
@@ -4733,7 +4958,7 @@
             <a:prstDash val="solid"/>
           </a:ln>
           <a:effectLst>
-            <a:outerShdw blurRad="114300" dist="38100" dir="8100000" algn="bl" rotWithShape="0">
+            <a:outerShdw sx="100000" sy="100000" kx="0" ky="0" algn="bl" rotWithShape="0" blurRad="114300" dist="38100" dir="8100000">
               <a:srgbClr val="0B3C49">
                 <a:alpha val="12000"/>
               </a:srgbClr>
@@ -4782,7 +5007,7 @@
           <a:bodyPr wrap="square" lIns="0" tIns="0" rIns="0" bIns="0" rtlCol="0" anchor="ctr"/>
           <a:lstStyle/>
           <a:p>
-            <a:pPr marL="0" indent="0" algn="ctr">
+            <a:pPr algn="ctr" indent="0" marL="0">
               <a:buNone/>
             </a:pPr>
             <a:r>
@@ -4821,7 +5046,7 @@
           <a:bodyPr wrap="square" lIns="0" tIns="0" rIns="0" bIns="0" rtlCol="0" anchor="ctr"/>
           <a:lstStyle/>
           <a:p>
-            <a:pPr marL="0" indent="0">
+            <a:pPr indent="0" marL="0">
               <a:buNone/>
             </a:pPr>
             <a:r>
@@ -4860,7 +5085,7 @@
           <a:bodyPr wrap="square" lIns="0" tIns="0" rIns="0" bIns="0" rtlCol="0" anchor="ctr"/>
           <a:lstStyle/>
           <a:p>
-            <a:pPr marL="0" indent="0">
+            <a:pPr indent="0" marL="0">
               <a:buNone/>
             </a:pPr>
             <a:r>
@@ -4902,7 +5127,7 @@
             <a:prstDash val="solid"/>
           </a:ln>
           <a:effectLst>
-            <a:outerShdw blurRad="114300" dist="38100" dir="8100000" algn="bl" rotWithShape="0">
+            <a:outerShdw sx="100000" sy="100000" kx="0" ky="0" algn="bl" rotWithShape="0" blurRad="114300" dist="38100" dir="8100000">
               <a:srgbClr val="0B3C49">
                 <a:alpha val="12000"/>
               </a:srgbClr>
@@ -4951,7 +5176,7 @@
           <a:bodyPr wrap="square" lIns="0" tIns="0" rIns="0" bIns="0" rtlCol="0" anchor="ctr"/>
           <a:lstStyle/>
           <a:p>
-            <a:pPr marL="0" indent="0" algn="ctr">
+            <a:pPr algn="ctr" indent="0" marL="0">
               <a:buNone/>
             </a:pPr>
             <a:r>
@@ -4990,7 +5215,7 @@
           <a:bodyPr wrap="square" lIns="0" tIns="0" rIns="0" bIns="0" rtlCol="0" anchor="ctr"/>
           <a:lstStyle/>
           <a:p>
-            <a:pPr marL="0" indent="0">
+            <a:pPr indent="0" marL="0">
               <a:buNone/>
             </a:pPr>
             <a:r>
@@ -5029,7 +5254,7 @@
           <a:bodyPr wrap="square" lIns="0" tIns="0" rIns="0" bIns="0" rtlCol="0" anchor="ctr"/>
           <a:lstStyle/>
           <a:p>
-            <a:pPr marL="0" indent="0">
+            <a:pPr indent="0" marL="0">
               <a:buNone/>
             </a:pPr>
             <a:r>
@@ -5071,7 +5296,7 @@
             <a:prstDash val="solid"/>
           </a:ln>
           <a:effectLst>
-            <a:outerShdw blurRad="114300" dist="38100" dir="8100000" algn="bl" rotWithShape="0">
+            <a:outerShdw sx="100000" sy="100000" kx="0" ky="0" algn="bl" rotWithShape="0" blurRad="114300" dist="38100" dir="8100000">
               <a:srgbClr val="0B3C49">
                 <a:alpha val="12000"/>
               </a:srgbClr>
@@ -5120,7 +5345,7 @@
           <a:bodyPr wrap="square" lIns="0" tIns="0" rIns="0" bIns="0" rtlCol="0" anchor="ctr"/>
           <a:lstStyle/>
           <a:p>
-            <a:pPr marL="0" indent="0" algn="ctr">
+            <a:pPr algn="ctr" indent="0" marL="0">
               <a:buNone/>
             </a:pPr>
             <a:r>
@@ -5159,7 +5384,7 @@
           <a:bodyPr wrap="square" lIns="0" tIns="0" rIns="0" bIns="0" rtlCol="0" anchor="ctr"/>
           <a:lstStyle/>
           <a:p>
-            <a:pPr marL="0" indent="0">
+            <a:pPr indent="0" marL="0">
               <a:buNone/>
             </a:pPr>
             <a:r>
@@ -5198,7 +5423,7 @@
           <a:bodyPr wrap="square" lIns="0" tIns="0" rIns="0" bIns="0" rtlCol="0" anchor="ctr"/>
           <a:lstStyle/>
           <a:p>
-            <a:pPr marL="0" indent="0">
+            <a:pPr indent="0" marL="0">
               <a:buNone/>
             </a:pPr>
             <a:r>
@@ -5240,7 +5465,7 @@
             <a:prstDash val="solid"/>
           </a:ln>
           <a:effectLst>
-            <a:outerShdw blurRad="114300" dist="38100" dir="8100000" algn="bl" rotWithShape="0">
+            <a:outerShdw sx="100000" sy="100000" kx="0" ky="0" algn="bl" rotWithShape="0" blurRad="114300" dist="38100" dir="8100000">
               <a:srgbClr val="0B3C49">
                 <a:alpha val="12000"/>
               </a:srgbClr>
@@ -5289,7 +5514,7 @@
           <a:bodyPr wrap="square" lIns="0" tIns="0" rIns="0" bIns="0" rtlCol="0" anchor="ctr"/>
           <a:lstStyle/>
           <a:p>
-            <a:pPr marL="0" indent="0" algn="ctr">
+            <a:pPr algn="ctr" indent="0" marL="0">
               <a:buNone/>
             </a:pPr>
             <a:r>
@@ -5328,7 +5553,7 @@
           <a:bodyPr wrap="square" lIns="0" tIns="0" rIns="0" bIns="0" rtlCol="0" anchor="ctr"/>
           <a:lstStyle/>
           <a:p>
-            <a:pPr marL="0" indent="0">
+            <a:pPr indent="0" marL="0">
               <a:buNone/>
             </a:pPr>
             <a:r>
@@ -5367,7 +5592,7 @@
           <a:bodyPr wrap="square" lIns="0" tIns="0" rIns="0" bIns="0" rtlCol="0" anchor="ctr"/>
           <a:lstStyle/>
           <a:p>
-            <a:pPr marL="0" indent="0">
+            <a:pPr indent="0" marL="0">
               <a:buNone/>
             </a:pPr>
             <a:r>
@@ -5406,7 +5631,7 @@
           <a:bodyPr wrap="square" lIns="0" tIns="0" rIns="0" bIns="0" rtlCol="0" anchor="ctr"/>
           <a:lstStyle/>
           <a:p>
-            <a:pPr marL="0" indent="0" algn="r">
+            <a:pPr algn="r" indent="0" marL="0">
               <a:buNone/>
             </a:pPr>
             <a:r>
@@ -5440,7 +5665,6 @@
         <a:solidFill>
           <a:srgbClr val="F2F7F7"/>
         </a:solidFill>
-        <a:effectLst/>
       </p:bgPr>
     </p:bg>
     <p:spTree>
@@ -5498,11 +5722,11 @@
           <a:bodyPr wrap="square" lIns="0" tIns="0" rIns="0" bIns="0" rtlCol="0" anchor="ctr"/>
           <a:lstStyle/>
           <a:p>
-            <a:pPr marL="0" indent="0">
-              <a:buNone/>
-            </a:pPr>
-            <a:r>
-              <a:rPr lang="en-US" sz="1200" b="1" kern="0" spc="300" dirty="0">
+            <a:pPr indent="0" marL="0">
+              <a:buNone/>
+            </a:pPr>
+            <a:r>
+              <a:rPr lang="en-US" sz="1200" b="1" spc="300" kern="0" dirty="0">
                 <a:solidFill>
                   <a:srgbClr val="028090"/>
                 </a:solidFill>
@@ -5537,7 +5761,7 @@
           <a:bodyPr wrap="square" lIns="0" tIns="0" rIns="0" bIns="0" rtlCol="0" anchor="ctr"/>
           <a:lstStyle/>
           <a:p>
-            <a:pPr marL="0" indent="0">
+            <a:pPr indent="0" marL="0">
               <a:buNone/>
             </a:pPr>
             <a:r>
@@ -5557,7 +5781,7 @@
       </p:sp>
       <p:graphicFrame>
         <p:nvGraphicFramePr>
-          <p:cNvPr id="5" name="Table 0"/>
+          <p:cNvPr id="4" name="Table 0"/>
           <p:cNvGraphicFramePr>
             <a:graphicFrameLocks noGrp="1"/>
           </p:cNvGraphicFramePr>
@@ -5571,55 +5795,19 @@
         </p:nvGraphicFramePr>
         <p:xfrm>
           <a:off x="640080" y="1783080"/>
-          <a:ext cx="10881360" cy="3337560"/>
+          <a:ext cx="10881360" cy="914400"/>
         </p:xfrm>
         <a:graphic>
           <a:graphicData uri="http://schemas.openxmlformats.org/drawingml/2006/table">
             <a:tbl>
               <a:tblPr/>
               <a:tblGrid>
-                <a:gridCol w="1828800">
-                  <a:extLst>
-                    <a:ext uri="{9D8B030D-6E8A-4147-A177-3AD203B41FA5}">
-                      <a16:colId xmlns:a16="http://schemas.microsoft.com/office/drawing/2014/main" val="20000"/>
-                    </a:ext>
-                  </a:extLst>
-                </a:gridCol>
-                <a:gridCol w="1737360">
-                  <a:extLst>
-                    <a:ext uri="{9D8B030D-6E8A-4147-A177-3AD203B41FA5}">
-                      <a16:colId xmlns:a16="http://schemas.microsoft.com/office/drawing/2014/main" val="20001"/>
-                    </a:ext>
-                  </a:extLst>
-                </a:gridCol>
-                <a:gridCol w="2103120">
-                  <a:extLst>
-                    <a:ext uri="{9D8B030D-6E8A-4147-A177-3AD203B41FA5}">
-                      <a16:colId xmlns:a16="http://schemas.microsoft.com/office/drawing/2014/main" val="20002"/>
-                    </a:ext>
-                  </a:extLst>
-                </a:gridCol>
-                <a:gridCol w="1691640">
-                  <a:extLst>
-                    <a:ext uri="{9D8B030D-6E8A-4147-A177-3AD203B41FA5}">
-                      <a16:colId xmlns:a16="http://schemas.microsoft.com/office/drawing/2014/main" val="20003"/>
-                    </a:ext>
-                  </a:extLst>
-                </a:gridCol>
-                <a:gridCol w="1554480">
-                  <a:extLst>
-                    <a:ext uri="{9D8B030D-6E8A-4147-A177-3AD203B41FA5}">
-                      <a16:colId xmlns:a16="http://schemas.microsoft.com/office/drawing/2014/main" val="20004"/>
-                    </a:ext>
-                  </a:extLst>
-                </a:gridCol>
-                <a:gridCol w="1965960">
-                  <a:extLst>
-                    <a:ext uri="{9D8B030D-6E8A-4147-A177-3AD203B41FA5}">
-                      <a16:colId xmlns:a16="http://schemas.microsoft.com/office/drawing/2014/main" val="20005"/>
-                    </a:ext>
-                  </a:extLst>
-                </a:gridCol>
+                <a:gridCol w="1828800"/>
+                <a:gridCol w="1737360"/>
+                <a:gridCol w="2103120"/>
+                <a:gridCol w="1691640"/>
+                <a:gridCol w="1554480"/>
+                <a:gridCol w="1965960"/>
               </a:tblGrid>
               <a:tr h="502920">
                 <a:tc>
@@ -5627,7 +5815,7 @@
                     <a:bodyPr/>
                     <a:lstStyle/>
                     <a:p>
-                      <a:pPr marL="0" indent="0" algn="ctr">
+                      <a:pPr algn="ctr" indent="0" marL="0">
                         <a:buNone/>
                       </a:pPr>
                       <a:r>
@@ -5648,7 +5836,7 @@
                       </a:endParaRPr>
                     </a:p>
                   </a:txBody>
-                  <a:tcPr anchor="ctr">
+                  <a:tcPr marL="91440" marR="91440" marT="45720" marB="45720" anchor="ctr">
                     <a:lnL w="12700" cap="flat" cmpd="sng" algn="ctr">
                       <a:solidFill>
                         <a:srgbClr val="D5E3E4"/>
@@ -5695,7 +5883,7 @@
                     <a:bodyPr/>
                     <a:lstStyle/>
                     <a:p>
-                      <a:pPr marL="0" indent="0" algn="ctr">
+                      <a:pPr algn="ctr" indent="0" marL="0">
                         <a:buNone/>
                       </a:pPr>
                       <a:r>
@@ -5716,7 +5904,7 @@
                       </a:endParaRPr>
                     </a:p>
                   </a:txBody>
-                  <a:tcPr anchor="ctr">
+                  <a:tcPr marL="91440" marR="91440" marT="45720" marB="45720" anchor="ctr">
                     <a:lnL w="12700" cap="flat" cmpd="sng" algn="ctr">
                       <a:solidFill>
                         <a:srgbClr val="D5E3E4"/>
@@ -5763,7 +5951,7 @@
                     <a:bodyPr/>
                     <a:lstStyle/>
                     <a:p>
-                      <a:pPr marL="0" indent="0" algn="ctr">
+                      <a:pPr algn="ctr" indent="0" marL="0">
                         <a:buNone/>
                       </a:pPr>
                       <a:r>
@@ -5784,7 +5972,7 @@
                       </a:endParaRPr>
                     </a:p>
                   </a:txBody>
-                  <a:tcPr anchor="ctr">
+                  <a:tcPr marL="91440" marR="91440" marT="45720" marB="45720" anchor="ctr">
                     <a:lnL w="12700" cap="flat" cmpd="sng" algn="ctr">
                       <a:solidFill>
                         <a:srgbClr val="D5E3E4"/>
@@ -5831,7 +6019,7 @@
                     <a:bodyPr/>
                     <a:lstStyle/>
                     <a:p>
-                      <a:pPr marL="0" indent="0" algn="ctr">
+                      <a:pPr algn="ctr" indent="0" marL="0">
                         <a:buNone/>
                       </a:pPr>
                       <a:r>
@@ -5852,7 +6040,7 @@
                       </a:endParaRPr>
                     </a:p>
                   </a:txBody>
-                  <a:tcPr anchor="ctr">
+                  <a:tcPr marL="91440" marR="91440" marT="45720" marB="45720" anchor="ctr">
                     <a:lnL w="12700" cap="flat" cmpd="sng" algn="ctr">
                       <a:solidFill>
                         <a:srgbClr val="D5E3E4"/>
@@ -5899,7 +6087,7 @@
                     <a:bodyPr/>
                     <a:lstStyle/>
                     <a:p>
-                      <a:pPr marL="0" indent="0" algn="ctr">
+                      <a:pPr algn="ctr" indent="0" marL="0">
                         <a:buNone/>
                       </a:pPr>
                       <a:r>
@@ -5920,7 +6108,7 @@
                       </a:endParaRPr>
                     </a:p>
                   </a:txBody>
-                  <a:tcPr anchor="ctr">
+                  <a:tcPr marL="91440" marR="91440" marT="45720" marB="45720" anchor="ctr">
                     <a:lnL w="12700" cap="flat" cmpd="sng" algn="ctr">
                       <a:solidFill>
                         <a:srgbClr val="D5E3E4"/>
@@ -5967,7 +6155,7 @@
                     <a:bodyPr/>
                     <a:lstStyle/>
                     <a:p>
-                      <a:pPr marL="0" indent="0" algn="ctr">
+                      <a:pPr algn="ctr" indent="0" marL="0">
                         <a:buNone/>
                       </a:pPr>
                       <a:r>
@@ -5988,7 +6176,7 @@
                       </a:endParaRPr>
                     </a:p>
                   </a:txBody>
-                  <a:tcPr anchor="ctr">
+                  <a:tcPr marL="91440" marR="91440" marT="45720" marB="45720" anchor="ctr">
                     <a:lnL w="12700" cap="flat" cmpd="sng" algn="ctr">
                       <a:solidFill>
                         <a:srgbClr val="D5E3E4"/>
@@ -6030,11 +6218,6 @@
                     </a:solidFill>
                   </a:tcPr>
                 </a:tc>
-                <a:extLst>
-                  <a:ext uri="{0D108BD9-81ED-4DB2-BD59-A6C34878D82A}">
-                    <a16:rowId xmlns:a16="http://schemas.microsoft.com/office/drawing/2014/main" val="10000"/>
-                  </a:ext>
-                </a:extLst>
               </a:tr>
               <a:tr h="566928">
                 <a:tc>
@@ -6042,7 +6225,7 @@
                     <a:bodyPr/>
                     <a:lstStyle/>
                     <a:p>
-                      <a:pPr marL="0" indent="0" algn="l">
+                      <a:pPr algn="l" indent="0" marL="0">
                         <a:buNone/>
                       </a:pPr>
                       <a:r>
@@ -6063,7 +6246,7 @@
                       </a:endParaRPr>
                     </a:p>
                   </a:txBody>
-                  <a:tcPr anchor="ctr">
+                  <a:tcPr marL="91440" marR="91440" marT="45720" marB="45720" anchor="ctr">
                     <a:lnL w="12700" cap="flat" cmpd="sng" algn="ctr">
                       <a:solidFill>
                         <a:srgbClr val="D5E3E4"/>
@@ -6110,7 +6293,7 @@
                     <a:bodyPr/>
                     <a:lstStyle/>
                     <a:p>
-                      <a:pPr marL="0" indent="0" algn="ctr">
+                      <a:pPr algn="ctr" indent="0" marL="0">
                         <a:buNone/>
                       </a:pPr>
                       <a:r>
@@ -6131,7 +6314,7 @@
                       </a:endParaRPr>
                     </a:p>
                   </a:txBody>
-                  <a:tcPr anchor="ctr">
+                  <a:tcPr marL="91440" marR="91440" marT="45720" marB="45720" anchor="ctr">
                     <a:lnL w="12700" cap="flat" cmpd="sng" algn="ctr">
                       <a:solidFill>
                         <a:srgbClr val="D5E3E4"/>
@@ -6178,7 +6361,7 @@
                     <a:bodyPr/>
                     <a:lstStyle/>
                     <a:p>
-                      <a:pPr marL="0" indent="0" algn="ctr">
+                      <a:pPr algn="ctr" indent="0" marL="0">
                         <a:buNone/>
                       </a:pPr>
                       <a:r>
@@ -6199,7 +6382,7 @@
                       </a:endParaRPr>
                     </a:p>
                   </a:txBody>
-                  <a:tcPr anchor="ctr">
+                  <a:tcPr marL="91440" marR="91440" marT="45720" marB="45720" anchor="ctr">
                     <a:lnL w="12700" cap="flat" cmpd="sng" algn="ctr">
                       <a:solidFill>
                         <a:srgbClr val="D5E3E4"/>
@@ -6246,7 +6429,7 @@
                     <a:bodyPr/>
                     <a:lstStyle/>
                     <a:p>
-                      <a:pPr marL="0" indent="0" algn="ctr">
+                      <a:pPr algn="ctr" indent="0" marL="0">
                         <a:buNone/>
                       </a:pPr>
                       <a:r>
@@ -6267,7 +6450,7 @@
                       </a:endParaRPr>
                     </a:p>
                   </a:txBody>
-                  <a:tcPr anchor="ctr">
+                  <a:tcPr marL="91440" marR="91440" marT="45720" marB="45720" anchor="ctr">
                     <a:lnL w="12700" cap="flat" cmpd="sng" algn="ctr">
                       <a:solidFill>
                         <a:srgbClr val="D5E3E4"/>
@@ -6314,7 +6497,7 @@
                     <a:bodyPr/>
                     <a:lstStyle/>
                     <a:p>
-                      <a:pPr marL="0" indent="0" algn="ctr">
+                      <a:pPr algn="ctr" indent="0" marL="0">
                         <a:buNone/>
                       </a:pPr>
                       <a:r>
@@ -6335,7 +6518,7 @@
                       </a:endParaRPr>
                     </a:p>
                   </a:txBody>
-                  <a:tcPr anchor="ctr">
+                  <a:tcPr marL="91440" marR="91440" marT="45720" marB="45720" anchor="ctr">
                     <a:lnL w="12700" cap="flat" cmpd="sng" algn="ctr">
                       <a:solidFill>
                         <a:srgbClr val="D5E3E4"/>
@@ -6382,7 +6565,7 @@
                     <a:bodyPr/>
                     <a:lstStyle/>
                     <a:p>
-                      <a:pPr marL="0" indent="0" algn="ctr">
+                      <a:pPr algn="ctr" indent="0" marL="0">
                         <a:buNone/>
                       </a:pPr>
                       <a:r>
@@ -6403,7 +6586,7 @@
                       </a:endParaRPr>
                     </a:p>
                   </a:txBody>
-                  <a:tcPr anchor="ctr">
+                  <a:tcPr marL="91440" marR="91440" marT="45720" marB="45720" anchor="ctr">
                     <a:lnL w="12700" cap="flat" cmpd="sng" algn="ctr">
                       <a:solidFill>
                         <a:srgbClr val="D5E3E4"/>
@@ -6445,11 +6628,6 @@
                     </a:solidFill>
                   </a:tcPr>
                 </a:tc>
-                <a:extLst>
-                  <a:ext uri="{0D108BD9-81ED-4DB2-BD59-A6C34878D82A}">
-                    <a16:rowId xmlns:a16="http://schemas.microsoft.com/office/drawing/2014/main" val="10001"/>
-                  </a:ext>
-                </a:extLst>
               </a:tr>
               <a:tr h="566928">
                 <a:tc>
@@ -6457,7 +6635,7 @@
                     <a:bodyPr/>
                     <a:lstStyle/>
                     <a:p>
-                      <a:pPr marL="0" indent="0" algn="l">
+                      <a:pPr algn="l" indent="0" marL="0">
                         <a:buNone/>
                       </a:pPr>
                       <a:r>
@@ -6478,7 +6656,7 @@
                       </a:endParaRPr>
                     </a:p>
                   </a:txBody>
-                  <a:tcPr anchor="ctr">
+                  <a:tcPr marL="91440" marR="91440" marT="45720" marB="45720" anchor="ctr">
                     <a:lnL w="12700" cap="flat" cmpd="sng" algn="ctr">
                       <a:solidFill>
                         <a:srgbClr val="D5E3E4"/>
@@ -6525,7 +6703,7 @@
                     <a:bodyPr/>
                     <a:lstStyle/>
                     <a:p>
-                      <a:pPr marL="0" indent="0" algn="ctr">
+                      <a:pPr algn="ctr" indent="0" marL="0">
                         <a:buNone/>
                       </a:pPr>
                       <a:r>
@@ -6546,7 +6724,7 @@
                       </a:endParaRPr>
                     </a:p>
                   </a:txBody>
-                  <a:tcPr anchor="ctr">
+                  <a:tcPr marL="91440" marR="91440" marT="45720" marB="45720" anchor="ctr">
                     <a:lnL w="12700" cap="flat" cmpd="sng" algn="ctr">
                       <a:solidFill>
                         <a:srgbClr val="D5E3E4"/>
@@ -6593,7 +6771,7 @@
                     <a:bodyPr/>
                     <a:lstStyle/>
                     <a:p>
-                      <a:pPr marL="0" indent="0" algn="ctr">
+                      <a:pPr algn="ctr" indent="0" marL="0">
                         <a:buNone/>
                       </a:pPr>
                       <a:r>
@@ -6614,7 +6792,7 @@
                       </a:endParaRPr>
                     </a:p>
                   </a:txBody>
-                  <a:tcPr anchor="ctr">
+                  <a:tcPr marL="91440" marR="91440" marT="45720" marB="45720" anchor="ctr">
                     <a:lnL w="12700" cap="flat" cmpd="sng" algn="ctr">
                       <a:solidFill>
                         <a:srgbClr val="D5E3E4"/>
@@ -6661,7 +6839,7 @@
                     <a:bodyPr/>
                     <a:lstStyle/>
                     <a:p>
-                      <a:pPr marL="0" indent="0" algn="ctr">
+                      <a:pPr algn="ctr" indent="0" marL="0">
                         <a:buNone/>
                       </a:pPr>
                       <a:r>
@@ -6682,7 +6860,7 @@
                       </a:endParaRPr>
                     </a:p>
                   </a:txBody>
-                  <a:tcPr anchor="ctr">
+                  <a:tcPr marL="91440" marR="91440" marT="45720" marB="45720" anchor="ctr">
                     <a:lnL w="12700" cap="flat" cmpd="sng" algn="ctr">
                       <a:solidFill>
                         <a:srgbClr val="D5E3E4"/>
@@ -6729,7 +6907,7 @@
                     <a:bodyPr/>
                     <a:lstStyle/>
                     <a:p>
-                      <a:pPr marL="0" indent="0" algn="ctr">
+                      <a:pPr algn="ctr" indent="0" marL="0">
                         <a:buNone/>
                       </a:pPr>
                       <a:r>
@@ -6750,7 +6928,7 @@
                       </a:endParaRPr>
                     </a:p>
                   </a:txBody>
-                  <a:tcPr anchor="ctr">
+                  <a:tcPr marL="91440" marR="91440" marT="45720" marB="45720" anchor="ctr">
                     <a:lnL w="12700" cap="flat" cmpd="sng" algn="ctr">
                       <a:solidFill>
                         <a:srgbClr val="D5E3E4"/>
@@ -6797,7 +6975,7 @@
                     <a:bodyPr/>
                     <a:lstStyle/>
                     <a:p>
-                      <a:pPr marL="0" indent="0" algn="ctr">
+                      <a:pPr algn="ctr" indent="0" marL="0">
                         <a:buNone/>
                       </a:pPr>
                       <a:r>
@@ -6818,7 +6996,7 @@
                       </a:endParaRPr>
                     </a:p>
                   </a:txBody>
-                  <a:tcPr anchor="ctr">
+                  <a:tcPr marL="91440" marR="91440" marT="45720" marB="45720" anchor="ctr">
                     <a:lnL w="12700" cap="flat" cmpd="sng" algn="ctr">
                       <a:solidFill>
                         <a:srgbClr val="D5E3E4"/>
@@ -6860,11 +7038,6 @@
                     </a:solidFill>
                   </a:tcPr>
                 </a:tc>
-                <a:extLst>
-                  <a:ext uri="{0D108BD9-81ED-4DB2-BD59-A6C34878D82A}">
-                    <a16:rowId xmlns:a16="http://schemas.microsoft.com/office/drawing/2014/main" val="10002"/>
-                  </a:ext>
-                </a:extLst>
               </a:tr>
               <a:tr h="566928">
                 <a:tc>
@@ -6872,7 +7045,7 @@
                     <a:bodyPr/>
                     <a:lstStyle/>
                     <a:p>
-                      <a:pPr marL="0" indent="0" algn="l">
+                      <a:pPr algn="l" indent="0" marL="0">
                         <a:buNone/>
                       </a:pPr>
                       <a:r>
@@ -6893,7 +7066,7 @@
                       </a:endParaRPr>
                     </a:p>
                   </a:txBody>
-                  <a:tcPr anchor="ctr">
+                  <a:tcPr marL="91440" marR="91440" marT="45720" marB="45720" anchor="ctr">
                     <a:lnL w="12700" cap="flat" cmpd="sng" algn="ctr">
                       <a:solidFill>
                         <a:srgbClr val="D5E3E4"/>
@@ -6940,7 +7113,7 @@
                     <a:bodyPr/>
                     <a:lstStyle/>
                     <a:p>
-                      <a:pPr marL="0" indent="0" algn="ctr">
+                      <a:pPr algn="ctr" indent="0" marL="0">
                         <a:buNone/>
                       </a:pPr>
                       <a:r>
@@ -6961,7 +7134,7 @@
                       </a:endParaRPr>
                     </a:p>
                   </a:txBody>
-                  <a:tcPr anchor="ctr">
+                  <a:tcPr marL="91440" marR="91440" marT="45720" marB="45720" anchor="ctr">
                     <a:lnL w="12700" cap="flat" cmpd="sng" algn="ctr">
                       <a:solidFill>
                         <a:srgbClr val="D5E3E4"/>
@@ -7008,7 +7181,7 @@
                     <a:bodyPr/>
                     <a:lstStyle/>
                     <a:p>
-                      <a:pPr marL="0" indent="0" algn="ctr">
+                      <a:pPr algn="ctr" indent="0" marL="0">
                         <a:buNone/>
                       </a:pPr>
                       <a:r>
@@ -7029,7 +7202,7 @@
                       </a:endParaRPr>
                     </a:p>
                   </a:txBody>
-                  <a:tcPr anchor="ctr">
+                  <a:tcPr marL="91440" marR="91440" marT="45720" marB="45720" anchor="ctr">
                     <a:lnL w="12700" cap="flat" cmpd="sng" algn="ctr">
                       <a:solidFill>
                         <a:srgbClr val="D5E3E4"/>
@@ -7076,7 +7249,7 @@
                     <a:bodyPr/>
                     <a:lstStyle/>
                     <a:p>
-                      <a:pPr marL="0" indent="0" algn="ctr">
+                      <a:pPr algn="ctr" indent="0" marL="0">
                         <a:buNone/>
                       </a:pPr>
                       <a:r>
@@ -7097,7 +7270,7 @@
                       </a:endParaRPr>
                     </a:p>
                   </a:txBody>
-                  <a:tcPr anchor="ctr">
+                  <a:tcPr marL="91440" marR="91440" marT="45720" marB="45720" anchor="ctr">
                     <a:lnL w="12700" cap="flat" cmpd="sng" algn="ctr">
                       <a:solidFill>
                         <a:srgbClr val="D5E3E4"/>
@@ -7144,7 +7317,7 @@
                     <a:bodyPr/>
                     <a:lstStyle/>
                     <a:p>
-                      <a:pPr marL="0" indent="0" algn="ctr">
+                      <a:pPr algn="ctr" indent="0" marL="0">
                         <a:buNone/>
                       </a:pPr>
                       <a:r>
@@ -7165,7 +7338,7 @@
                       </a:endParaRPr>
                     </a:p>
                   </a:txBody>
-                  <a:tcPr anchor="ctr">
+                  <a:tcPr marL="91440" marR="91440" marT="45720" marB="45720" anchor="ctr">
                     <a:lnL w="12700" cap="flat" cmpd="sng" algn="ctr">
                       <a:solidFill>
                         <a:srgbClr val="D5E3E4"/>
@@ -7212,7 +7385,7 @@
                     <a:bodyPr/>
                     <a:lstStyle/>
                     <a:p>
-                      <a:pPr marL="0" indent="0" algn="ctr">
+                      <a:pPr algn="ctr" indent="0" marL="0">
                         <a:buNone/>
                       </a:pPr>
                       <a:r>
@@ -7233,7 +7406,7 @@
                       </a:endParaRPr>
                     </a:p>
                   </a:txBody>
-                  <a:tcPr anchor="ctr">
+                  <a:tcPr marL="91440" marR="91440" marT="45720" marB="45720" anchor="ctr">
                     <a:lnL w="12700" cap="flat" cmpd="sng" algn="ctr">
                       <a:solidFill>
                         <a:srgbClr val="D5E3E4"/>
@@ -7275,11 +7448,6 @@
                     </a:solidFill>
                   </a:tcPr>
                 </a:tc>
-                <a:extLst>
-                  <a:ext uri="{0D108BD9-81ED-4DB2-BD59-A6C34878D82A}">
-                    <a16:rowId xmlns:a16="http://schemas.microsoft.com/office/drawing/2014/main" val="10003"/>
-                  </a:ext>
-                </a:extLst>
               </a:tr>
               <a:tr h="566928">
                 <a:tc>
@@ -7287,7 +7455,7 @@
                     <a:bodyPr/>
                     <a:lstStyle/>
                     <a:p>
-                      <a:pPr marL="0" indent="0" algn="l">
+                      <a:pPr algn="l" indent="0" marL="0">
                         <a:buNone/>
                       </a:pPr>
                       <a:r>
@@ -7308,7 +7476,7 @@
                       </a:endParaRPr>
                     </a:p>
                   </a:txBody>
-                  <a:tcPr anchor="ctr">
+                  <a:tcPr marL="91440" marR="91440" marT="45720" marB="45720" anchor="ctr">
                     <a:lnL w="12700" cap="flat" cmpd="sng" algn="ctr">
                       <a:solidFill>
                         <a:srgbClr val="D5E3E4"/>
@@ -7355,7 +7523,7 @@
                     <a:bodyPr/>
                     <a:lstStyle/>
                     <a:p>
-                      <a:pPr marL="0" indent="0" algn="ctr">
+                      <a:pPr algn="ctr" indent="0" marL="0">
                         <a:buNone/>
                       </a:pPr>
                       <a:r>
@@ -7376,7 +7544,7 @@
                       </a:endParaRPr>
                     </a:p>
                   </a:txBody>
-                  <a:tcPr anchor="ctr">
+                  <a:tcPr marL="91440" marR="91440" marT="45720" marB="45720" anchor="ctr">
                     <a:lnL w="12700" cap="flat" cmpd="sng" algn="ctr">
                       <a:solidFill>
                         <a:srgbClr val="D5E3E4"/>
@@ -7423,7 +7591,7 @@
                     <a:bodyPr/>
                     <a:lstStyle/>
                     <a:p>
-                      <a:pPr marL="0" indent="0" algn="ctr">
+                      <a:pPr algn="ctr" indent="0" marL="0">
                         <a:buNone/>
                       </a:pPr>
                       <a:r>
@@ -7444,7 +7612,7 @@
                       </a:endParaRPr>
                     </a:p>
                   </a:txBody>
-                  <a:tcPr anchor="ctr">
+                  <a:tcPr marL="91440" marR="91440" marT="45720" marB="45720" anchor="ctr">
                     <a:lnL w="12700" cap="flat" cmpd="sng" algn="ctr">
                       <a:solidFill>
                         <a:srgbClr val="D5E3E4"/>
@@ -7491,7 +7659,7 @@
                     <a:bodyPr/>
                     <a:lstStyle/>
                     <a:p>
-                      <a:pPr marL="0" indent="0" algn="ctr">
+                      <a:pPr algn="ctr" indent="0" marL="0">
                         <a:buNone/>
                       </a:pPr>
                       <a:r>
@@ -7512,7 +7680,7 @@
                       </a:endParaRPr>
                     </a:p>
                   </a:txBody>
-                  <a:tcPr anchor="ctr">
+                  <a:tcPr marL="91440" marR="91440" marT="45720" marB="45720" anchor="ctr">
                     <a:lnL w="12700" cap="flat" cmpd="sng" algn="ctr">
                       <a:solidFill>
                         <a:srgbClr val="D5E3E4"/>
@@ -7559,7 +7727,7 @@
                     <a:bodyPr/>
                     <a:lstStyle/>
                     <a:p>
-                      <a:pPr marL="0" indent="0" algn="ctr">
+                      <a:pPr algn="ctr" indent="0" marL="0">
                         <a:buNone/>
                       </a:pPr>
                       <a:r>
@@ -7580,7 +7748,7 @@
                       </a:endParaRPr>
                     </a:p>
                   </a:txBody>
-                  <a:tcPr anchor="ctr">
+                  <a:tcPr marL="91440" marR="91440" marT="45720" marB="45720" anchor="ctr">
                     <a:lnL w="12700" cap="flat" cmpd="sng" algn="ctr">
                       <a:solidFill>
                         <a:srgbClr val="D5E3E4"/>
@@ -7627,7 +7795,7 @@
                     <a:bodyPr/>
                     <a:lstStyle/>
                     <a:p>
-                      <a:pPr marL="0" indent="0" algn="ctr">
+                      <a:pPr algn="ctr" indent="0" marL="0">
                         <a:buNone/>
                       </a:pPr>
                       <a:r>
@@ -7648,7 +7816,7 @@
                       </a:endParaRPr>
                     </a:p>
                   </a:txBody>
-                  <a:tcPr anchor="ctr">
+                  <a:tcPr marL="91440" marR="91440" marT="45720" marB="45720" anchor="ctr">
                     <a:lnL w="12700" cap="flat" cmpd="sng" algn="ctr">
                       <a:solidFill>
                         <a:srgbClr val="D5E3E4"/>
@@ -7690,11 +7858,6 @@
                     </a:solidFill>
                   </a:tcPr>
                 </a:tc>
-                <a:extLst>
-                  <a:ext uri="{0D108BD9-81ED-4DB2-BD59-A6C34878D82A}">
-                    <a16:rowId xmlns:a16="http://schemas.microsoft.com/office/drawing/2014/main" val="10004"/>
-                  </a:ext>
-                </a:extLst>
               </a:tr>
               <a:tr h="566928">
                 <a:tc>
@@ -7702,7 +7865,7 @@
                     <a:bodyPr/>
                     <a:lstStyle/>
                     <a:p>
-                      <a:pPr marL="0" indent="0" algn="l">
+                      <a:pPr algn="l" indent="0" marL="0">
                         <a:buNone/>
                       </a:pPr>
                       <a:r>
@@ -7723,7 +7886,7 @@
                       </a:endParaRPr>
                     </a:p>
                   </a:txBody>
-                  <a:tcPr anchor="ctr">
+                  <a:tcPr marL="91440" marR="91440" marT="45720" marB="45720" anchor="ctr">
                     <a:lnL w="12700" cap="flat" cmpd="sng" algn="ctr">
                       <a:solidFill>
                         <a:srgbClr val="D5E3E4"/>
@@ -7770,7 +7933,7 @@
                     <a:bodyPr/>
                     <a:lstStyle/>
                     <a:p>
-                      <a:pPr marL="0" indent="0" algn="ctr">
+                      <a:pPr algn="ctr" indent="0" marL="0">
                         <a:buNone/>
                       </a:pPr>
                       <a:r>
@@ -7791,7 +7954,7 @@
                       </a:endParaRPr>
                     </a:p>
                   </a:txBody>
-                  <a:tcPr anchor="ctr">
+                  <a:tcPr marL="91440" marR="91440" marT="45720" marB="45720" anchor="ctr">
                     <a:lnL w="12700" cap="flat" cmpd="sng" algn="ctr">
                       <a:solidFill>
                         <a:srgbClr val="D5E3E4"/>
@@ -7838,7 +8001,7 @@
                     <a:bodyPr/>
                     <a:lstStyle/>
                     <a:p>
-                      <a:pPr marL="0" indent="0" algn="ctr">
+                      <a:pPr algn="ctr" indent="0" marL="0">
                         <a:buNone/>
                       </a:pPr>
                       <a:r>
@@ -7859,7 +8022,7 @@
                       </a:endParaRPr>
                     </a:p>
                   </a:txBody>
-                  <a:tcPr anchor="ctr">
+                  <a:tcPr marL="91440" marR="91440" marT="45720" marB="45720" anchor="ctr">
                     <a:lnL w="12700" cap="flat" cmpd="sng" algn="ctr">
                       <a:solidFill>
                         <a:srgbClr val="D5E3E4"/>
@@ -7906,7 +8069,7 @@
                     <a:bodyPr/>
                     <a:lstStyle/>
                     <a:p>
-                      <a:pPr marL="0" indent="0" algn="ctr">
+                      <a:pPr algn="ctr" indent="0" marL="0">
                         <a:buNone/>
                       </a:pPr>
                       <a:r>
@@ -7927,7 +8090,7 @@
                       </a:endParaRPr>
                     </a:p>
                   </a:txBody>
-                  <a:tcPr anchor="ctr">
+                  <a:tcPr marL="91440" marR="91440" marT="45720" marB="45720" anchor="ctr">
                     <a:lnL w="12700" cap="flat" cmpd="sng" algn="ctr">
                       <a:solidFill>
                         <a:srgbClr val="D5E3E4"/>
@@ -7974,7 +8137,7 @@
                     <a:bodyPr/>
                     <a:lstStyle/>
                     <a:p>
-                      <a:pPr marL="0" indent="0" algn="ctr">
+                      <a:pPr algn="ctr" indent="0" marL="0">
                         <a:buNone/>
                       </a:pPr>
                       <a:r>
@@ -7995,7 +8158,7 @@
                       </a:endParaRPr>
                     </a:p>
                   </a:txBody>
-                  <a:tcPr anchor="ctr">
+                  <a:tcPr marL="91440" marR="91440" marT="45720" marB="45720" anchor="ctr">
                     <a:lnL w="12700" cap="flat" cmpd="sng" algn="ctr">
                       <a:solidFill>
                         <a:srgbClr val="D5E3E4"/>
@@ -8042,7 +8205,7 @@
                     <a:bodyPr/>
                     <a:lstStyle/>
                     <a:p>
-                      <a:pPr marL="0" indent="0" algn="ctr">
+                      <a:pPr algn="ctr" indent="0" marL="0">
                         <a:buNone/>
                       </a:pPr>
                       <a:r>
@@ -8063,7 +8226,7 @@
                       </a:endParaRPr>
                     </a:p>
                   </a:txBody>
-                  <a:tcPr anchor="ctr">
+                  <a:tcPr marL="91440" marR="91440" marT="45720" marB="45720" anchor="ctr">
                     <a:lnL w="12700" cap="flat" cmpd="sng" algn="ctr">
                       <a:solidFill>
                         <a:srgbClr val="D5E3E4"/>
@@ -8105,11 +8268,6 @@
                     </a:solidFill>
                   </a:tcPr>
                 </a:tc>
-                <a:extLst>
-                  <a:ext uri="{0D108BD9-81ED-4DB2-BD59-A6C34878D82A}">
-                    <a16:rowId xmlns:a16="http://schemas.microsoft.com/office/drawing/2014/main" val="10005"/>
-                  </a:ext>
-                </a:extLst>
               </a:tr>
             </a:tbl>
           </a:graphicData>
@@ -8161,7 +8319,7 @@
           <a:bodyPr wrap="square" lIns="0" tIns="0" rIns="0" bIns="0" rtlCol="0" anchor="ctr"/>
           <a:lstStyle/>
           <a:p>
-            <a:pPr marL="0" indent="0">
+            <a:pPr indent="0" marL="0">
               <a:lnSpc>
                 <a:spcPct val="102000"/>
               </a:lnSpc>
@@ -8178,6 +8336,12 @@
               </a:rPr>
               <a:t>结论：</a:t>
             </a:r>
+            <a:pPr indent="0" marL="0">
+              <a:lnSpc>
+                <a:spcPct val="102000"/>
+              </a:lnSpc>
+              <a:buNone/>
+            </a:pPr>
             <a:r>
               <a:rPr lang="en-US" sz="1250" dirty="0">
                 <a:solidFill>
@@ -8189,6 +8353,12 @@
               </a:rPr>
               <a:t>5 工具全部部署 / 环境就绪；其中 </a:t>
             </a:r>
+            <a:pPr indent="0" marL="0">
+              <a:lnSpc>
+                <a:spcPct val="102000"/>
+              </a:lnSpc>
+              <a:buNone/>
+            </a:pPr>
             <a:r>
               <a:rPr lang="en-US" sz="1250" b="1" dirty="0">
                 <a:solidFill>
@@ -8200,6 +8370,12 @@
               </a:rPr>
               <a:t>5 / 5 均产出 ELISpot 真实分数并完成 benchmark</a:t>
             </a:r>
+            <a:pPr indent="0" marL="0">
+              <a:lnSpc>
+                <a:spcPct val="102000"/>
+              </a:lnSpc>
+              <a:buNone/>
+            </a:pPr>
             <a:r>
               <a:rPr lang="en-US" sz="1250" dirty="0">
                 <a:solidFill>
@@ -8261,7 +8437,7 @@
           <a:bodyPr wrap="square" lIns="0" tIns="0" rIns="0" bIns="0" rtlCol="0" anchor="ctr"/>
           <a:lstStyle/>
           <a:p>
-            <a:pPr marL="0" indent="0">
+            <a:pPr indent="0" marL="0">
               <a:lnSpc>
                 <a:spcPct val="100000"/>
               </a:lnSpc>
@@ -8278,6 +8454,12 @@
               </a:rPr>
               <a:t>「部分完成」= 工具自身限制，非部署失败：</a:t>
             </a:r>
+            <a:pPr indent="0" marL="0">
+              <a:lnSpc>
+                <a:spcPct val="100000"/>
+              </a:lnSpc>
+              <a:buNone/>
+            </a:pPr>
             <a:r>
               <a:rPr lang="en-US" sz="1100" dirty="0">
                 <a:solidFill>
@@ -8314,7 +8496,7 @@
           <a:bodyPr wrap="square" lIns="0" tIns="0" rIns="0" bIns="0" rtlCol="0" anchor="ctr"/>
           <a:lstStyle/>
           <a:p>
-            <a:pPr marL="0" indent="0" algn="r">
+            <a:pPr algn="r" indent="0" marL="0">
               <a:buNone/>
             </a:pPr>
             <a:r>
@@ -8348,7 +8530,6 @@
         <a:solidFill>
           <a:srgbClr val="F2F7F7"/>
         </a:solidFill>
-        <a:effectLst/>
       </p:bgPr>
     </p:bg>
     <p:spTree>
@@ -8406,11 +8587,11 @@
           <a:bodyPr wrap="square" lIns="0" tIns="0" rIns="0" bIns="0" rtlCol="0" anchor="ctr"/>
           <a:lstStyle/>
           <a:p>
-            <a:pPr marL="0" indent="0">
-              <a:buNone/>
-            </a:pPr>
-            <a:r>
-              <a:rPr lang="en-US" sz="1200" b="1" kern="0" spc="300" dirty="0">
+            <a:pPr indent="0" marL="0">
+              <a:buNone/>
+            </a:pPr>
+            <a:r>
+              <a:rPr lang="en-US" sz="1200" b="1" spc="300" kern="0" dirty="0">
                 <a:solidFill>
                   <a:srgbClr val="028090"/>
                 </a:solidFill>
@@ -8445,7 +8626,7 @@
           <a:bodyPr wrap="square" lIns="0" tIns="0" rIns="0" bIns="0" rtlCol="0" anchor="ctr"/>
           <a:lstStyle/>
           <a:p>
-            <a:pPr marL="0" indent="0">
+            <a:pPr indent="0" marL="0">
               <a:buNone/>
             </a:pPr>
             <a:r>
@@ -8484,7 +8665,7 @@
           <a:bodyPr wrap="square" lIns="0" tIns="0" rIns="0" bIns="0" rtlCol="0" anchor="ctr"/>
           <a:lstStyle/>
           <a:p>
-            <a:pPr marL="0" indent="0">
+            <a:pPr indent="0" marL="0">
               <a:buNone/>
             </a:pPr>
             <a:r>
@@ -8545,7 +8726,7 @@
           <a:bodyPr wrap="square" lIns="0" tIns="0" rIns="0" bIns="0" rtlCol="0" anchor="ctr"/>
           <a:lstStyle/>
           <a:p>
-            <a:pPr marL="0" indent="0" algn="ctr">
+            <a:pPr algn="ctr" indent="0" marL="0">
               <a:buNone/>
             </a:pPr>
             <a:r>
@@ -8584,7 +8765,7 @@
           <a:bodyPr wrap="square" lIns="0" tIns="0" rIns="0" bIns="0" rtlCol="0" anchor="ctr"/>
           <a:lstStyle/>
           <a:p>
-            <a:pPr marL="0" indent="0" algn="ctr">
+            <a:pPr algn="ctr" indent="0" marL="0">
               <a:buNone/>
             </a:pPr>
             <a:r>
@@ -8626,7 +8807,7 @@
             <a:prstDash val="solid"/>
           </a:ln>
           <a:effectLst>
-            <a:outerShdw blurRad="114300" dist="38100" dir="8100000" algn="bl" rotWithShape="0">
+            <a:outerShdw sx="100000" sy="100000" kx="0" ky="0" algn="bl" rotWithShape="0" blurRad="114300" dist="38100" dir="8100000">
               <a:srgbClr val="0B3C49">
                 <a:alpha val="12000"/>
               </a:srgbClr>
@@ -8675,7 +8856,7 @@
           <a:bodyPr wrap="square" lIns="0" tIns="0" rIns="0" bIns="0" rtlCol="0" anchor="ctr"/>
           <a:lstStyle/>
           <a:p>
-            <a:pPr marL="0" indent="0">
+            <a:pPr indent="0" marL="0">
               <a:buNone/>
             </a:pPr>
             <a:r>
@@ -8823,7 +9004,7 @@
             <a:prstDash val="solid"/>
           </a:ln>
           <a:effectLst>
-            <a:outerShdw blurRad="114300" dist="38100" dir="8100000" algn="bl" rotWithShape="0">
+            <a:outerShdw sx="100000" sy="100000" kx="0" ky="0" algn="bl" rotWithShape="0" blurRad="114300" dist="38100" dir="8100000">
               <a:srgbClr val="0B3C49">
                 <a:alpha val="12000"/>
               </a:srgbClr>
@@ -8872,7 +9053,7 @@
           <a:bodyPr wrap="square" lIns="0" tIns="0" rIns="0" bIns="0" rtlCol="0" anchor="ctr"/>
           <a:lstStyle/>
           <a:p>
-            <a:pPr marL="0" indent="0">
+            <a:pPr indent="0" marL="0">
               <a:buNone/>
             </a:pPr>
             <a:r>
@@ -8999,7 +9180,7 @@
             <a:prstDash val="solid"/>
           </a:ln>
           <a:effectLst>
-            <a:outerShdw blurRad="114300" dist="38100" dir="8100000" algn="bl" rotWithShape="0">
+            <a:outerShdw sx="100000" sy="100000" kx="0" ky="0" algn="bl" rotWithShape="0" blurRad="114300" dist="38100" dir="8100000">
               <a:srgbClr val="0B3C49">
                 <a:alpha val="12000"/>
               </a:srgbClr>
@@ -9048,7 +9229,7 @@
           <a:bodyPr wrap="square" lIns="0" tIns="0" rIns="0" bIns="0" rtlCol="0" anchor="ctr"/>
           <a:lstStyle/>
           <a:p>
-            <a:pPr marL="0" indent="0">
+            <a:pPr indent="0" marL="0">
               <a:buNone/>
             </a:pPr>
             <a:r>
@@ -9175,7 +9356,7 @@
             <a:prstDash val="solid"/>
           </a:ln>
           <a:effectLst>
-            <a:outerShdw blurRad="114300" dist="38100" dir="8100000" algn="bl" rotWithShape="0">
+            <a:outerShdw sx="100000" sy="100000" kx="0" ky="0" algn="bl" rotWithShape="0" blurRad="114300" dist="38100" dir="8100000">
               <a:srgbClr val="0B3C49">
                 <a:alpha val="12000"/>
               </a:srgbClr>
@@ -9224,7 +9405,7 @@
           <a:bodyPr wrap="square" lIns="0" tIns="0" rIns="0" bIns="0" rtlCol="0" anchor="ctr"/>
           <a:lstStyle/>
           <a:p>
-            <a:pPr marL="0" indent="0">
+            <a:pPr indent="0" marL="0">
               <a:buNone/>
             </a:pPr>
             <a:r>
@@ -9348,7 +9529,7 @@
           <a:bodyPr wrap="square" lIns="0" tIns="0" rIns="0" bIns="0" rtlCol="0" anchor="ctr"/>
           <a:lstStyle/>
           <a:p>
-            <a:pPr marL="0" indent="0" algn="r">
+            <a:pPr algn="r" indent="0" marL="0">
               <a:buNone/>
             </a:pPr>
             <a:r>
@@ -9382,7 +9563,6 @@
         <a:solidFill>
           <a:srgbClr val="F2F7F7"/>
         </a:solidFill>
-        <a:effectLst/>
       </p:bgPr>
     </p:bg>
     <p:spTree>
@@ -9440,11 +9620,11 @@
           <a:bodyPr wrap="square" lIns="0" tIns="0" rIns="0" bIns="0" rtlCol="0" anchor="ctr"/>
           <a:lstStyle/>
           <a:p>
-            <a:pPr marL="0" indent="0">
-              <a:buNone/>
-            </a:pPr>
-            <a:r>
-              <a:rPr lang="en-US" sz="1200" b="1" kern="0" spc="300" dirty="0">
+            <a:pPr indent="0" marL="0">
+              <a:buNone/>
+            </a:pPr>
+            <a:r>
+              <a:rPr lang="en-US" sz="1200" b="1" spc="300" kern="0" dirty="0">
                 <a:solidFill>
                   <a:srgbClr val="1C7293"/>
                 </a:solidFill>
@@ -9479,7 +9659,7 @@
           <a:bodyPr wrap="square" lIns="0" tIns="0" rIns="0" bIns="0" rtlCol="0" anchor="ctr"/>
           <a:lstStyle/>
           <a:p>
-            <a:pPr marL="0" indent="0">
+            <a:pPr indent="0" marL="0">
               <a:buNone/>
             </a:pPr>
             <a:r>
@@ -9518,7 +9698,7 @@
           <a:bodyPr wrap="square" lIns="0" tIns="0" rIns="0" bIns="0" rtlCol="0" anchor="ctr"/>
           <a:lstStyle/>
           <a:p>
-            <a:pPr marL="0" indent="0">
+            <a:pPr indent="0" marL="0">
               <a:buNone/>
             </a:pPr>
             <a:r>
@@ -9579,7 +9759,7 @@
           <a:bodyPr wrap="square" lIns="0" tIns="0" rIns="0" bIns="0" rtlCol="0" anchor="ctr"/>
           <a:lstStyle/>
           <a:p>
-            <a:pPr marL="0" indent="0" algn="ctr">
+            <a:pPr algn="ctr" indent="0" marL="0">
               <a:buNone/>
             </a:pPr>
             <a:r>
@@ -9618,7 +9798,7 @@
           <a:bodyPr wrap="square" lIns="0" tIns="0" rIns="0" bIns="0" rtlCol="0" anchor="ctr"/>
           <a:lstStyle/>
           <a:p>
-            <a:pPr marL="0" indent="0" algn="ctr">
+            <a:pPr algn="ctr" indent="0" marL="0">
               <a:buNone/>
             </a:pPr>
             <a:r>
@@ -9660,7 +9840,7 @@
             <a:prstDash val="solid"/>
           </a:ln>
           <a:effectLst>
-            <a:outerShdw blurRad="114300" dist="38100" dir="8100000" algn="bl" rotWithShape="0">
+            <a:outerShdw sx="100000" sy="100000" kx="0" ky="0" algn="bl" rotWithShape="0" blurRad="114300" dist="38100" dir="8100000">
               <a:srgbClr val="0B3C49">
                 <a:alpha val="12000"/>
               </a:srgbClr>
@@ -9709,7 +9889,7 @@
           <a:bodyPr wrap="square" lIns="0" tIns="0" rIns="0" bIns="0" rtlCol="0" anchor="ctr"/>
           <a:lstStyle/>
           <a:p>
-            <a:pPr marL="0" indent="0">
+            <a:pPr indent="0" marL="0">
               <a:buNone/>
             </a:pPr>
             <a:r>
@@ -9836,7 +10016,7 @@
             <a:prstDash val="solid"/>
           </a:ln>
           <a:effectLst>
-            <a:outerShdw blurRad="114300" dist="38100" dir="8100000" algn="bl" rotWithShape="0">
+            <a:outerShdw sx="100000" sy="100000" kx="0" ky="0" algn="bl" rotWithShape="0" blurRad="114300" dist="38100" dir="8100000">
               <a:srgbClr val="0B3C49">
                 <a:alpha val="12000"/>
               </a:srgbClr>
@@ -9885,7 +10065,7 @@
           <a:bodyPr wrap="square" lIns="0" tIns="0" rIns="0" bIns="0" rtlCol="0" anchor="ctr"/>
           <a:lstStyle/>
           <a:p>
-            <a:pPr marL="0" indent="0">
+            <a:pPr indent="0" marL="0">
               <a:buNone/>
             </a:pPr>
             <a:r>
@@ -10012,7 +10192,7 @@
             <a:prstDash val="solid"/>
           </a:ln>
           <a:effectLst>
-            <a:outerShdw blurRad="114300" dist="38100" dir="8100000" algn="bl" rotWithShape="0">
+            <a:outerShdw sx="100000" sy="100000" kx="0" ky="0" algn="bl" rotWithShape="0" blurRad="114300" dist="38100" dir="8100000">
               <a:srgbClr val="0B3C49">
                 <a:alpha val="12000"/>
               </a:srgbClr>
@@ -10061,7 +10241,7 @@
           <a:bodyPr wrap="square" lIns="0" tIns="0" rIns="0" bIns="0" rtlCol="0" anchor="ctr"/>
           <a:lstStyle/>
           <a:p>
-            <a:pPr marL="0" indent="0">
+            <a:pPr indent="0" marL="0">
               <a:buNone/>
             </a:pPr>
             <a:r>
@@ -10188,7 +10368,7 @@
             <a:prstDash val="solid"/>
           </a:ln>
           <a:effectLst>
-            <a:outerShdw blurRad="114300" dist="38100" dir="8100000" algn="bl" rotWithShape="0">
+            <a:outerShdw sx="100000" sy="100000" kx="0" ky="0" algn="bl" rotWithShape="0" blurRad="114300" dist="38100" dir="8100000">
               <a:srgbClr val="0B3C49">
                 <a:alpha val="12000"/>
               </a:srgbClr>
@@ -10237,7 +10417,7 @@
           <a:bodyPr wrap="square" lIns="0" tIns="0" rIns="0" bIns="0" rtlCol="0" anchor="ctr"/>
           <a:lstStyle/>
           <a:p>
-            <a:pPr marL="0" indent="0">
+            <a:pPr indent="0" marL="0">
               <a:buNone/>
             </a:pPr>
             <a:r>
@@ -10361,7 +10541,7 @@
           <a:bodyPr wrap="square" lIns="0" tIns="0" rIns="0" bIns="0" rtlCol="0" anchor="ctr"/>
           <a:lstStyle/>
           <a:p>
-            <a:pPr marL="0" indent="0" algn="r">
+            <a:pPr algn="r" indent="0" marL="0">
               <a:buNone/>
             </a:pPr>
             <a:r>
@@ -10395,7 +10575,6 @@
         <a:solidFill>
           <a:srgbClr val="F2F7F7"/>
         </a:solidFill>
-        <a:effectLst/>
       </p:bgPr>
     </p:bg>
     <p:spTree>
@@ -10453,11 +10632,11 @@
           <a:bodyPr wrap="square" lIns="0" tIns="0" rIns="0" bIns="0" rtlCol="0" anchor="ctr"/>
           <a:lstStyle/>
           <a:p>
-            <a:pPr marL="0" indent="0">
-              <a:buNone/>
-            </a:pPr>
-            <a:r>
-              <a:rPr lang="en-US" sz="1200" b="1" kern="0" spc="300" dirty="0">
+            <a:pPr indent="0" marL="0">
+              <a:buNone/>
+            </a:pPr>
+            <a:r>
+              <a:rPr lang="en-US" sz="1200" b="1" spc="300" kern="0" dirty="0">
                 <a:solidFill>
                   <a:srgbClr val="028090"/>
                 </a:solidFill>
@@ -10492,7 +10671,7 @@
           <a:bodyPr wrap="square" lIns="0" tIns="0" rIns="0" bIns="0" rtlCol="0" anchor="ctr"/>
           <a:lstStyle/>
           <a:p>
-            <a:pPr marL="0" indent="0">
+            <a:pPr indent="0" marL="0">
               <a:buNone/>
             </a:pPr>
             <a:r>
@@ -10531,7 +10710,7 @@
           <a:bodyPr wrap="square" lIns="0" tIns="0" rIns="0" bIns="0" rtlCol="0" anchor="ctr"/>
           <a:lstStyle/>
           <a:p>
-            <a:pPr marL="0" indent="0">
+            <a:pPr indent="0" marL="0">
               <a:buNone/>
             </a:pPr>
             <a:r>
@@ -10592,7 +10771,7 @@
           <a:bodyPr wrap="square" lIns="0" tIns="0" rIns="0" bIns="0" rtlCol="0" anchor="ctr"/>
           <a:lstStyle/>
           <a:p>
-            <a:pPr marL="0" indent="0" algn="ctr">
+            <a:pPr algn="ctr" indent="0" marL="0">
               <a:buNone/>
             </a:pPr>
             <a:r>
@@ -10631,7 +10810,7 @@
           <a:bodyPr wrap="square" lIns="0" tIns="0" rIns="0" bIns="0" rtlCol="0" anchor="ctr"/>
           <a:lstStyle/>
           <a:p>
-            <a:pPr marL="0" indent="0" algn="ctr">
+            <a:pPr algn="ctr" indent="0" marL="0">
               <a:buNone/>
             </a:pPr>
             <a:r>
@@ -10673,7 +10852,7 @@
             <a:prstDash val="solid"/>
           </a:ln>
           <a:effectLst>
-            <a:outerShdw blurRad="114300" dist="38100" dir="8100000" algn="bl" rotWithShape="0">
+            <a:outerShdw sx="100000" sy="100000" kx="0" ky="0" algn="bl" rotWithShape="0" blurRad="114300" dist="38100" dir="8100000">
               <a:srgbClr val="0B3C49">
                 <a:alpha val="12000"/>
               </a:srgbClr>
@@ -10722,7 +10901,7 @@
           <a:bodyPr wrap="square" lIns="0" tIns="0" rIns="0" bIns="0" rtlCol="0" anchor="ctr"/>
           <a:lstStyle/>
           <a:p>
-            <a:pPr marL="0" indent="0">
+            <a:pPr indent="0" marL="0">
               <a:buNone/>
             </a:pPr>
             <a:r>
@@ -10849,7 +11028,7 @@
             <a:prstDash val="solid"/>
           </a:ln>
           <a:effectLst>
-            <a:outerShdw blurRad="114300" dist="38100" dir="8100000" algn="bl" rotWithShape="0">
+            <a:outerShdw sx="100000" sy="100000" kx="0" ky="0" algn="bl" rotWithShape="0" blurRad="114300" dist="38100" dir="8100000">
               <a:srgbClr val="0B3C49">
                 <a:alpha val="12000"/>
               </a:srgbClr>
@@ -10898,7 +11077,7 @@
           <a:bodyPr wrap="square" lIns="0" tIns="0" rIns="0" bIns="0" rtlCol="0" anchor="ctr"/>
           <a:lstStyle/>
           <a:p>
-            <a:pPr marL="0" indent="0">
+            <a:pPr indent="0" marL="0">
               <a:buNone/>
             </a:pPr>
             <a:r>
@@ -11004,7 +11183,7 @@
             <a:prstDash val="solid"/>
           </a:ln>
           <a:effectLst>
-            <a:outerShdw blurRad="114300" dist="38100" dir="8100000" algn="bl" rotWithShape="0">
+            <a:outerShdw sx="100000" sy="100000" kx="0" ky="0" algn="bl" rotWithShape="0" blurRad="114300" dist="38100" dir="8100000">
               <a:srgbClr val="0B3C49">
                 <a:alpha val="12000"/>
               </a:srgbClr>
@@ -11053,7 +11232,7 @@
           <a:bodyPr wrap="square" lIns="0" tIns="0" rIns="0" bIns="0" rtlCol="0" anchor="ctr"/>
           <a:lstStyle/>
           <a:p>
-            <a:pPr marL="0" indent="0">
+            <a:pPr indent="0" marL="0">
               <a:buNone/>
             </a:pPr>
             <a:r>
@@ -11180,7 +11359,7 @@
             <a:prstDash val="solid"/>
           </a:ln>
           <a:effectLst>
-            <a:outerShdw blurRad="114300" dist="38100" dir="8100000" algn="bl" rotWithShape="0">
+            <a:outerShdw sx="100000" sy="100000" kx="0" ky="0" algn="bl" rotWithShape="0" blurRad="114300" dist="38100" dir="8100000">
               <a:srgbClr val="0B3C49">
                 <a:alpha val="12000"/>
               </a:srgbClr>
@@ -11229,7 +11408,7 @@
           <a:bodyPr wrap="square" lIns="0" tIns="0" rIns="0" bIns="0" rtlCol="0" anchor="ctr"/>
           <a:lstStyle/>
           <a:p>
-            <a:pPr marL="0" indent="0">
+            <a:pPr indent="0" marL="0">
               <a:buNone/>
             </a:pPr>
             <a:r>
@@ -11326,7 +11505,7 @@
                 <a:ea typeface="Microsoft YaHei" pitchFamily="34" charset="-122"/>
                 <a:cs typeface="Microsoft YaHei" pitchFamily="34" charset="-120"/>
               </a:rPr>
-              <a:t>Predict 步本地+HPC 跑通；全特征链需学术许可工具</a:t>
+              <a:t>Predict 步本地+HPC 跑通；许可工具(netMHCpan/PRIME)已到位，全特征链余 netMHCstabpan(glibc 挡)+self_similarity/garnish 待补</a:t>
             </a:r>
             <a:endParaRPr lang="en-US" sz="1150" dirty="0"/>
           </a:p>
@@ -11353,7 +11532,7 @@
           <a:bodyPr wrap="square" lIns="0" tIns="0" rIns="0" bIns="0" rtlCol="0" anchor="ctr"/>
           <a:lstStyle/>
           <a:p>
-            <a:pPr marL="0" indent="0" algn="r">
+            <a:pPr algn="r" indent="0" marL="0">
               <a:buNone/>
             </a:pPr>
             <a:r>
@@ -11387,7 +11566,6 @@
         <a:solidFill>
           <a:srgbClr val="F2F7F7"/>
         </a:solidFill>
-        <a:effectLst/>
       </p:bgPr>
     </p:bg>
     <p:spTree>
@@ -11445,11 +11623,11 @@
           <a:bodyPr wrap="square" lIns="0" tIns="0" rIns="0" bIns="0" rtlCol="0" anchor="ctr"/>
           <a:lstStyle/>
           <a:p>
-            <a:pPr marL="0" indent="0">
-              <a:buNone/>
-            </a:pPr>
-            <a:r>
-              <a:rPr lang="en-US" sz="1200" b="1" kern="0" spc="300" dirty="0">
+            <a:pPr indent="0" marL="0">
+              <a:buNone/>
+            </a:pPr>
+            <a:r>
+              <a:rPr lang="en-US" sz="1200" b="1" spc="300" kern="0" dirty="0">
                 <a:solidFill>
                   <a:srgbClr val="1C7293"/>
                 </a:solidFill>
@@ -11484,7 +11662,7 @@
           <a:bodyPr wrap="square" lIns="0" tIns="0" rIns="0" bIns="0" rtlCol="0" anchor="ctr"/>
           <a:lstStyle/>
           <a:p>
-            <a:pPr marL="0" indent="0">
+            <a:pPr indent="0" marL="0">
               <a:buNone/>
             </a:pPr>
             <a:r>
@@ -11523,7 +11701,7 @@
           <a:bodyPr wrap="square" lIns="0" tIns="0" rIns="0" bIns="0" rtlCol="0" anchor="ctr"/>
           <a:lstStyle/>
           <a:p>
-            <a:pPr marL="0" indent="0">
+            <a:pPr indent="0" marL="0">
               <a:buNone/>
             </a:pPr>
             <a:r>
@@ -11584,7 +11762,7 @@
           <a:bodyPr wrap="square" lIns="0" tIns="0" rIns="0" bIns="0" rtlCol="0" anchor="ctr"/>
           <a:lstStyle/>
           <a:p>
-            <a:pPr marL="0" indent="0" algn="ctr">
+            <a:pPr algn="ctr" indent="0" marL="0">
               <a:buNone/>
             </a:pPr>
             <a:r>
@@ -11623,7 +11801,7 @@
           <a:bodyPr wrap="square" lIns="0" tIns="0" rIns="0" bIns="0" rtlCol="0" anchor="ctr"/>
           <a:lstStyle/>
           <a:p>
-            <a:pPr marL="0" indent="0" algn="ctr">
+            <a:pPr algn="ctr" indent="0" marL="0">
               <a:buNone/>
             </a:pPr>
             <a:r>
@@ -11665,7 +11843,7 @@
             <a:prstDash val="solid"/>
           </a:ln>
           <a:effectLst>
-            <a:outerShdw blurRad="114300" dist="38100" dir="8100000" algn="bl" rotWithShape="0">
+            <a:outerShdw sx="100000" sy="100000" kx="0" ky="0" algn="bl" rotWithShape="0" blurRad="114300" dist="38100" dir="8100000">
               <a:srgbClr val="0B3C49">
                 <a:alpha val="12000"/>
               </a:srgbClr>
@@ -11714,7 +11892,7 @@
           <a:bodyPr wrap="square" lIns="0" tIns="0" rIns="0" bIns="0" rtlCol="0" anchor="ctr"/>
           <a:lstStyle/>
           <a:p>
-            <a:pPr marL="0" indent="0">
+            <a:pPr indent="0" marL="0">
               <a:buNone/>
             </a:pPr>
             <a:r>
@@ -11841,7 +12019,7 @@
             <a:prstDash val="solid"/>
           </a:ln>
           <a:effectLst>
-            <a:outerShdw blurRad="114300" dist="38100" dir="8100000" algn="bl" rotWithShape="0">
+            <a:outerShdw sx="100000" sy="100000" kx="0" ky="0" algn="bl" rotWithShape="0" blurRad="114300" dist="38100" dir="8100000">
               <a:srgbClr val="0B3C49">
                 <a:alpha val="12000"/>
               </a:srgbClr>
@@ -11890,7 +12068,7 @@
           <a:bodyPr wrap="square" lIns="0" tIns="0" rIns="0" bIns="0" rtlCol="0" anchor="ctr"/>
           <a:lstStyle/>
           <a:p>
-            <a:pPr marL="0" indent="0">
+            <a:pPr indent="0" marL="0">
               <a:buNone/>
             </a:pPr>
             <a:r>
@@ -11996,7 +12174,7 @@
             <a:prstDash val="solid"/>
           </a:ln>
           <a:effectLst>
-            <a:outerShdw blurRad="114300" dist="38100" dir="8100000" algn="bl" rotWithShape="0">
+            <a:outerShdw sx="100000" sy="100000" kx="0" ky="0" algn="bl" rotWithShape="0" blurRad="114300" dist="38100" dir="8100000">
               <a:srgbClr val="0B3C49">
                 <a:alpha val="12000"/>
               </a:srgbClr>
@@ -12045,7 +12223,7 @@
           <a:bodyPr wrap="square" lIns="0" tIns="0" rIns="0" bIns="0" rtlCol="0" anchor="ctr"/>
           <a:lstStyle/>
           <a:p>
-            <a:pPr marL="0" indent="0">
+            <a:pPr indent="0" marL="0">
               <a:buNone/>
             </a:pPr>
             <a:r>
@@ -12172,7 +12350,7 @@
             <a:prstDash val="solid"/>
           </a:ln>
           <a:effectLst>
-            <a:outerShdw blurRad="114300" dist="38100" dir="8100000" algn="bl" rotWithShape="0">
+            <a:outerShdw sx="100000" sy="100000" kx="0" ky="0" algn="bl" rotWithShape="0" blurRad="114300" dist="38100" dir="8100000">
               <a:srgbClr val="0B3C49">
                 <a:alpha val="12000"/>
               </a:srgbClr>
@@ -12221,7 +12399,7 @@
           <a:bodyPr wrap="square" lIns="0" tIns="0" rIns="0" bIns="0" rtlCol="0" anchor="ctr"/>
           <a:lstStyle/>
           <a:p>
-            <a:pPr marL="0" indent="0">
+            <a:pPr indent="0" marL="0">
               <a:buNone/>
             </a:pPr>
             <a:r>
@@ -12345,7 +12523,7 @@
           <a:bodyPr wrap="square" lIns="0" tIns="0" rIns="0" bIns="0" rtlCol="0" anchor="ctr"/>
           <a:lstStyle/>
           <a:p>
-            <a:pPr marL="0" indent="0" algn="r">
+            <a:pPr algn="r" indent="0" marL="0">
               <a:buNone/>
             </a:pPr>
             <a:r>
@@ -12379,7 +12557,6 @@
         <a:solidFill>
           <a:srgbClr val="F2F7F7"/>
         </a:solidFill>
-        <a:effectLst/>
       </p:bgPr>
     </p:bg>
     <p:spTree>
@@ -12437,11 +12614,11 @@
           <a:bodyPr wrap="square" lIns="0" tIns="0" rIns="0" bIns="0" rtlCol="0" anchor="ctr"/>
           <a:lstStyle/>
           <a:p>
-            <a:pPr marL="0" indent="0">
-              <a:buNone/>
-            </a:pPr>
-            <a:r>
-              <a:rPr lang="en-US" sz="1200" b="1" kern="0" spc="300" dirty="0">
+            <a:pPr indent="0" marL="0">
+              <a:buNone/>
+            </a:pPr>
+            <a:r>
+              <a:rPr lang="en-US" sz="1200" b="1" spc="300" kern="0" dirty="0">
                 <a:solidFill>
                   <a:srgbClr val="028090"/>
                 </a:solidFill>
@@ -12476,7 +12653,7 @@
           <a:bodyPr wrap="square" lIns="0" tIns="0" rIns="0" bIns="0" rtlCol="0" anchor="ctr"/>
           <a:lstStyle/>
           <a:p>
-            <a:pPr marL="0" indent="0">
+            <a:pPr indent="0" marL="0">
               <a:buNone/>
             </a:pPr>
             <a:r>
@@ -12515,7 +12692,7 @@
           <a:bodyPr wrap="square" lIns="0" tIns="0" rIns="0" bIns="0" rtlCol="0" anchor="ctr"/>
           <a:lstStyle/>
           <a:p>
-            <a:pPr marL="0" indent="0">
+            <a:pPr indent="0" marL="0">
               <a:buNone/>
             </a:pPr>
             <a:r>
@@ -12576,7 +12753,7 @@
           <a:bodyPr wrap="square" lIns="0" tIns="0" rIns="0" bIns="0" rtlCol="0" anchor="ctr"/>
           <a:lstStyle/>
           <a:p>
-            <a:pPr marL="0" indent="0" algn="ctr">
+            <a:pPr algn="ctr" indent="0" marL="0">
               <a:buNone/>
             </a:pPr>
             <a:r>
@@ -12615,7 +12792,7 @@
           <a:bodyPr wrap="square" lIns="0" tIns="0" rIns="0" bIns="0" rtlCol="0" anchor="ctr"/>
           <a:lstStyle/>
           <a:p>
-            <a:pPr marL="0" indent="0" algn="ctr">
+            <a:pPr algn="ctr" indent="0" marL="0">
               <a:buNone/>
             </a:pPr>
             <a:r>
@@ -12657,7 +12834,7 @@
             <a:prstDash val="solid"/>
           </a:ln>
           <a:effectLst>
-            <a:outerShdw blurRad="114300" dist="38100" dir="8100000" algn="bl" rotWithShape="0">
+            <a:outerShdw sx="100000" sy="100000" kx="0" ky="0" algn="bl" rotWithShape="0" blurRad="114300" dist="38100" dir="8100000">
               <a:srgbClr val="0B3C49">
                 <a:alpha val="12000"/>
               </a:srgbClr>
@@ -12706,7 +12883,7 @@
           <a:bodyPr wrap="square" lIns="0" tIns="0" rIns="0" bIns="0" rtlCol="0" anchor="ctr"/>
           <a:lstStyle/>
           <a:p>
-            <a:pPr marL="0" indent="0">
+            <a:pPr indent="0" marL="0">
               <a:buNone/>
             </a:pPr>
             <a:r>
@@ -12812,7 +12989,7 @@
             <a:prstDash val="solid"/>
           </a:ln>
           <a:effectLst>
-            <a:outerShdw blurRad="114300" dist="38100" dir="8100000" algn="bl" rotWithShape="0">
+            <a:outerShdw sx="100000" sy="100000" kx="0" ky="0" algn="bl" rotWithShape="0" blurRad="114300" dist="38100" dir="8100000">
               <a:srgbClr val="0B3C49">
                 <a:alpha val="12000"/>
               </a:srgbClr>
@@ -12861,7 +13038,7 @@
           <a:bodyPr wrap="square" lIns="0" tIns="0" rIns="0" bIns="0" rtlCol="0" anchor="ctr"/>
           <a:lstStyle/>
           <a:p>
-            <a:pPr marL="0" indent="0">
+            <a:pPr indent="0" marL="0">
               <a:buNone/>
             </a:pPr>
             <a:r>
@@ -12988,7 +13165,7 @@
             <a:prstDash val="solid"/>
           </a:ln>
           <a:effectLst>
-            <a:outerShdw blurRad="114300" dist="38100" dir="8100000" algn="bl" rotWithShape="0">
+            <a:outerShdw sx="100000" sy="100000" kx="0" ky="0" algn="bl" rotWithShape="0" blurRad="114300" dist="38100" dir="8100000">
               <a:srgbClr val="0B3C49">
                 <a:alpha val="12000"/>
               </a:srgbClr>
@@ -13037,7 +13214,7 @@
           <a:bodyPr wrap="square" lIns="0" tIns="0" rIns="0" bIns="0" rtlCol="0" anchor="ctr"/>
           <a:lstStyle/>
           <a:p>
-            <a:pPr marL="0" indent="0">
+            <a:pPr indent="0" marL="0">
               <a:buNone/>
             </a:pPr>
             <a:r>
@@ -13164,7 +13341,7 @@
             <a:prstDash val="solid"/>
           </a:ln>
           <a:effectLst>
-            <a:outerShdw blurRad="114300" dist="38100" dir="8100000" algn="bl" rotWithShape="0">
+            <a:outerShdw sx="100000" sy="100000" kx="0" ky="0" algn="bl" rotWithShape="0" blurRad="114300" dist="38100" dir="8100000">
               <a:srgbClr val="0B3C49">
                 <a:alpha val="12000"/>
               </a:srgbClr>
@@ -13213,7 +13390,7 @@
           <a:bodyPr wrap="square" lIns="0" tIns="0" rIns="0" bIns="0" rtlCol="0" anchor="ctr"/>
           <a:lstStyle/>
           <a:p>
-            <a:pPr marL="0" indent="0">
+            <a:pPr indent="0" marL="0">
               <a:buNone/>
             </a:pPr>
             <a:r>
@@ -13337,7 +13514,7 @@
           <a:bodyPr wrap="square" lIns="0" tIns="0" rIns="0" bIns="0" rtlCol="0" anchor="ctr"/>
           <a:lstStyle/>
           <a:p>
-            <a:pPr marL="0" indent="0" algn="r">
+            <a:pPr algn="r" indent="0" marL="0">
               <a:buNone/>
             </a:pPr>
             <a:r>
@@ -13371,7 +13548,6 @@
         <a:solidFill>
           <a:srgbClr val="F2F7F7"/>
         </a:solidFill>
-        <a:effectLst/>
       </p:bgPr>
     </p:bg>
     <p:spTree>
@@ -13429,11 +13605,11 @@
           <a:bodyPr wrap="square" lIns="0" tIns="0" rIns="0" bIns="0" rtlCol="0" anchor="ctr"/>
           <a:lstStyle/>
           <a:p>
-            <a:pPr marL="0" indent="0">
-              <a:buNone/>
-            </a:pPr>
-            <a:r>
-              <a:rPr lang="en-US" sz="1200" b="1" kern="0" spc="300" dirty="0">
+            <a:pPr indent="0" marL="0">
+              <a:buNone/>
+            </a:pPr>
+            <a:r>
+              <a:rPr lang="en-US" sz="1200" b="1" spc="300" kern="0" dirty="0">
                 <a:solidFill>
                   <a:srgbClr val="028090"/>
                 </a:solidFill>
@@ -13468,7 +13644,7 @@
           <a:bodyPr wrap="square" lIns="0" tIns="0" rIns="0" bIns="0" rtlCol="0" anchor="ctr"/>
           <a:lstStyle/>
           <a:p>
-            <a:pPr marL="0" indent="0">
+            <a:pPr indent="0" marL="0">
               <a:buNone/>
             </a:pPr>
             <a:r>
@@ -13505,7 +13681,7 @@
           </a:solidFill>
           <a:ln/>
           <a:effectLst>
-            <a:outerShdw blurRad="114300" dist="38100" dir="8100000" algn="bl" rotWithShape="0">
+            <a:outerShdw sx="100000" sy="100000" kx="0" ky="0" algn="bl" rotWithShape="0" blurRad="114300" dist="38100" dir="8100000">
               <a:srgbClr val="0B3C49">
                 <a:alpha val="12000"/>
               </a:srgbClr>
@@ -13534,7 +13710,7 @@
           <a:bodyPr wrap="square" lIns="0" tIns="0" rIns="0" bIns="0" rtlCol="0" anchor="ctr"/>
           <a:lstStyle/>
           <a:p>
-            <a:pPr marL="0" indent="0">
+            <a:pPr indent="0" marL="0">
               <a:buNone/>
             </a:pPr>
             <a:r>
@@ -13573,7 +13749,7 @@
           <a:bodyPr wrap="square" lIns="0" tIns="0" rIns="0" bIns="0" rtlCol="0" anchor="t"/>
           <a:lstStyle/>
           <a:p>
-            <a:pPr marL="0" indent="0">
+            <a:pPr indent="0" marL="0">
               <a:buNone/>
             </a:pPr>
             <a:r>
@@ -13590,7 +13766,7 @@
             <a:endParaRPr lang="en-US" sz="1350" dirty="0"/>
           </a:p>
           <a:p>
-            <a:pPr marL="0" indent="0">
+            <a:pPr indent="0" marL="0">
               <a:spcAft>
                 <a:spcPts val="1000"/>
               </a:spcAft>
@@ -13610,7 +13786,7 @@
             <a:endParaRPr lang="en-US" sz="1350" dirty="0"/>
           </a:p>
           <a:p>
-            <a:pPr marL="0" indent="0">
+            <a:pPr indent="0" marL="0">
               <a:buNone/>
             </a:pPr>
             <a:r>
@@ -13627,7 +13803,7 @@
             <a:endParaRPr lang="en-US" sz="1350" dirty="0"/>
           </a:p>
           <a:p>
-            <a:pPr marL="0" indent="0">
+            <a:pPr indent="0" marL="0">
               <a:buNone/>
             </a:pPr>
             <a:r>
@@ -13644,7 +13820,7 @@
             <a:endParaRPr lang="en-US" sz="1350" dirty="0"/>
           </a:p>
           <a:p>
-            <a:pPr marL="0" indent="0">
+            <a:pPr indent="0" marL="0">
               <a:spcAft>
                 <a:spcPts val="1000"/>
               </a:spcAft>
@@ -13664,7 +13840,7 @@
             <a:endParaRPr lang="en-US" sz="1350" dirty="0"/>
           </a:p>
           <a:p>
-            <a:pPr marL="0" indent="0">
+            <a:pPr indent="0" marL="0">
               <a:buNone/>
             </a:pPr>
             <a:r>
@@ -13681,7 +13857,7 @@
             <a:endParaRPr lang="en-US" sz="1350" dirty="0"/>
           </a:p>
           <a:p>
-            <a:pPr marL="0" indent="0">
+            <a:pPr indent="0" marL="0">
               <a:buNone/>
             </a:pPr>
             <a:r>
@@ -13720,7 +13896,7 @@
           <a:bodyPr wrap="square" lIns="0" tIns="0" rIns="0" bIns="0" rtlCol="0" anchor="ctr"/>
           <a:lstStyle/>
           <a:p>
-            <a:pPr marL="0" indent="0">
+            <a:pPr indent="0" marL="0">
               <a:buNone/>
             </a:pPr>
             <a:r>
@@ -13762,7 +13938,7 @@
             <a:prstDash val="solid"/>
           </a:ln>
           <a:effectLst>
-            <a:outerShdw blurRad="114300" dist="38100" dir="8100000" algn="bl" rotWithShape="0">
+            <a:outerShdw sx="100000" sy="100000" kx="0" ky="0" algn="bl" rotWithShape="0" blurRad="114300" dist="38100" dir="8100000">
               <a:srgbClr val="0B3C49">
                 <a:alpha val="12000"/>
               </a:srgbClr>
@@ -13811,7 +13987,7 @@
           <a:bodyPr wrap="square" lIns="0" tIns="0" rIns="0" bIns="0" rtlCol="0" anchor="ctr"/>
           <a:lstStyle/>
           <a:p>
-            <a:pPr marL="0" indent="0">
+            <a:pPr indent="0" marL="0">
               <a:buNone/>
             </a:pPr>
             <a:r>
@@ -13850,7 +14026,7 @@
           <a:bodyPr wrap="square" lIns="0" tIns="0" rIns="0" bIns="0" rtlCol="0" anchor="t"/>
           <a:lstStyle/>
           <a:p>
-            <a:pPr marL="0" indent="0">
+            <a:pPr indent="0" marL="0">
               <a:buNone/>
             </a:pPr>
             <a:r>
@@ -13892,7 +14068,7 @@
             <a:prstDash val="solid"/>
           </a:ln>
           <a:effectLst>
-            <a:outerShdw blurRad="114300" dist="38100" dir="8100000" algn="bl" rotWithShape="0">
+            <a:outerShdw sx="100000" sy="100000" kx="0" ky="0" algn="bl" rotWithShape="0" blurRad="114300" dist="38100" dir="8100000">
               <a:srgbClr val="0B3C49">
                 <a:alpha val="12000"/>
               </a:srgbClr>
@@ -13941,7 +14117,7 @@
           <a:bodyPr wrap="square" lIns="0" tIns="0" rIns="0" bIns="0" rtlCol="0" anchor="ctr"/>
           <a:lstStyle/>
           <a:p>
-            <a:pPr marL="0" indent="0">
+            <a:pPr indent="0" marL="0">
               <a:buNone/>
             </a:pPr>
             <a:r>
@@ -13980,7 +14156,7 @@
           <a:bodyPr wrap="square" lIns="0" tIns="0" rIns="0" bIns="0" rtlCol="0" anchor="t"/>
           <a:lstStyle/>
           <a:p>
-            <a:pPr marL="0" indent="0">
+            <a:pPr indent="0" marL="0">
               <a:buNone/>
             </a:pPr>
             <a:r>
@@ -14022,7 +14198,7 @@
             <a:prstDash val="solid"/>
           </a:ln>
           <a:effectLst>
-            <a:outerShdw blurRad="114300" dist="38100" dir="8100000" algn="bl" rotWithShape="0">
+            <a:outerShdw sx="100000" sy="100000" kx="0" ky="0" algn="bl" rotWithShape="0" blurRad="114300" dist="38100" dir="8100000">
               <a:srgbClr val="0B3C49">
                 <a:alpha val="12000"/>
               </a:srgbClr>
@@ -14071,7 +14247,7 @@
           <a:bodyPr wrap="square" lIns="0" tIns="0" rIns="0" bIns="0" rtlCol="0" anchor="ctr"/>
           <a:lstStyle/>
           <a:p>
-            <a:pPr marL="0" indent="0">
+            <a:pPr indent="0" marL="0">
               <a:buNone/>
             </a:pPr>
             <a:r>
@@ -14110,7 +14286,7 @@
           <a:bodyPr wrap="square" lIns="0" tIns="0" rIns="0" bIns="0" rtlCol="0" anchor="t"/>
           <a:lstStyle/>
           <a:p>
-            <a:pPr marL="0" indent="0">
+            <a:pPr indent="0" marL="0">
               <a:buNone/>
             </a:pPr>
             <a:r>
@@ -14152,7 +14328,7 @@
             <a:prstDash val="solid"/>
           </a:ln>
           <a:effectLst>
-            <a:outerShdw blurRad="114300" dist="38100" dir="8100000" algn="bl" rotWithShape="0">
+            <a:outerShdw sx="100000" sy="100000" kx="0" ky="0" algn="bl" rotWithShape="0" blurRad="114300" dist="38100" dir="8100000">
               <a:srgbClr val="0B3C49">
                 <a:alpha val="12000"/>
               </a:srgbClr>
@@ -14201,7 +14377,7 @@
           <a:bodyPr wrap="square" lIns="0" tIns="0" rIns="0" bIns="0" rtlCol="0" anchor="ctr"/>
           <a:lstStyle/>
           <a:p>
-            <a:pPr marL="0" indent="0">
+            <a:pPr indent="0" marL="0">
               <a:buNone/>
             </a:pPr>
             <a:r>
@@ -14240,7 +14416,7 @@
           <a:bodyPr wrap="square" lIns="0" tIns="0" rIns="0" bIns="0" rtlCol="0" anchor="t"/>
           <a:lstStyle/>
           <a:p>
-            <a:pPr marL="0" indent="0">
+            <a:pPr indent="0" marL="0">
               <a:buNone/>
             </a:pPr>
             <a:r>
@@ -14282,7 +14458,7 @@
             <a:prstDash val="solid"/>
           </a:ln>
           <a:effectLst>
-            <a:outerShdw blurRad="114300" dist="38100" dir="8100000" algn="bl" rotWithShape="0">
+            <a:outerShdw sx="100000" sy="100000" kx="0" ky="0" algn="bl" rotWithShape="0" blurRad="114300" dist="38100" dir="8100000">
               <a:srgbClr val="0B3C49">
                 <a:alpha val="12000"/>
               </a:srgbClr>
@@ -14331,7 +14507,7 @@
           <a:bodyPr wrap="square" lIns="0" tIns="0" rIns="0" bIns="0" rtlCol="0" anchor="ctr"/>
           <a:lstStyle/>
           <a:p>
-            <a:pPr marL="0" indent="0">
+            <a:pPr indent="0" marL="0">
               <a:buNone/>
             </a:pPr>
             <a:r>
@@ -14370,7 +14546,7 @@
           <a:bodyPr wrap="square" lIns="0" tIns="0" rIns="0" bIns="0" rtlCol="0" anchor="t"/>
           <a:lstStyle/>
           <a:p>
-            <a:pPr marL="0" indent="0">
+            <a:pPr indent="0" marL="0">
               <a:buNone/>
             </a:pPr>
             <a:r>
@@ -14412,7 +14588,7 @@
             <a:prstDash val="solid"/>
           </a:ln>
           <a:effectLst>
-            <a:outerShdw blurRad="114300" dist="38100" dir="8100000" algn="bl" rotWithShape="0">
+            <a:outerShdw sx="100000" sy="100000" kx="0" ky="0" algn="bl" rotWithShape="0" blurRad="114300" dist="38100" dir="8100000">
               <a:srgbClr val="0B3C49">
                 <a:alpha val="12000"/>
               </a:srgbClr>
@@ -14461,7 +14637,7 @@
           <a:bodyPr wrap="square" lIns="0" tIns="0" rIns="0" bIns="0" rtlCol="0" anchor="ctr"/>
           <a:lstStyle/>
           <a:p>
-            <a:pPr marL="0" indent="0">
+            <a:pPr indent="0" marL="0">
               <a:buNone/>
             </a:pPr>
             <a:r>
@@ -14500,7 +14676,7 @@
           <a:bodyPr wrap="square" lIns="0" tIns="0" rIns="0" bIns="0" rtlCol="0" anchor="t"/>
           <a:lstStyle/>
           <a:p>
-            <a:pPr marL="0" indent="0">
+            <a:pPr indent="0" marL="0">
               <a:buNone/>
             </a:pPr>
             <a:r>
@@ -14539,7 +14715,7 @@
           <a:bodyPr wrap="square" lIns="0" tIns="0" rIns="0" bIns="0" rtlCol="0" anchor="ctr"/>
           <a:lstStyle/>
           <a:p>
-            <a:pPr marL="0" indent="0" algn="r">
+            <a:pPr algn="r" indent="0" marL="0">
               <a:buNone/>
             </a:pPr>
             <a:r>
@@ -14858,319 +15034,4 @@
     </a:ext>
   </a:extLst>
 </a:theme>
-</file>
-
-<file path=ppt/theme/theme2.xml><?xml version="1.0" encoding="utf-8"?>
-<a:theme xmlns:a="http://schemas.openxmlformats.org/drawingml/2006/main" name="Office 主题​​">
-  <a:themeElements>
-    <a:clrScheme name="Office">
-      <a:dk1>
-        <a:sysClr val="windowText" lastClr="000000"/>
-      </a:dk1>
-      <a:lt1>
-        <a:sysClr val="window" lastClr="FFFFFF"/>
-      </a:lt1>
-      <a:dk2>
-        <a:srgbClr val="0E2841"/>
-      </a:dk2>
-      <a:lt2>
-        <a:srgbClr val="E8E8E8"/>
-      </a:lt2>
-      <a:accent1>
-        <a:srgbClr val="156082"/>
-      </a:accent1>
-      <a:accent2>
-        <a:srgbClr val="E97132"/>
-      </a:accent2>
-      <a:accent3>
-        <a:srgbClr val="196B24"/>
-      </a:accent3>
-      <a:accent4>
-        <a:srgbClr val="0F9ED5"/>
-      </a:accent4>
-      <a:accent5>
-        <a:srgbClr val="A02B93"/>
-      </a:accent5>
-      <a:accent6>
-        <a:srgbClr val="4EA72E"/>
-      </a:accent6>
-      <a:hlink>
-        <a:srgbClr val="467886"/>
-      </a:hlink>
-      <a:folHlink>
-        <a:srgbClr val="96607D"/>
-      </a:folHlink>
-    </a:clrScheme>
-    <a:fontScheme name="Office">
-      <a:majorFont>
-        <a:latin typeface="等线 Light" panose="02110004020202020204"/>
-        <a:ea typeface=""/>
-        <a:cs typeface=""/>
-        <a:font script="Jpan" typeface="游ゴシック Light"/>
-        <a:font script="Hang" typeface="맑은 고딕"/>
-        <a:font script="Hans" typeface="等线 Light"/>
-        <a:font script="Hant" typeface="新細明體"/>
-        <a:font script="Arab" typeface="Times New Roman"/>
-        <a:font script="Hebr" typeface="Times New Roman"/>
-        <a:font script="Thai" typeface="Angsana New"/>
-        <a:font script="Ethi" typeface="Nyala"/>
-        <a:font script="Beng" typeface="Vrinda"/>
-        <a:font script="Gujr" typeface="Shruti"/>
-        <a:font script="Khmr" typeface="MoolBoran"/>
-        <a:font script="Knda" typeface="Tunga"/>
-        <a:font script="Guru" typeface="Raavi"/>
-        <a:font script="Cans" typeface="Euphemia"/>
-        <a:font script="Cher" typeface="Plantagenet Cherokee"/>
-        <a:font script="Yiii" typeface="Microsoft Yi Baiti"/>
-        <a:font script="Tibt" typeface="Microsoft Himalaya"/>
-        <a:font script="Thaa" typeface="MV Boli"/>
-        <a:font script="Deva" typeface="Mangal"/>
-        <a:font script="Telu" typeface="Gautami"/>
-        <a:font script="Taml" typeface="Latha"/>
-        <a:font script="Syrc" typeface="Estrangelo Edessa"/>
-        <a:font script="Orya" typeface="Kalinga"/>
-        <a:font script="Mlym" typeface="Kartika"/>
-        <a:font script="Laoo" typeface="DokChampa"/>
-        <a:font script="Sinh" typeface="Iskoola Pota"/>
-        <a:font script="Mong" typeface="Mongolian Baiti"/>
-        <a:font script="Viet" typeface="Times New Roman"/>
-        <a:font script="Uigh" typeface="Microsoft Uighur"/>
-        <a:font script="Geor" typeface="Sylfaen"/>
-        <a:font script="Armn" typeface="Arial"/>
-        <a:font script="Bugi" typeface="Leelawadee UI"/>
-        <a:font script="Bopo" typeface="Microsoft JhengHei"/>
-        <a:font script="Java" typeface="Javanese Text"/>
-        <a:font script="Lisu" typeface="Segoe UI"/>
-        <a:font script="Mymr" typeface="Myanmar Text"/>
-        <a:font script="Nkoo" typeface="Ebrima"/>
-        <a:font script="Olck" typeface="Nirmala UI"/>
-        <a:font script="Osma" typeface="Ebrima"/>
-        <a:font script="Phag" typeface="Phagspa"/>
-        <a:font script="Syrn" typeface="Estrangelo Edessa"/>
-        <a:font script="Syrj" typeface="Estrangelo Edessa"/>
-        <a:font script="Syre" typeface="Estrangelo Edessa"/>
-        <a:font script="Sora" typeface="Nirmala UI"/>
-        <a:font script="Tale" typeface="Microsoft Tai Le"/>
-        <a:font script="Talu" typeface="Microsoft New Tai Lue"/>
-        <a:font script="Tfng" typeface="Ebrima"/>
-      </a:majorFont>
-      <a:minorFont>
-        <a:latin typeface="等线" panose="02110004020202020204"/>
-        <a:ea typeface=""/>
-        <a:cs typeface=""/>
-        <a:font script="Jpan" typeface="游ゴシック"/>
-        <a:font script="Hang" typeface="맑은 고딕"/>
-        <a:font script="Hans" typeface="等线"/>
-        <a:font script="Hant" typeface="新細明體"/>
-        <a:font script="Arab" typeface="Arial"/>
-        <a:font script="Hebr" typeface="Arial"/>
-        <a:font script="Thai" typeface="Cordia New"/>
-        <a:font script="Ethi" typeface="Nyala"/>
-        <a:font script="Beng" typeface="Vrinda"/>
-        <a:font script="Gujr" typeface="Shruti"/>
-        <a:font script="Khmr" typeface="DaunPenh"/>
-        <a:font script="Knda" typeface="Tunga"/>
-        <a:font script="Guru" typeface="Raavi"/>
-        <a:font script="Cans" typeface="Euphemia"/>
-        <a:font script="Cher" typeface="Plantagenet Cherokee"/>
-        <a:font script="Yiii" typeface="Microsoft Yi Baiti"/>
-        <a:font script="Tibt" typeface="Microsoft Himalaya"/>
-        <a:font script="Thaa" typeface="MV Boli"/>
-        <a:font script="Deva" typeface="Mangal"/>
-        <a:font script="Telu" typeface="Gautami"/>
-        <a:font script="Taml" typeface="Latha"/>
-        <a:font script="Syrc" typeface="Estrangelo Edessa"/>
-        <a:font script="Orya" typeface="Kalinga"/>
-        <a:font script="Mlym" typeface="Kartika"/>
-        <a:font script="Laoo" typeface="DokChampa"/>
-        <a:font script="Sinh" typeface="Iskoola Pota"/>
-        <a:font script="Mong" typeface="Mongolian Baiti"/>
-        <a:font script="Viet" typeface="Arial"/>
-        <a:font script="Uigh" typeface="Microsoft Uighur"/>
-        <a:font script="Geor" typeface="Sylfaen"/>
-        <a:font script="Armn" typeface="Arial"/>
-        <a:font script="Bugi" typeface="Leelawadee UI"/>
-        <a:font script="Bopo" typeface="Microsoft JhengHei"/>
-        <a:font script="Java" typeface="Javanese Text"/>
-        <a:font script="Lisu" typeface="Segoe UI"/>
-        <a:font script="Mymr" typeface="Myanmar Text"/>
-        <a:font script="Nkoo" typeface="Ebrima"/>
-        <a:font script="Olck" typeface="Nirmala UI"/>
-        <a:font script="Osma" typeface="Ebrima"/>
-        <a:font script="Phag" typeface="Phagspa"/>
-        <a:font script="Syrn" typeface="Estrangelo Edessa"/>
-        <a:font script="Syrj" typeface="Estrangelo Edessa"/>
-        <a:font script="Syre" typeface="Estrangelo Edessa"/>
-        <a:font script="Sora" typeface="Nirmala UI"/>
-        <a:font script="Tale" typeface="Microsoft Tai Le"/>
-        <a:font script="Talu" typeface="Microsoft New Tai Lue"/>
-        <a:font script="Tfng" typeface="Ebrima"/>
-      </a:minorFont>
-    </a:fontScheme>
-    <a:fmtScheme name="Office">
-      <a:fillStyleLst>
-        <a:solidFill>
-          <a:schemeClr val="phClr"/>
-        </a:solidFill>
-        <a:gradFill rotWithShape="1">
-          <a:gsLst>
-            <a:gs pos="0">
-              <a:schemeClr val="phClr">
-                <a:lumMod val="110000"/>
-                <a:satMod val="105000"/>
-                <a:tint val="67000"/>
-              </a:schemeClr>
-            </a:gs>
-            <a:gs pos="50000">
-              <a:schemeClr val="phClr">
-                <a:lumMod val="105000"/>
-                <a:satMod val="103000"/>
-                <a:tint val="73000"/>
-              </a:schemeClr>
-            </a:gs>
-            <a:gs pos="100000">
-              <a:schemeClr val="phClr">
-                <a:lumMod val="105000"/>
-                <a:satMod val="109000"/>
-                <a:tint val="81000"/>
-              </a:schemeClr>
-            </a:gs>
-          </a:gsLst>
-          <a:lin ang="5400000" scaled="0"/>
-        </a:gradFill>
-        <a:gradFill rotWithShape="1">
-          <a:gsLst>
-            <a:gs pos="0">
-              <a:schemeClr val="phClr">
-                <a:satMod val="103000"/>
-                <a:lumMod val="102000"/>
-                <a:tint val="94000"/>
-              </a:schemeClr>
-            </a:gs>
-            <a:gs pos="50000">
-              <a:schemeClr val="phClr">
-                <a:satMod val="110000"/>
-                <a:lumMod val="100000"/>
-                <a:shade val="100000"/>
-              </a:schemeClr>
-            </a:gs>
-            <a:gs pos="100000">
-              <a:schemeClr val="phClr">
-                <a:lumMod val="99000"/>
-                <a:satMod val="120000"/>
-                <a:shade val="78000"/>
-              </a:schemeClr>
-            </a:gs>
-          </a:gsLst>
-          <a:lin ang="5400000" scaled="0"/>
-        </a:gradFill>
-      </a:fillStyleLst>
-      <a:lnStyleLst>
-        <a:ln w="12700" cap="flat" cmpd="sng" algn="ctr">
-          <a:solidFill>
-            <a:schemeClr val="phClr"/>
-          </a:solidFill>
-          <a:prstDash val="solid"/>
-          <a:miter lim="800000"/>
-        </a:ln>
-        <a:ln w="19050" cap="flat" cmpd="sng" algn="ctr">
-          <a:solidFill>
-            <a:schemeClr val="phClr"/>
-          </a:solidFill>
-          <a:prstDash val="solid"/>
-          <a:miter lim="800000"/>
-        </a:ln>
-        <a:ln w="25400" cap="flat" cmpd="sng" algn="ctr">
-          <a:solidFill>
-            <a:schemeClr val="phClr"/>
-          </a:solidFill>
-          <a:prstDash val="solid"/>
-          <a:miter lim="800000"/>
-        </a:ln>
-      </a:lnStyleLst>
-      <a:effectStyleLst>
-        <a:effectStyle>
-          <a:effectLst/>
-        </a:effectStyle>
-        <a:effectStyle>
-          <a:effectLst/>
-        </a:effectStyle>
-        <a:effectStyle>
-          <a:effectLst>
-            <a:outerShdw blurRad="57150" dist="19050" dir="5400000" algn="ctr" rotWithShape="0">
-              <a:srgbClr val="000000">
-                <a:alpha val="63000"/>
-              </a:srgbClr>
-            </a:outerShdw>
-          </a:effectLst>
-        </a:effectStyle>
-      </a:effectStyleLst>
-      <a:bgFillStyleLst>
-        <a:solidFill>
-          <a:schemeClr val="phClr"/>
-        </a:solidFill>
-        <a:solidFill>
-          <a:schemeClr val="phClr">
-            <a:tint val="95000"/>
-            <a:satMod val="170000"/>
-          </a:schemeClr>
-        </a:solidFill>
-        <a:gradFill rotWithShape="1">
-          <a:gsLst>
-            <a:gs pos="0">
-              <a:schemeClr val="phClr">
-                <a:tint val="93000"/>
-                <a:satMod val="150000"/>
-                <a:shade val="98000"/>
-                <a:lumMod val="102000"/>
-              </a:schemeClr>
-            </a:gs>
-            <a:gs pos="50000">
-              <a:schemeClr val="phClr">
-                <a:tint val="98000"/>
-                <a:satMod val="130000"/>
-                <a:shade val="90000"/>
-                <a:lumMod val="103000"/>
-              </a:schemeClr>
-            </a:gs>
-            <a:gs pos="100000">
-              <a:schemeClr val="phClr">
-                <a:shade val="63000"/>
-                <a:satMod val="120000"/>
-              </a:schemeClr>
-            </a:gs>
-          </a:gsLst>
-          <a:lin ang="5400000" scaled="0"/>
-        </a:gradFill>
-      </a:bgFillStyleLst>
-    </a:fmtScheme>
-  </a:themeElements>
-  <a:objectDefaults>
-    <a:lnDef>
-      <a:spPr/>
-      <a:bodyPr/>
-      <a:lstStyle/>
-      <a:style>
-        <a:lnRef idx="2">
-          <a:schemeClr val="accent1"/>
-        </a:lnRef>
-        <a:fillRef idx="0">
-          <a:schemeClr val="accent1"/>
-        </a:fillRef>
-        <a:effectRef idx="1">
-          <a:schemeClr val="accent1"/>
-        </a:effectRef>
-        <a:fontRef idx="minor">
-          <a:schemeClr val="tx1"/>
-        </a:fontRef>
-      </a:style>
-    </a:lnDef>
-  </a:objectDefaults>
-  <a:extraClrSchemeLst/>
-  <a:extLst>
-    <a:ext uri="{05A4C25C-085E-4340-85A3-A5531E510DB2}">
-      <thm15:themeFamily xmlns:thm15="http://schemas.microsoft.com/office/thememl/2012/main" name="Office Theme" id="{2E142A2C-CD16-42D6-873A-C26D2A0506FA}" vid="{1BDDFF52-6CD6-40A5-AB3C-68EB2F1E4D0A}"/>
-    </a:ext>
-  </a:extLst>
-</a:theme>
 </file>
</xml_diff>